<commit_message>
Publish once-only frozen synthetic evaluation and evidence (B1)
</commit_message>
<xml_diff>
--- a/deliverables/CycleTwin_architecture.pptx
+++ b/deliverables/CycleTwin_architecture.pptx
@@ -2,13 +2,13 @@
 <file path=ppt/presentation.xml><?xml version="1.0" encoding="utf-8"?>
 <p:presentation xmlns:p="http://schemas.openxmlformats.org/presentationml/2006/main">
   <p:sldMasterIdLst>
-    <p:sldMasterId xmlns:r="http://schemas.openxmlformats.org/officeDocument/2006/relationships" id="2147483648" r:id="Ra979495123c4472c"/>
+    <p:sldMasterId xmlns:r="http://schemas.openxmlformats.org/officeDocument/2006/relationships" id="2147483648" r:id="Re676d8fbc3fa473a"/>
   </p:sldMasterIdLst>
   <p:notesMasterIdLst>
-    <p:notesMasterId xmlns:r="http://schemas.openxmlformats.org/officeDocument/2006/relationships" r:id="Ra51ccb19fe45464c"/>
+    <p:notesMasterId xmlns:r="http://schemas.openxmlformats.org/officeDocument/2006/relationships" r:id="R15b7b5e7977b4025"/>
   </p:notesMasterIdLst>
   <p:sldIdLst>
-    <p:sldId xmlns:r="http://schemas.openxmlformats.org/officeDocument/2006/relationships" id="256" r:id="R3c326f0e8fc742aa"/>
+    <p:sldId xmlns:r="http://schemas.openxmlformats.org/officeDocument/2006/relationships" id="256" r:id="R5a7981f672be4a29"/>
   </p:sldIdLst>
   <p:sldSz cx="12192000" cy="6858000"/>
   <p:notesSz cx="6858000" cy="9144000"/>
@@ -489,7 +489,7 @@
           <p:cNvPr id="3" name="Title">
             <a:extLst xmlns:a="http://schemas.openxmlformats.org/drawingml/2006/main">
               <a:ext uri="{FF2B5EF4-FFF2-40B4-BE49-F238E27FC236}">
-                <a16:creationId xmlns:a16="http://schemas.microsoft.com/office/drawing/2014/main" id="{50349723-4642-4C1A-A78B-D2892074A1A6}"/>
+                <a16:creationId xmlns:a16="http://schemas.microsoft.com/office/drawing/2014/main" id="{017CC5AD-D4B8-4EA7-860B-CC013B7B2F28}"/>
               </a:ext>
             </a:extLst>
           </p:cNvPr>
@@ -718,7 +718,7 @@
           <p:cNvPr id="2" name="Subtitle">
             <a:extLst xmlns:a="http://schemas.openxmlformats.org/drawingml/2006/main">
               <a:ext uri="{FF2B5EF4-FFF2-40B4-BE49-F238E27FC236}">
-                <a16:creationId xmlns:a16="http://schemas.microsoft.com/office/drawing/2014/main" id="{C0B4F3B2-10FF-443F-A442-8BC5246220C4}"/>
+                <a16:creationId xmlns:a16="http://schemas.microsoft.com/office/drawing/2014/main" id="{2A94C464-1EF8-44A4-9CE5-D863DA18AB77}"/>
               </a:ext>
             </a:extLst>
           </p:cNvPr>
@@ -964,7 +964,7 @@
           <p:cNvPr id="2" name="Section title">
             <a:extLst xmlns:a="http://schemas.openxmlformats.org/drawingml/2006/main">
               <a:ext uri="{FF2B5EF4-FFF2-40B4-BE49-F238E27FC236}">
-                <a16:creationId xmlns:a16="http://schemas.microsoft.com/office/drawing/2014/main" id="{AD4C71D5-961A-48DA-92C8-E4AE73E9BEBA}"/>
+                <a16:creationId xmlns:a16="http://schemas.microsoft.com/office/drawing/2014/main" id="{41F83FDC-C5B6-4274-9DCC-2F1B2FB5E18B}"/>
               </a:ext>
             </a:extLst>
           </p:cNvPr>
@@ -1210,7 +1210,7 @@
           <p:cNvPr id="3" name="Title">
             <a:extLst xmlns:a="http://schemas.openxmlformats.org/drawingml/2006/main">
               <a:ext uri="{FF2B5EF4-FFF2-40B4-BE49-F238E27FC236}">
-                <a16:creationId xmlns:a16="http://schemas.microsoft.com/office/drawing/2014/main" id="{1C3DD3CA-DBFA-40BB-914F-3CBE54E02A8A}"/>
+                <a16:creationId xmlns:a16="http://schemas.microsoft.com/office/drawing/2014/main" id="{960F2A9A-0990-439C-BF3C-8CE711F5C120}"/>
               </a:ext>
             </a:extLst>
           </p:cNvPr>
@@ -1439,7 +1439,7 @@
           <p:cNvPr id="2" name="Body">
             <a:extLst xmlns:a="http://schemas.openxmlformats.org/drawingml/2006/main">
               <a:ext uri="{FF2B5EF4-FFF2-40B4-BE49-F238E27FC236}">
-                <a16:creationId xmlns:a16="http://schemas.microsoft.com/office/drawing/2014/main" id="{5E765510-B36E-45E1-91F9-57DDA6FFD9BA}"/>
+                <a16:creationId xmlns:a16="http://schemas.microsoft.com/office/drawing/2014/main" id="{996128FC-0645-44D2-A22F-5AD34A0C1325}"/>
               </a:ext>
             </a:extLst>
           </p:cNvPr>
@@ -1685,7 +1685,7 @@
           <p:cNvPr id="4" name="Title">
             <a:extLst xmlns:a="http://schemas.openxmlformats.org/drawingml/2006/main">
               <a:ext uri="{FF2B5EF4-FFF2-40B4-BE49-F238E27FC236}">
-                <a16:creationId xmlns:a16="http://schemas.microsoft.com/office/drawing/2014/main" id="{2B0B3768-32EF-4458-8DCB-CD4A0343AC53}"/>
+                <a16:creationId xmlns:a16="http://schemas.microsoft.com/office/drawing/2014/main" id="{0FA166B3-1D9E-4D65-8A4B-F53779D61B6E}"/>
               </a:ext>
             </a:extLst>
           </p:cNvPr>
@@ -1914,7 +1914,7 @@
           <p:cNvPr id="2" name="Left column">
             <a:extLst xmlns:a="http://schemas.openxmlformats.org/drawingml/2006/main">
               <a:ext uri="{FF2B5EF4-FFF2-40B4-BE49-F238E27FC236}">
-                <a16:creationId xmlns:a16="http://schemas.microsoft.com/office/drawing/2014/main" id="{54264238-5150-48B9-A747-75CE43FA461D}"/>
+                <a16:creationId xmlns:a16="http://schemas.microsoft.com/office/drawing/2014/main" id="{0B5AC067-1949-420B-BDDA-D8450903E690}"/>
               </a:ext>
             </a:extLst>
           </p:cNvPr>
@@ -2143,7 +2143,7 @@
           <p:cNvPr id="3" name="Right column">
             <a:extLst xmlns:a="http://schemas.openxmlformats.org/drawingml/2006/main">
               <a:ext uri="{FF2B5EF4-FFF2-40B4-BE49-F238E27FC236}">
-                <a16:creationId xmlns:a16="http://schemas.microsoft.com/office/drawing/2014/main" id="{25E90554-5EF9-48D9-A921-B09FDA797903}"/>
+                <a16:creationId xmlns:a16="http://schemas.microsoft.com/office/drawing/2014/main" id="{8DA655C1-EDF6-49AA-AAA2-A981806857A8}"/>
               </a:ext>
             </a:extLst>
           </p:cNvPr>
@@ -2389,7 +2389,7 @@
           <p:cNvPr id="3" name="Title">
             <a:extLst xmlns:a="http://schemas.openxmlformats.org/drawingml/2006/main">
               <a:ext uri="{FF2B5EF4-FFF2-40B4-BE49-F238E27FC236}">
-                <a16:creationId xmlns:a16="http://schemas.microsoft.com/office/drawing/2014/main" id="{45DF5465-37B0-443E-BCB4-DA29313FF8EF}"/>
+                <a16:creationId xmlns:a16="http://schemas.microsoft.com/office/drawing/2014/main" id="{E8C638B2-C8FD-45C0-83CF-331E6A4B0E8F}"/>
               </a:ext>
             </a:extLst>
           </p:cNvPr>
@@ -2618,7 +2618,7 @@
           <p:cNvPr id="2" name="Left column">
             <a:extLst xmlns:a="http://schemas.openxmlformats.org/drawingml/2006/main">
               <a:ext uri="{FF2B5EF4-FFF2-40B4-BE49-F238E27FC236}">
-                <a16:creationId xmlns:a16="http://schemas.microsoft.com/office/drawing/2014/main" id="{C2E51547-3363-4892-B069-03A8695549A3}"/>
+                <a16:creationId xmlns:a16="http://schemas.microsoft.com/office/drawing/2014/main" id="{F1EA813B-7B1A-4EF1-89F5-10E0D58A2B99}"/>
               </a:ext>
             </a:extLst>
           </p:cNvPr>
@@ -2885,12 +2885,12 @@
   </p:cSld>
   <p:clrMap bg1="lt1" tx1="dk1" bg2="lt2" tx2="dk2" accent1="accent1" accent2="accent2" accent3="accent3" accent4="accent4" accent5="accent5" accent6="accent6" hlink="hlink" folHlink="folHlink"/>
   <p:sldLayoutIdLst>
-    <p:sldLayoutId xmlns:r="http://schemas.openxmlformats.org/officeDocument/2006/relationships" id="2147483649" r:id="R28cfecd67f6c42e0"/>
-    <p:sldLayoutId xmlns:r="http://schemas.openxmlformats.org/officeDocument/2006/relationships" id="2147483650" r:id="R21377d687287495c"/>
-    <p:sldLayoutId xmlns:r="http://schemas.openxmlformats.org/officeDocument/2006/relationships" id="2147483651" r:id="R6d553fa352694e5c"/>
-    <p:sldLayoutId xmlns:r="http://schemas.openxmlformats.org/officeDocument/2006/relationships" id="2147483652" r:id="Rb04dfd9935bd427c"/>
-    <p:sldLayoutId xmlns:r="http://schemas.openxmlformats.org/officeDocument/2006/relationships" id="2147483653" r:id="Rdbe7c55a9ff8480f"/>
-    <p:sldLayoutId xmlns:r="http://schemas.openxmlformats.org/officeDocument/2006/relationships" id="2147483654" r:id="Rad6925212a3f45e2"/>
+    <p:sldLayoutId xmlns:r="http://schemas.openxmlformats.org/officeDocument/2006/relationships" id="2147483649" r:id="R8e25dcca194d48a4"/>
+    <p:sldLayoutId xmlns:r="http://schemas.openxmlformats.org/officeDocument/2006/relationships" id="2147483650" r:id="Rae0ec55136e44a30"/>
+    <p:sldLayoutId xmlns:r="http://schemas.openxmlformats.org/officeDocument/2006/relationships" id="2147483651" r:id="Rbff95273bfb24539"/>
+    <p:sldLayoutId xmlns:r="http://schemas.openxmlformats.org/officeDocument/2006/relationships" id="2147483652" r:id="R19516a2878ff46c2"/>
+    <p:sldLayoutId xmlns:r="http://schemas.openxmlformats.org/officeDocument/2006/relationships" id="2147483653" r:id="R49b8ec20675341ab"/>
+    <p:sldLayoutId xmlns:r="http://schemas.openxmlformats.org/officeDocument/2006/relationships" id="2147483654" r:id="R22d268b67d744f50"/>
   </p:sldLayoutIdLst>
   <p:txStyles>
     <p:titleStyle>
@@ -3441,7 +3441,7 @@
           <p:cNvPr id="14" name="">
             <a:extLst xmlns:a="http://schemas.openxmlformats.org/drawingml/2006/main">
               <a:ext uri="{FF2B5EF4-FFF2-40B4-BE49-F238E27FC236}">
-                <a16:creationId xmlns:a16="http://schemas.microsoft.com/office/drawing/2014/main" id="{5858BF58-21C1-4DD9-BFCF-6C61BFAEE9EA}"/>
+                <a16:creationId xmlns:a16="http://schemas.microsoft.com/office/drawing/2014/main" id="{19ECCEE9-E89A-4F1E-8937-16DEFA2BA287}"/>
               </a:ext>
             </a:extLst>
           </p:cNvPr>
@@ -3472,7 +3472,7 @@
           <p:cNvPr id="13" name="">
             <a:extLst xmlns:a="http://schemas.openxmlformats.org/drawingml/2006/main">
               <a:ext uri="{FF2B5EF4-FFF2-40B4-BE49-F238E27FC236}">
-                <a16:creationId xmlns:a16="http://schemas.microsoft.com/office/drawing/2014/main" id="{BADD6E20-BF08-4408-997D-F5950D048A9E}"/>
+                <a16:creationId xmlns:a16="http://schemas.microsoft.com/office/drawing/2014/main" id="{AA11C98F-2344-4F2A-9E9D-207A159DC1CD}"/>
               </a:ext>
             </a:extLst>
           </p:cNvPr>
@@ -3503,7 +3503,7 @@
           <p:cNvPr id="12" name="">
             <a:extLst xmlns:a="http://schemas.openxmlformats.org/drawingml/2006/main">
               <a:ext uri="{FF2B5EF4-FFF2-40B4-BE49-F238E27FC236}">
-                <a16:creationId xmlns:a16="http://schemas.microsoft.com/office/drawing/2014/main" id="{E3A99ED4-2AF8-4DDD-8F1C-2B49CF6F871A}"/>
+                <a16:creationId xmlns:a16="http://schemas.microsoft.com/office/drawing/2014/main" id="{CC4C87A8-8245-4FA5-9643-4D1D91DBDE37}"/>
               </a:ext>
             </a:extLst>
           </p:cNvPr>
@@ -3534,7 +3534,7 @@
           <p:cNvPr id="11" name="">
             <a:extLst xmlns:a="http://schemas.openxmlformats.org/drawingml/2006/main">
               <a:ext uri="{FF2B5EF4-FFF2-40B4-BE49-F238E27FC236}">
-                <a16:creationId xmlns:a16="http://schemas.microsoft.com/office/drawing/2014/main" id="{93FCAA43-D449-4E8D-B02E-71C459BB8428}"/>
+                <a16:creationId xmlns:a16="http://schemas.microsoft.com/office/drawing/2014/main" id="{6707ACA3-64B5-4628-A6C6-E3E15852EF52}"/>
               </a:ext>
             </a:extLst>
           </p:cNvPr>
@@ -3567,7 +3567,7 @@
           <p:cNvPr id="10" name="">
             <a:extLst xmlns:a="http://schemas.openxmlformats.org/drawingml/2006/main">
               <a:ext uri="{FF2B5EF4-FFF2-40B4-BE49-F238E27FC236}">
-                <a16:creationId xmlns:a16="http://schemas.microsoft.com/office/drawing/2014/main" id="{3D9F36B8-4187-459C-A4AF-8CEBFE0A4AC6}"/>
+                <a16:creationId xmlns:a16="http://schemas.microsoft.com/office/drawing/2014/main" id="{99FCB408-5C23-4CD6-B21F-C821475C9180}"/>
               </a:ext>
             </a:extLst>
           </p:cNvPr>
@@ -3600,7 +3600,7 @@
           <p:cNvPr id="16" name="">
             <a:extLst xmlns:a="http://schemas.openxmlformats.org/drawingml/2006/main">
               <a:ext uri="{FF2B5EF4-FFF2-40B4-BE49-F238E27FC236}">
-                <a16:creationId xmlns:a16="http://schemas.microsoft.com/office/drawing/2014/main" id="{B5354A33-66FE-4A9C-85A8-8F26B49BED75}"/>
+                <a16:creationId xmlns:a16="http://schemas.microsoft.com/office/drawing/2014/main" id="{3F90812E-658E-44B0-A483-CAFC86C00DE2}"/>
               </a:ext>
             </a:extLst>
           </p:cNvPr>
@@ -3756,7 +3756,7 @@
           <p:cNvPr id="2" name="">
             <a:extLst xmlns:a="http://schemas.openxmlformats.org/drawingml/2006/main">
               <a:ext uri="{FF2B5EF4-FFF2-40B4-BE49-F238E27FC236}">
-                <a16:creationId xmlns:a16="http://schemas.microsoft.com/office/drawing/2014/main" id="{4373A50B-3AFC-4495-967B-32D03B7E1ACA}"/>
+                <a16:creationId xmlns:a16="http://schemas.microsoft.com/office/drawing/2014/main" id="{EBA7E357-A940-4D73-A7A4-D4970D7B08FC}"/>
               </a:ext>
             </a:extLst>
           </p:cNvPr>
@@ -3912,7 +3912,7 @@
           <p:cNvPr id="3" name="">
             <a:extLst xmlns:a="http://schemas.openxmlformats.org/drawingml/2006/main">
               <a:ext uri="{FF2B5EF4-FFF2-40B4-BE49-F238E27FC236}">
-                <a16:creationId xmlns:a16="http://schemas.microsoft.com/office/drawing/2014/main" id="{7EF00CF5-EEA9-48BB-B209-80561EB4E607}"/>
+                <a16:creationId xmlns:a16="http://schemas.microsoft.com/office/drawing/2014/main" id="{A9F58FA1-8EEA-43E7-A731-D990C2C33EC1}"/>
               </a:ext>
             </a:extLst>
           </p:cNvPr>
@@ -4095,7 +4095,7 @@
           <p:cNvPr id="4" name="">
             <a:extLst xmlns:a="http://schemas.openxmlformats.org/drawingml/2006/main">
               <a:ext uri="{FF2B5EF4-FFF2-40B4-BE49-F238E27FC236}">
-                <a16:creationId xmlns:a16="http://schemas.microsoft.com/office/drawing/2014/main" id="{11505BF8-8576-4D84-AAFC-FA5145733717}"/>
+                <a16:creationId xmlns:a16="http://schemas.microsoft.com/office/drawing/2014/main" id="{B0F31BAC-A14B-4732-93C9-7487FBC35872}"/>
               </a:ext>
             </a:extLst>
           </p:cNvPr>
@@ -4278,7 +4278,7 @@
           <p:cNvPr id="5" name="">
             <a:extLst xmlns:a="http://schemas.openxmlformats.org/drawingml/2006/main">
               <a:ext uri="{FF2B5EF4-FFF2-40B4-BE49-F238E27FC236}">
-                <a16:creationId xmlns:a16="http://schemas.microsoft.com/office/drawing/2014/main" id="{49FD612A-52ED-4C10-AEBA-DD75D4C58354}"/>
+                <a16:creationId xmlns:a16="http://schemas.microsoft.com/office/drawing/2014/main" id="{52B80683-5B42-49AD-ADD7-40547EFEA420}"/>
               </a:ext>
             </a:extLst>
           </p:cNvPr>
@@ -4461,7 +4461,7 @@
           <p:cNvPr id="6" name="">
             <a:extLst xmlns:a="http://schemas.openxmlformats.org/drawingml/2006/main">
               <a:ext uri="{FF2B5EF4-FFF2-40B4-BE49-F238E27FC236}">
-                <a16:creationId xmlns:a16="http://schemas.microsoft.com/office/drawing/2014/main" id="{23A7C883-4605-4219-B9DB-F328BE3F0206}"/>
+                <a16:creationId xmlns:a16="http://schemas.microsoft.com/office/drawing/2014/main" id="{D894D1B0-50A7-448F-AC65-D698385B7178}"/>
               </a:ext>
             </a:extLst>
           </p:cNvPr>
@@ -4644,7 +4644,7 @@
           <p:cNvPr id="7" name="">
             <a:extLst xmlns:a="http://schemas.openxmlformats.org/drawingml/2006/main">
               <a:ext uri="{FF2B5EF4-FFF2-40B4-BE49-F238E27FC236}">
-                <a16:creationId xmlns:a16="http://schemas.microsoft.com/office/drawing/2014/main" id="{B155207A-E094-4C8B-948F-0A10C3C7CCD4}"/>
+                <a16:creationId xmlns:a16="http://schemas.microsoft.com/office/drawing/2014/main" id="{ABFF6480-05DE-4C5D-B411-61BD00A8776E}"/>
               </a:ext>
             </a:extLst>
           </p:cNvPr>
@@ -4827,7 +4827,7 @@
           <p:cNvPr id="8" name="">
             <a:extLst xmlns:a="http://schemas.openxmlformats.org/drawingml/2006/main">
               <a:ext uri="{FF2B5EF4-FFF2-40B4-BE49-F238E27FC236}">
-                <a16:creationId xmlns:a16="http://schemas.microsoft.com/office/drawing/2014/main" id="{0E62407D-302C-4C54-8F17-65C26052F8E5}"/>
+                <a16:creationId xmlns:a16="http://schemas.microsoft.com/office/drawing/2014/main" id="{9A46ADAC-2F86-46F9-989A-90931FA562D1}"/>
               </a:ext>
             </a:extLst>
           </p:cNvPr>
@@ -5010,7 +5010,7 @@
           <p:cNvPr id="9" name="">
             <a:extLst xmlns:a="http://schemas.openxmlformats.org/drawingml/2006/main">
               <a:ext uri="{FF2B5EF4-FFF2-40B4-BE49-F238E27FC236}">
-                <a16:creationId xmlns:a16="http://schemas.microsoft.com/office/drawing/2014/main" id="{B6F44EAD-95D8-4887-B2D7-341319DC4A78}"/>
+                <a16:creationId xmlns:a16="http://schemas.microsoft.com/office/drawing/2014/main" id="{A6071EAA-639F-4CAA-9E57-E1836CFA0463}"/>
               </a:ext>
             </a:extLst>
           </p:cNvPr>
@@ -5193,7 +5193,7 @@
           <p:cNvPr id="15" name="">
             <a:extLst xmlns:a="http://schemas.openxmlformats.org/drawingml/2006/main">
               <a:ext uri="{FF2B5EF4-FFF2-40B4-BE49-F238E27FC236}">
-                <a16:creationId xmlns:a16="http://schemas.microsoft.com/office/drawing/2014/main" id="{177F9238-E9A4-4C19-A56E-27ED04905C51}"/>
+                <a16:creationId xmlns:a16="http://schemas.microsoft.com/office/drawing/2014/main" id="{445F39E8-B5AF-403F-B507-FFF70B63125E}"/>
               </a:ext>
             </a:extLst>
           </p:cNvPr>
@@ -5347,7 +5347,7 @@
     </p:spTree>
     <p:extLst>
       <p:ext uri="{BB962C8B-B14F-4D97-AF65-F5344CB8AC3E}">
-        <p14:creationId xmlns:p14="http://schemas.microsoft.com/office/powerpoint/2010/main" val="2106358557"/>
+        <p14:creationId xmlns:p14="http://schemas.microsoft.com/office/powerpoint/2010/main" val="955596032"/>
       </p:ext>
     </p:extLst>
   </p:cSld>

</xml_diff>

<commit_message>
Add frozen calibration and subgroup reporting (B2)
</commit_message>
<xml_diff>
--- a/deliverables/CycleTwin_architecture.pptx
+++ b/deliverables/CycleTwin_architecture.pptx
@@ -2,13 +2,13 @@
 <file path=ppt/presentation.xml><?xml version="1.0" encoding="utf-8"?>
 <p:presentation xmlns:p="http://schemas.openxmlformats.org/presentationml/2006/main">
   <p:sldMasterIdLst>
-    <p:sldMasterId xmlns:r="http://schemas.openxmlformats.org/officeDocument/2006/relationships" id="2147483648" r:id="Re676d8fbc3fa473a"/>
+    <p:sldMasterId xmlns:r="http://schemas.openxmlformats.org/officeDocument/2006/relationships" id="2147483648" r:id="R148b4c1939d545a2"/>
   </p:sldMasterIdLst>
   <p:notesMasterIdLst>
-    <p:notesMasterId xmlns:r="http://schemas.openxmlformats.org/officeDocument/2006/relationships" r:id="R15b7b5e7977b4025"/>
+    <p:notesMasterId xmlns:r="http://schemas.openxmlformats.org/officeDocument/2006/relationships" r:id="R2007d8a40d2f47f7"/>
   </p:notesMasterIdLst>
   <p:sldIdLst>
-    <p:sldId xmlns:r="http://schemas.openxmlformats.org/officeDocument/2006/relationships" id="256" r:id="R5a7981f672be4a29"/>
+    <p:sldId xmlns:r="http://schemas.openxmlformats.org/officeDocument/2006/relationships" id="256" r:id="Rd453355faea9433c"/>
   </p:sldIdLst>
   <p:sldSz cx="12192000" cy="6858000"/>
   <p:notesSz cx="6858000" cy="9144000"/>
@@ -489,7 +489,7 @@
           <p:cNvPr id="3" name="Title">
             <a:extLst xmlns:a="http://schemas.openxmlformats.org/drawingml/2006/main">
               <a:ext uri="{FF2B5EF4-FFF2-40B4-BE49-F238E27FC236}">
-                <a16:creationId xmlns:a16="http://schemas.microsoft.com/office/drawing/2014/main" id="{017CC5AD-D4B8-4EA7-860B-CC013B7B2F28}"/>
+                <a16:creationId xmlns:a16="http://schemas.microsoft.com/office/drawing/2014/main" id="{8FAAD3D4-34F7-485E-AF4F-28174803567D}"/>
               </a:ext>
             </a:extLst>
           </p:cNvPr>
@@ -718,7 +718,7 @@
           <p:cNvPr id="2" name="Subtitle">
             <a:extLst xmlns:a="http://schemas.openxmlformats.org/drawingml/2006/main">
               <a:ext uri="{FF2B5EF4-FFF2-40B4-BE49-F238E27FC236}">
-                <a16:creationId xmlns:a16="http://schemas.microsoft.com/office/drawing/2014/main" id="{2A94C464-1EF8-44A4-9CE5-D863DA18AB77}"/>
+                <a16:creationId xmlns:a16="http://schemas.microsoft.com/office/drawing/2014/main" id="{A5E97888-7713-4B3B-BBB3-D54CE3E7B530}"/>
               </a:ext>
             </a:extLst>
           </p:cNvPr>
@@ -964,7 +964,7 @@
           <p:cNvPr id="2" name="Section title">
             <a:extLst xmlns:a="http://schemas.openxmlformats.org/drawingml/2006/main">
               <a:ext uri="{FF2B5EF4-FFF2-40B4-BE49-F238E27FC236}">
-                <a16:creationId xmlns:a16="http://schemas.microsoft.com/office/drawing/2014/main" id="{41F83FDC-C5B6-4274-9DCC-2F1B2FB5E18B}"/>
+                <a16:creationId xmlns:a16="http://schemas.microsoft.com/office/drawing/2014/main" id="{B3442719-859F-4E2C-B64E-D3969B5CA04F}"/>
               </a:ext>
             </a:extLst>
           </p:cNvPr>
@@ -1210,7 +1210,7 @@
           <p:cNvPr id="3" name="Title">
             <a:extLst xmlns:a="http://schemas.openxmlformats.org/drawingml/2006/main">
               <a:ext uri="{FF2B5EF4-FFF2-40B4-BE49-F238E27FC236}">
-                <a16:creationId xmlns:a16="http://schemas.microsoft.com/office/drawing/2014/main" id="{960F2A9A-0990-439C-BF3C-8CE711F5C120}"/>
+                <a16:creationId xmlns:a16="http://schemas.microsoft.com/office/drawing/2014/main" id="{3027BB26-5033-4F73-87AC-395AFB8FBE93}"/>
               </a:ext>
             </a:extLst>
           </p:cNvPr>
@@ -1439,7 +1439,7 @@
           <p:cNvPr id="2" name="Body">
             <a:extLst xmlns:a="http://schemas.openxmlformats.org/drawingml/2006/main">
               <a:ext uri="{FF2B5EF4-FFF2-40B4-BE49-F238E27FC236}">
-                <a16:creationId xmlns:a16="http://schemas.microsoft.com/office/drawing/2014/main" id="{996128FC-0645-44D2-A22F-5AD34A0C1325}"/>
+                <a16:creationId xmlns:a16="http://schemas.microsoft.com/office/drawing/2014/main" id="{89AD81BC-538E-4A1B-B12D-C3DD539CB371}"/>
               </a:ext>
             </a:extLst>
           </p:cNvPr>
@@ -1685,7 +1685,7 @@
           <p:cNvPr id="4" name="Title">
             <a:extLst xmlns:a="http://schemas.openxmlformats.org/drawingml/2006/main">
               <a:ext uri="{FF2B5EF4-FFF2-40B4-BE49-F238E27FC236}">
-                <a16:creationId xmlns:a16="http://schemas.microsoft.com/office/drawing/2014/main" id="{0FA166B3-1D9E-4D65-8A4B-F53779D61B6E}"/>
+                <a16:creationId xmlns:a16="http://schemas.microsoft.com/office/drawing/2014/main" id="{5E4D4008-7208-4336-85FC-1274C1AFB14C}"/>
               </a:ext>
             </a:extLst>
           </p:cNvPr>
@@ -1914,7 +1914,7 @@
           <p:cNvPr id="2" name="Left column">
             <a:extLst xmlns:a="http://schemas.openxmlformats.org/drawingml/2006/main">
               <a:ext uri="{FF2B5EF4-FFF2-40B4-BE49-F238E27FC236}">
-                <a16:creationId xmlns:a16="http://schemas.microsoft.com/office/drawing/2014/main" id="{0B5AC067-1949-420B-BDDA-D8450903E690}"/>
+                <a16:creationId xmlns:a16="http://schemas.microsoft.com/office/drawing/2014/main" id="{21601C5E-8F93-4692-85AD-2139B103B499}"/>
               </a:ext>
             </a:extLst>
           </p:cNvPr>
@@ -2143,7 +2143,7 @@
           <p:cNvPr id="3" name="Right column">
             <a:extLst xmlns:a="http://schemas.openxmlformats.org/drawingml/2006/main">
               <a:ext uri="{FF2B5EF4-FFF2-40B4-BE49-F238E27FC236}">
-                <a16:creationId xmlns:a16="http://schemas.microsoft.com/office/drawing/2014/main" id="{8DA655C1-EDF6-49AA-AAA2-A981806857A8}"/>
+                <a16:creationId xmlns:a16="http://schemas.microsoft.com/office/drawing/2014/main" id="{63853C48-52D0-4D02-8926-1FCF20AE014B}"/>
               </a:ext>
             </a:extLst>
           </p:cNvPr>
@@ -2389,7 +2389,7 @@
           <p:cNvPr id="3" name="Title">
             <a:extLst xmlns:a="http://schemas.openxmlformats.org/drawingml/2006/main">
               <a:ext uri="{FF2B5EF4-FFF2-40B4-BE49-F238E27FC236}">
-                <a16:creationId xmlns:a16="http://schemas.microsoft.com/office/drawing/2014/main" id="{E8C638B2-C8FD-45C0-83CF-331E6A4B0E8F}"/>
+                <a16:creationId xmlns:a16="http://schemas.microsoft.com/office/drawing/2014/main" id="{C9ED8934-BB99-4BD0-8368-0282BCFBA300}"/>
               </a:ext>
             </a:extLst>
           </p:cNvPr>
@@ -2618,7 +2618,7 @@
           <p:cNvPr id="2" name="Left column">
             <a:extLst xmlns:a="http://schemas.openxmlformats.org/drawingml/2006/main">
               <a:ext uri="{FF2B5EF4-FFF2-40B4-BE49-F238E27FC236}">
-                <a16:creationId xmlns:a16="http://schemas.microsoft.com/office/drawing/2014/main" id="{F1EA813B-7B1A-4EF1-89F5-10E0D58A2B99}"/>
+                <a16:creationId xmlns:a16="http://schemas.microsoft.com/office/drawing/2014/main" id="{CBC346B1-552C-4ED9-9258-2E46B3A0292C}"/>
               </a:ext>
             </a:extLst>
           </p:cNvPr>
@@ -2885,12 +2885,12 @@
   </p:cSld>
   <p:clrMap bg1="lt1" tx1="dk1" bg2="lt2" tx2="dk2" accent1="accent1" accent2="accent2" accent3="accent3" accent4="accent4" accent5="accent5" accent6="accent6" hlink="hlink" folHlink="folHlink"/>
   <p:sldLayoutIdLst>
-    <p:sldLayoutId xmlns:r="http://schemas.openxmlformats.org/officeDocument/2006/relationships" id="2147483649" r:id="R8e25dcca194d48a4"/>
-    <p:sldLayoutId xmlns:r="http://schemas.openxmlformats.org/officeDocument/2006/relationships" id="2147483650" r:id="Rae0ec55136e44a30"/>
-    <p:sldLayoutId xmlns:r="http://schemas.openxmlformats.org/officeDocument/2006/relationships" id="2147483651" r:id="Rbff95273bfb24539"/>
-    <p:sldLayoutId xmlns:r="http://schemas.openxmlformats.org/officeDocument/2006/relationships" id="2147483652" r:id="R19516a2878ff46c2"/>
-    <p:sldLayoutId xmlns:r="http://schemas.openxmlformats.org/officeDocument/2006/relationships" id="2147483653" r:id="R49b8ec20675341ab"/>
-    <p:sldLayoutId xmlns:r="http://schemas.openxmlformats.org/officeDocument/2006/relationships" id="2147483654" r:id="R22d268b67d744f50"/>
+    <p:sldLayoutId xmlns:r="http://schemas.openxmlformats.org/officeDocument/2006/relationships" id="2147483649" r:id="Rf98fe8c8704b45c6"/>
+    <p:sldLayoutId xmlns:r="http://schemas.openxmlformats.org/officeDocument/2006/relationships" id="2147483650" r:id="Rcb59d11e66214bec"/>
+    <p:sldLayoutId xmlns:r="http://schemas.openxmlformats.org/officeDocument/2006/relationships" id="2147483651" r:id="R0882d86cdb0249bf"/>
+    <p:sldLayoutId xmlns:r="http://schemas.openxmlformats.org/officeDocument/2006/relationships" id="2147483652" r:id="Rd89a6855be9e4481"/>
+    <p:sldLayoutId xmlns:r="http://schemas.openxmlformats.org/officeDocument/2006/relationships" id="2147483653" r:id="R5509d4c774174fbd"/>
+    <p:sldLayoutId xmlns:r="http://schemas.openxmlformats.org/officeDocument/2006/relationships" id="2147483654" r:id="Rd059b50ff4304c7a"/>
   </p:sldLayoutIdLst>
   <p:txStyles>
     <p:titleStyle>
@@ -3441,7 +3441,7 @@
           <p:cNvPr id="14" name="">
             <a:extLst xmlns:a="http://schemas.openxmlformats.org/drawingml/2006/main">
               <a:ext uri="{FF2B5EF4-FFF2-40B4-BE49-F238E27FC236}">
-                <a16:creationId xmlns:a16="http://schemas.microsoft.com/office/drawing/2014/main" id="{19ECCEE9-E89A-4F1E-8937-16DEFA2BA287}"/>
+                <a16:creationId xmlns:a16="http://schemas.microsoft.com/office/drawing/2014/main" id="{3CAAD12C-1FEE-4199-8BFE-CBA21F5404A8}"/>
               </a:ext>
             </a:extLst>
           </p:cNvPr>
@@ -3472,7 +3472,7 @@
           <p:cNvPr id="13" name="">
             <a:extLst xmlns:a="http://schemas.openxmlformats.org/drawingml/2006/main">
               <a:ext uri="{FF2B5EF4-FFF2-40B4-BE49-F238E27FC236}">
-                <a16:creationId xmlns:a16="http://schemas.microsoft.com/office/drawing/2014/main" id="{AA11C98F-2344-4F2A-9E9D-207A159DC1CD}"/>
+                <a16:creationId xmlns:a16="http://schemas.microsoft.com/office/drawing/2014/main" id="{A85C9BED-57FE-4F09-B5C5-2F9F606776F8}"/>
               </a:ext>
             </a:extLst>
           </p:cNvPr>
@@ -3503,7 +3503,7 @@
           <p:cNvPr id="12" name="">
             <a:extLst xmlns:a="http://schemas.openxmlformats.org/drawingml/2006/main">
               <a:ext uri="{FF2B5EF4-FFF2-40B4-BE49-F238E27FC236}">
-                <a16:creationId xmlns:a16="http://schemas.microsoft.com/office/drawing/2014/main" id="{CC4C87A8-8245-4FA5-9643-4D1D91DBDE37}"/>
+                <a16:creationId xmlns:a16="http://schemas.microsoft.com/office/drawing/2014/main" id="{6FC1E5D6-18BC-413B-9439-A34B55999740}"/>
               </a:ext>
             </a:extLst>
           </p:cNvPr>
@@ -3534,7 +3534,7 @@
           <p:cNvPr id="11" name="">
             <a:extLst xmlns:a="http://schemas.openxmlformats.org/drawingml/2006/main">
               <a:ext uri="{FF2B5EF4-FFF2-40B4-BE49-F238E27FC236}">
-                <a16:creationId xmlns:a16="http://schemas.microsoft.com/office/drawing/2014/main" id="{6707ACA3-64B5-4628-A6C6-E3E15852EF52}"/>
+                <a16:creationId xmlns:a16="http://schemas.microsoft.com/office/drawing/2014/main" id="{20668440-030C-40B3-BC27-CF09F2E31011}"/>
               </a:ext>
             </a:extLst>
           </p:cNvPr>
@@ -3567,7 +3567,7 @@
           <p:cNvPr id="10" name="">
             <a:extLst xmlns:a="http://schemas.openxmlformats.org/drawingml/2006/main">
               <a:ext uri="{FF2B5EF4-FFF2-40B4-BE49-F238E27FC236}">
-                <a16:creationId xmlns:a16="http://schemas.microsoft.com/office/drawing/2014/main" id="{99FCB408-5C23-4CD6-B21F-C821475C9180}"/>
+                <a16:creationId xmlns:a16="http://schemas.microsoft.com/office/drawing/2014/main" id="{BF16F100-1520-4A98-83CA-9C86452FEF5C}"/>
               </a:ext>
             </a:extLst>
           </p:cNvPr>
@@ -3600,7 +3600,7 @@
           <p:cNvPr id="16" name="">
             <a:extLst xmlns:a="http://schemas.openxmlformats.org/drawingml/2006/main">
               <a:ext uri="{FF2B5EF4-FFF2-40B4-BE49-F238E27FC236}">
-                <a16:creationId xmlns:a16="http://schemas.microsoft.com/office/drawing/2014/main" id="{3F90812E-658E-44B0-A483-CAFC86C00DE2}"/>
+                <a16:creationId xmlns:a16="http://schemas.microsoft.com/office/drawing/2014/main" id="{19CEB0E3-2357-4460-AAE5-CAC02ACFB26A}"/>
               </a:ext>
             </a:extLst>
           </p:cNvPr>
@@ -3756,7 +3756,7 @@
           <p:cNvPr id="2" name="">
             <a:extLst xmlns:a="http://schemas.openxmlformats.org/drawingml/2006/main">
               <a:ext uri="{FF2B5EF4-FFF2-40B4-BE49-F238E27FC236}">
-                <a16:creationId xmlns:a16="http://schemas.microsoft.com/office/drawing/2014/main" id="{EBA7E357-A940-4D73-A7A4-D4970D7B08FC}"/>
+                <a16:creationId xmlns:a16="http://schemas.microsoft.com/office/drawing/2014/main" id="{580B4EAA-9DC7-4164-AE75-E470E42A3999}"/>
               </a:ext>
             </a:extLst>
           </p:cNvPr>
@@ -3912,7 +3912,7 @@
           <p:cNvPr id="3" name="">
             <a:extLst xmlns:a="http://schemas.openxmlformats.org/drawingml/2006/main">
               <a:ext uri="{FF2B5EF4-FFF2-40B4-BE49-F238E27FC236}">
-                <a16:creationId xmlns:a16="http://schemas.microsoft.com/office/drawing/2014/main" id="{A9F58FA1-8EEA-43E7-A731-D990C2C33EC1}"/>
+                <a16:creationId xmlns:a16="http://schemas.microsoft.com/office/drawing/2014/main" id="{9062F431-2A8F-4840-A663-16F2EB1068EC}"/>
               </a:ext>
             </a:extLst>
           </p:cNvPr>
@@ -4095,7 +4095,7 @@
           <p:cNvPr id="4" name="">
             <a:extLst xmlns:a="http://schemas.openxmlformats.org/drawingml/2006/main">
               <a:ext uri="{FF2B5EF4-FFF2-40B4-BE49-F238E27FC236}">
-                <a16:creationId xmlns:a16="http://schemas.microsoft.com/office/drawing/2014/main" id="{B0F31BAC-A14B-4732-93C9-7487FBC35872}"/>
+                <a16:creationId xmlns:a16="http://schemas.microsoft.com/office/drawing/2014/main" id="{DFF3F82B-D2E7-4027-BE42-F36A4E985EF8}"/>
               </a:ext>
             </a:extLst>
           </p:cNvPr>
@@ -4278,7 +4278,7 @@
           <p:cNvPr id="5" name="">
             <a:extLst xmlns:a="http://schemas.openxmlformats.org/drawingml/2006/main">
               <a:ext uri="{FF2B5EF4-FFF2-40B4-BE49-F238E27FC236}">
-                <a16:creationId xmlns:a16="http://schemas.microsoft.com/office/drawing/2014/main" id="{52B80683-5B42-49AD-ADD7-40547EFEA420}"/>
+                <a16:creationId xmlns:a16="http://schemas.microsoft.com/office/drawing/2014/main" id="{F3B30912-7BA6-4D9D-B509-73A11D901237}"/>
               </a:ext>
             </a:extLst>
           </p:cNvPr>
@@ -4461,7 +4461,7 @@
           <p:cNvPr id="6" name="">
             <a:extLst xmlns:a="http://schemas.openxmlformats.org/drawingml/2006/main">
               <a:ext uri="{FF2B5EF4-FFF2-40B4-BE49-F238E27FC236}">
-                <a16:creationId xmlns:a16="http://schemas.microsoft.com/office/drawing/2014/main" id="{D894D1B0-50A7-448F-AC65-D698385B7178}"/>
+                <a16:creationId xmlns:a16="http://schemas.microsoft.com/office/drawing/2014/main" id="{3FC52F65-5D66-4D6A-840A-7AB8E781D7A7}"/>
               </a:ext>
             </a:extLst>
           </p:cNvPr>
@@ -4644,7 +4644,7 @@
           <p:cNvPr id="7" name="">
             <a:extLst xmlns:a="http://schemas.openxmlformats.org/drawingml/2006/main">
               <a:ext uri="{FF2B5EF4-FFF2-40B4-BE49-F238E27FC236}">
-                <a16:creationId xmlns:a16="http://schemas.microsoft.com/office/drawing/2014/main" id="{ABFF6480-05DE-4C5D-B411-61BD00A8776E}"/>
+                <a16:creationId xmlns:a16="http://schemas.microsoft.com/office/drawing/2014/main" id="{18FCC589-42EA-43B8-8AF3-5BB017B632FD}"/>
               </a:ext>
             </a:extLst>
           </p:cNvPr>
@@ -4827,7 +4827,7 @@
           <p:cNvPr id="8" name="">
             <a:extLst xmlns:a="http://schemas.openxmlformats.org/drawingml/2006/main">
               <a:ext uri="{FF2B5EF4-FFF2-40B4-BE49-F238E27FC236}">
-                <a16:creationId xmlns:a16="http://schemas.microsoft.com/office/drawing/2014/main" id="{9A46ADAC-2F86-46F9-989A-90931FA562D1}"/>
+                <a16:creationId xmlns:a16="http://schemas.microsoft.com/office/drawing/2014/main" id="{9E7810A3-28C4-42D9-BFEC-8941F20BBC3D}"/>
               </a:ext>
             </a:extLst>
           </p:cNvPr>
@@ -5010,7 +5010,7 @@
           <p:cNvPr id="9" name="">
             <a:extLst xmlns:a="http://schemas.openxmlformats.org/drawingml/2006/main">
               <a:ext uri="{FF2B5EF4-FFF2-40B4-BE49-F238E27FC236}">
-                <a16:creationId xmlns:a16="http://schemas.microsoft.com/office/drawing/2014/main" id="{A6071EAA-639F-4CAA-9E57-E1836CFA0463}"/>
+                <a16:creationId xmlns:a16="http://schemas.microsoft.com/office/drawing/2014/main" id="{925A3832-0D8C-4EC2-A55F-A367E1BDE826}"/>
               </a:ext>
             </a:extLst>
           </p:cNvPr>
@@ -5193,7 +5193,7 @@
           <p:cNvPr id="15" name="">
             <a:extLst xmlns:a="http://schemas.openxmlformats.org/drawingml/2006/main">
               <a:ext uri="{FF2B5EF4-FFF2-40B4-BE49-F238E27FC236}">
-                <a16:creationId xmlns:a16="http://schemas.microsoft.com/office/drawing/2014/main" id="{445F39E8-B5AF-403F-B507-FFF70B63125E}"/>
+                <a16:creationId xmlns:a16="http://schemas.microsoft.com/office/drawing/2014/main" id="{703440D8-3E9B-4A0B-9974-E21F44A1ECD8}"/>
               </a:ext>
             </a:extLst>
           </p:cNvPr>
@@ -5347,7 +5347,7 @@
     </p:spTree>
     <p:extLst>
       <p:ext uri="{BB962C8B-B14F-4D97-AF65-F5344CB8AC3E}">
-        <p14:creationId xmlns:p14="http://schemas.microsoft.com/office/powerpoint/2010/main" val="955596032"/>
+        <p14:creationId xmlns:p14="http://schemas.microsoft.com/office/powerpoint/2010/main" val="1872730165"/>
       </p:ext>
     </p:extLst>
   </p:cSld>

</xml_diff>

<commit_message>
Evaluate causal frozen alert policy (B3)
</commit_message>
<xml_diff>
--- a/deliverables/CycleTwin_architecture.pptx
+++ b/deliverables/CycleTwin_architecture.pptx
@@ -2,13 +2,13 @@
 <file path=ppt/presentation.xml><?xml version="1.0" encoding="utf-8"?>
 <p:presentation xmlns:p="http://schemas.openxmlformats.org/presentationml/2006/main">
   <p:sldMasterIdLst>
-    <p:sldMasterId xmlns:r="http://schemas.openxmlformats.org/officeDocument/2006/relationships" id="2147483648" r:id="R148b4c1939d545a2"/>
+    <p:sldMasterId xmlns:r="http://schemas.openxmlformats.org/officeDocument/2006/relationships" id="2147483648" r:id="R8408a51494334647"/>
   </p:sldMasterIdLst>
   <p:notesMasterIdLst>
-    <p:notesMasterId xmlns:r="http://schemas.openxmlformats.org/officeDocument/2006/relationships" r:id="R2007d8a40d2f47f7"/>
+    <p:notesMasterId xmlns:r="http://schemas.openxmlformats.org/officeDocument/2006/relationships" r:id="R1de33d00e81543d1"/>
   </p:notesMasterIdLst>
   <p:sldIdLst>
-    <p:sldId xmlns:r="http://schemas.openxmlformats.org/officeDocument/2006/relationships" id="256" r:id="Rd453355faea9433c"/>
+    <p:sldId xmlns:r="http://schemas.openxmlformats.org/officeDocument/2006/relationships" id="256" r:id="R78108ed53ec0480a"/>
   </p:sldIdLst>
   <p:sldSz cx="12192000" cy="6858000"/>
   <p:notesSz cx="6858000" cy="9144000"/>
@@ -489,7 +489,7 @@
           <p:cNvPr id="3" name="Title">
             <a:extLst xmlns:a="http://schemas.openxmlformats.org/drawingml/2006/main">
               <a:ext uri="{FF2B5EF4-FFF2-40B4-BE49-F238E27FC236}">
-                <a16:creationId xmlns:a16="http://schemas.microsoft.com/office/drawing/2014/main" id="{8FAAD3D4-34F7-485E-AF4F-28174803567D}"/>
+                <a16:creationId xmlns:a16="http://schemas.microsoft.com/office/drawing/2014/main" id="{AA39AF3E-8C8C-411A-A794-3068B2D78F5B}"/>
               </a:ext>
             </a:extLst>
           </p:cNvPr>
@@ -718,7 +718,7 @@
           <p:cNvPr id="2" name="Subtitle">
             <a:extLst xmlns:a="http://schemas.openxmlformats.org/drawingml/2006/main">
               <a:ext uri="{FF2B5EF4-FFF2-40B4-BE49-F238E27FC236}">
-                <a16:creationId xmlns:a16="http://schemas.microsoft.com/office/drawing/2014/main" id="{A5E97888-7713-4B3B-BBB3-D54CE3E7B530}"/>
+                <a16:creationId xmlns:a16="http://schemas.microsoft.com/office/drawing/2014/main" id="{56F52385-41F4-4FCF-801A-FB8A4D5AA2C6}"/>
               </a:ext>
             </a:extLst>
           </p:cNvPr>
@@ -964,7 +964,7 @@
           <p:cNvPr id="2" name="Section title">
             <a:extLst xmlns:a="http://schemas.openxmlformats.org/drawingml/2006/main">
               <a:ext uri="{FF2B5EF4-FFF2-40B4-BE49-F238E27FC236}">
-                <a16:creationId xmlns:a16="http://schemas.microsoft.com/office/drawing/2014/main" id="{B3442719-859F-4E2C-B64E-D3969B5CA04F}"/>
+                <a16:creationId xmlns:a16="http://schemas.microsoft.com/office/drawing/2014/main" id="{B19A239D-6C94-4DB0-9E84-86CA7BF1D484}"/>
               </a:ext>
             </a:extLst>
           </p:cNvPr>
@@ -1210,7 +1210,7 @@
           <p:cNvPr id="3" name="Title">
             <a:extLst xmlns:a="http://schemas.openxmlformats.org/drawingml/2006/main">
               <a:ext uri="{FF2B5EF4-FFF2-40B4-BE49-F238E27FC236}">
-                <a16:creationId xmlns:a16="http://schemas.microsoft.com/office/drawing/2014/main" id="{3027BB26-5033-4F73-87AC-395AFB8FBE93}"/>
+                <a16:creationId xmlns:a16="http://schemas.microsoft.com/office/drawing/2014/main" id="{1BACC6C3-166E-4CE1-984B-D568CA955FB6}"/>
               </a:ext>
             </a:extLst>
           </p:cNvPr>
@@ -1439,7 +1439,7 @@
           <p:cNvPr id="2" name="Body">
             <a:extLst xmlns:a="http://schemas.openxmlformats.org/drawingml/2006/main">
               <a:ext uri="{FF2B5EF4-FFF2-40B4-BE49-F238E27FC236}">
-                <a16:creationId xmlns:a16="http://schemas.microsoft.com/office/drawing/2014/main" id="{89AD81BC-538E-4A1B-B12D-C3DD539CB371}"/>
+                <a16:creationId xmlns:a16="http://schemas.microsoft.com/office/drawing/2014/main" id="{E81E12C6-42B4-408E-A72E-A2EF7A860AFD}"/>
               </a:ext>
             </a:extLst>
           </p:cNvPr>
@@ -1685,7 +1685,7 @@
           <p:cNvPr id="4" name="Title">
             <a:extLst xmlns:a="http://schemas.openxmlformats.org/drawingml/2006/main">
               <a:ext uri="{FF2B5EF4-FFF2-40B4-BE49-F238E27FC236}">
-                <a16:creationId xmlns:a16="http://schemas.microsoft.com/office/drawing/2014/main" id="{5E4D4008-7208-4336-85FC-1274C1AFB14C}"/>
+                <a16:creationId xmlns:a16="http://schemas.microsoft.com/office/drawing/2014/main" id="{D86BD200-1239-44E7-AACE-67718DCC82C6}"/>
               </a:ext>
             </a:extLst>
           </p:cNvPr>
@@ -1914,7 +1914,7 @@
           <p:cNvPr id="2" name="Left column">
             <a:extLst xmlns:a="http://schemas.openxmlformats.org/drawingml/2006/main">
               <a:ext uri="{FF2B5EF4-FFF2-40B4-BE49-F238E27FC236}">
-                <a16:creationId xmlns:a16="http://schemas.microsoft.com/office/drawing/2014/main" id="{21601C5E-8F93-4692-85AD-2139B103B499}"/>
+                <a16:creationId xmlns:a16="http://schemas.microsoft.com/office/drawing/2014/main" id="{8AB5255F-BF92-47B7-8EF9-80C2C1D4F1AF}"/>
               </a:ext>
             </a:extLst>
           </p:cNvPr>
@@ -2143,7 +2143,7 @@
           <p:cNvPr id="3" name="Right column">
             <a:extLst xmlns:a="http://schemas.openxmlformats.org/drawingml/2006/main">
               <a:ext uri="{FF2B5EF4-FFF2-40B4-BE49-F238E27FC236}">
-                <a16:creationId xmlns:a16="http://schemas.microsoft.com/office/drawing/2014/main" id="{63853C48-52D0-4D02-8926-1FCF20AE014B}"/>
+                <a16:creationId xmlns:a16="http://schemas.microsoft.com/office/drawing/2014/main" id="{381E2D94-8E9D-4674-AC1B-9E1FBF566A3E}"/>
               </a:ext>
             </a:extLst>
           </p:cNvPr>
@@ -2389,7 +2389,7 @@
           <p:cNvPr id="3" name="Title">
             <a:extLst xmlns:a="http://schemas.openxmlformats.org/drawingml/2006/main">
               <a:ext uri="{FF2B5EF4-FFF2-40B4-BE49-F238E27FC236}">
-                <a16:creationId xmlns:a16="http://schemas.microsoft.com/office/drawing/2014/main" id="{C9ED8934-BB99-4BD0-8368-0282BCFBA300}"/>
+                <a16:creationId xmlns:a16="http://schemas.microsoft.com/office/drawing/2014/main" id="{833B5593-2446-4289-BCDB-37D6BE2B9A4E}"/>
               </a:ext>
             </a:extLst>
           </p:cNvPr>
@@ -2618,7 +2618,7 @@
           <p:cNvPr id="2" name="Left column">
             <a:extLst xmlns:a="http://schemas.openxmlformats.org/drawingml/2006/main">
               <a:ext uri="{FF2B5EF4-FFF2-40B4-BE49-F238E27FC236}">
-                <a16:creationId xmlns:a16="http://schemas.microsoft.com/office/drawing/2014/main" id="{CBC346B1-552C-4ED9-9258-2E46B3A0292C}"/>
+                <a16:creationId xmlns:a16="http://schemas.microsoft.com/office/drawing/2014/main" id="{8FF72903-5997-4547-B356-F3E28ED5E19A}"/>
               </a:ext>
             </a:extLst>
           </p:cNvPr>
@@ -2885,12 +2885,12 @@
   </p:cSld>
   <p:clrMap bg1="lt1" tx1="dk1" bg2="lt2" tx2="dk2" accent1="accent1" accent2="accent2" accent3="accent3" accent4="accent4" accent5="accent5" accent6="accent6" hlink="hlink" folHlink="folHlink"/>
   <p:sldLayoutIdLst>
-    <p:sldLayoutId xmlns:r="http://schemas.openxmlformats.org/officeDocument/2006/relationships" id="2147483649" r:id="Rf98fe8c8704b45c6"/>
-    <p:sldLayoutId xmlns:r="http://schemas.openxmlformats.org/officeDocument/2006/relationships" id="2147483650" r:id="Rcb59d11e66214bec"/>
-    <p:sldLayoutId xmlns:r="http://schemas.openxmlformats.org/officeDocument/2006/relationships" id="2147483651" r:id="R0882d86cdb0249bf"/>
-    <p:sldLayoutId xmlns:r="http://schemas.openxmlformats.org/officeDocument/2006/relationships" id="2147483652" r:id="Rd89a6855be9e4481"/>
-    <p:sldLayoutId xmlns:r="http://schemas.openxmlformats.org/officeDocument/2006/relationships" id="2147483653" r:id="R5509d4c774174fbd"/>
-    <p:sldLayoutId xmlns:r="http://schemas.openxmlformats.org/officeDocument/2006/relationships" id="2147483654" r:id="Rd059b50ff4304c7a"/>
+    <p:sldLayoutId xmlns:r="http://schemas.openxmlformats.org/officeDocument/2006/relationships" id="2147483649" r:id="Ree1ac80d3efc49e9"/>
+    <p:sldLayoutId xmlns:r="http://schemas.openxmlformats.org/officeDocument/2006/relationships" id="2147483650" r:id="Ra37448663e46435b"/>
+    <p:sldLayoutId xmlns:r="http://schemas.openxmlformats.org/officeDocument/2006/relationships" id="2147483651" r:id="R0c6e1b419a3c4275"/>
+    <p:sldLayoutId xmlns:r="http://schemas.openxmlformats.org/officeDocument/2006/relationships" id="2147483652" r:id="Rba787da387ee411b"/>
+    <p:sldLayoutId xmlns:r="http://schemas.openxmlformats.org/officeDocument/2006/relationships" id="2147483653" r:id="R8eab381c1eac4fd7"/>
+    <p:sldLayoutId xmlns:r="http://schemas.openxmlformats.org/officeDocument/2006/relationships" id="2147483654" r:id="R834a73e9bc7c4f22"/>
   </p:sldLayoutIdLst>
   <p:txStyles>
     <p:titleStyle>
@@ -3441,7 +3441,7 @@
           <p:cNvPr id="14" name="">
             <a:extLst xmlns:a="http://schemas.openxmlformats.org/drawingml/2006/main">
               <a:ext uri="{FF2B5EF4-FFF2-40B4-BE49-F238E27FC236}">
-                <a16:creationId xmlns:a16="http://schemas.microsoft.com/office/drawing/2014/main" id="{3CAAD12C-1FEE-4199-8BFE-CBA21F5404A8}"/>
+                <a16:creationId xmlns:a16="http://schemas.microsoft.com/office/drawing/2014/main" id="{C998EE1D-C587-49CF-BD68-4D9BE1566416}"/>
               </a:ext>
             </a:extLst>
           </p:cNvPr>
@@ -3472,7 +3472,7 @@
           <p:cNvPr id="13" name="">
             <a:extLst xmlns:a="http://schemas.openxmlformats.org/drawingml/2006/main">
               <a:ext uri="{FF2B5EF4-FFF2-40B4-BE49-F238E27FC236}">
-                <a16:creationId xmlns:a16="http://schemas.microsoft.com/office/drawing/2014/main" id="{A85C9BED-57FE-4F09-B5C5-2F9F606776F8}"/>
+                <a16:creationId xmlns:a16="http://schemas.microsoft.com/office/drawing/2014/main" id="{EE975974-7022-4AFC-9240-35A72477A360}"/>
               </a:ext>
             </a:extLst>
           </p:cNvPr>
@@ -3503,7 +3503,7 @@
           <p:cNvPr id="12" name="">
             <a:extLst xmlns:a="http://schemas.openxmlformats.org/drawingml/2006/main">
               <a:ext uri="{FF2B5EF4-FFF2-40B4-BE49-F238E27FC236}">
-                <a16:creationId xmlns:a16="http://schemas.microsoft.com/office/drawing/2014/main" id="{6FC1E5D6-18BC-413B-9439-A34B55999740}"/>
+                <a16:creationId xmlns:a16="http://schemas.microsoft.com/office/drawing/2014/main" id="{0E648D35-DDC6-450F-AB6C-327F71FD92BB}"/>
               </a:ext>
             </a:extLst>
           </p:cNvPr>
@@ -3534,7 +3534,7 @@
           <p:cNvPr id="11" name="">
             <a:extLst xmlns:a="http://schemas.openxmlformats.org/drawingml/2006/main">
               <a:ext uri="{FF2B5EF4-FFF2-40B4-BE49-F238E27FC236}">
-                <a16:creationId xmlns:a16="http://schemas.microsoft.com/office/drawing/2014/main" id="{20668440-030C-40B3-BC27-CF09F2E31011}"/>
+                <a16:creationId xmlns:a16="http://schemas.microsoft.com/office/drawing/2014/main" id="{C2F76EDE-E9C9-4BAF-91CD-83CBC741D7F8}"/>
               </a:ext>
             </a:extLst>
           </p:cNvPr>
@@ -3567,7 +3567,7 @@
           <p:cNvPr id="10" name="">
             <a:extLst xmlns:a="http://schemas.openxmlformats.org/drawingml/2006/main">
               <a:ext uri="{FF2B5EF4-FFF2-40B4-BE49-F238E27FC236}">
-                <a16:creationId xmlns:a16="http://schemas.microsoft.com/office/drawing/2014/main" id="{BF16F100-1520-4A98-83CA-9C86452FEF5C}"/>
+                <a16:creationId xmlns:a16="http://schemas.microsoft.com/office/drawing/2014/main" id="{86C4A014-6B00-4689-953A-3B77FAAC41E8}"/>
               </a:ext>
             </a:extLst>
           </p:cNvPr>
@@ -3600,7 +3600,7 @@
           <p:cNvPr id="16" name="">
             <a:extLst xmlns:a="http://schemas.openxmlformats.org/drawingml/2006/main">
               <a:ext uri="{FF2B5EF4-FFF2-40B4-BE49-F238E27FC236}">
-                <a16:creationId xmlns:a16="http://schemas.microsoft.com/office/drawing/2014/main" id="{19CEB0E3-2357-4460-AAE5-CAC02ACFB26A}"/>
+                <a16:creationId xmlns:a16="http://schemas.microsoft.com/office/drawing/2014/main" id="{9575D181-05B1-4AC0-86B9-97F69920F039}"/>
               </a:ext>
             </a:extLst>
           </p:cNvPr>
@@ -3756,7 +3756,7 @@
           <p:cNvPr id="2" name="">
             <a:extLst xmlns:a="http://schemas.openxmlformats.org/drawingml/2006/main">
               <a:ext uri="{FF2B5EF4-FFF2-40B4-BE49-F238E27FC236}">
-                <a16:creationId xmlns:a16="http://schemas.microsoft.com/office/drawing/2014/main" id="{580B4EAA-9DC7-4164-AE75-E470E42A3999}"/>
+                <a16:creationId xmlns:a16="http://schemas.microsoft.com/office/drawing/2014/main" id="{DE05A43F-757D-486A-ADC5-8405DB114758}"/>
               </a:ext>
             </a:extLst>
           </p:cNvPr>
@@ -3912,7 +3912,7 @@
           <p:cNvPr id="3" name="">
             <a:extLst xmlns:a="http://schemas.openxmlformats.org/drawingml/2006/main">
               <a:ext uri="{FF2B5EF4-FFF2-40B4-BE49-F238E27FC236}">
-                <a16:creationId xmlns:a16="http://schemas.microsoft.com/office/drawing/2014/main" id="{9062F431-2A8F-4840-A663-16F2EB1068EC}"/>
+                <a16:creationId xmlns:a16="http://schemas.microsoft.com/office/drawing/2014/main" id="{445CA372-1D5E-49A0-8452-25ECD5A70023}"/>
               </a:ext>
             </a:extLst>
           </p:cNvPr>
@@ -4095,7 +4095,7 @@
           <p:cNvPr id="4" name="">
             <a:extLst xmlns:a="http://schemas.openxmlformats.org/drawingml/2006/main">
               <a:ext uri="{FF2B5EF4-FFF2-40B4-BE49-F238E27FC236}">
-                <a16:creationId xmlns:a16="http://schemas.microsoft.com/office/drawing/2014/main" id="{DFF3F82B-D2E7-4027-BE42-F36A4E985EF8}"/>
+                <a16:creationId xmlns:a16="http://schemas.microsoft.com/office/drawing/2014/main" id="{1C67B36A-F54E-4C94-B669-16B0E80E0CB9}"/>
               </a:ext>
             </a:extLst>
           </p:cNvPr>
@@ -4278,7 +4278,7 @@
           <p:cNvPr id="5" name="">
             <a:extLst xmlns:a="http://schemas.openxmlformats.org/drawingml/2006/main">
               <a:ext uri="{FF2B5EF4-FFF2-40B4-BE49-F238E27FC236}">
-                <a16:creationId xmlns:a16="http://schemas.microsoft.com/office/drawing/2014/main" id="{F3B30912-7BA6-4D9D-B509-73A11D901237}"/>
+                <a16:creationId xmlns:a16="http://schemas.microsoft.com/office/drawing/2014/main" id="{ACB7A3F1-CE83-4154-9EFA-F2B4BE041CE6}"/>
               </a:ext>
             </a:extLst>
           </p:cNvPr>
@@ -4461,7 +4461,7 @@
           <p:cNvPr id="6" name="">
             <a:extLst xmlns:a="http://schemas.openxmlformats.org/drawingml/2006/main">
               <a:ext uri="{FF2B5EF4-FFF2-40B4-BE49-F238E27FC236}">
-                <a16:creationId xmlns:a16="http://schemas.microsoft.com/office/drawing/2014/main" id="{3FC52F65-5D66-4D6A-840A-7AB8E781D7A7}"/>
+                <a16:creationId xmlns:a16="http://schemas.microsoft.com/office/drawing/2014/main" id="{BDCED6BB-ED89-484E-B11E-E023D2452C0B}"/>
               </a:ext>
             </a:extLst>
           </p:cNvPr>
@@ -4644,7 +4644,7 @@
           <p:cNvPr id="7" name="">
             <a:extLst xmlns:a="http://schemas.openxmlformats.org/drawingml/2006/main">
               <a:ext uri="{FF2B5EF4-FFF2-40B4-BE49-F238E27FC236}">
-                <a16:creationId xmlns:a16="http://schemas.microsoft.com/office/drawing/2014/main" id="{18FCC589-42EA-43B8-8AF3-5BB017B632FD}"/>
+                <a16:creationId xmlns:a16="http://schemas.microsoft.com/office/drawing/2014/main" id="{8A76F972-F253-4C93-B7B9-C6F99A22748F}"/>
               </a:ext>
             </a:extLst>
           </p:cNvPr>
@@ -4827,7 +4827,7 @@
           <p:cNvPr id="8" name="">
             <a:extLst xmlns:a="http://schemas.openxmlformats.org/drawingml/2006/main">
               <a:ext uri="{FF2B5EF4-FFF2-40B4-BE49-F238E27FC236}">
-                <a16:creationId xmlns:a16="http://schemas.microsoft.com/office/drawing/2014/main" id="{9E7810A3-28C4-42D9-BFEC-8941F20BBC3D}"/>
+                <a16:creationId xmlns:a16="http://schemas.microsoft.com/office/drawing/2014/main" id="{61D014DD-1B9D-4DD5-8ADA-9E9CD2C08B4E}"/>
               </a:ext>
             </a:extLst>
           </p:cNvPr>
@@ -5010,7 +5010,7 @@
           <p:cNvPr id="9" name="">
             <a:extLst xmlns:a="http://schemas.openxmlformats.org/drawingml/2006/main">
               <a:ext uri="{FF2B5EF4-FFF2-40B4-BE49-F238E27FC236}">
-                <a16:creationId xmlns:a16="http://schemas.microsoft.com/office/drawing/2014/main" id="{925A3832-0D8C-4EC2-A55F-A367E1BDE826}"/>
+                <a16:creationId xmlns:a16="http://schemas.microsoft.com/office/drawing/2014/main" id="{82FAF77C-59E8-4EEA-BEE5-3BB794678261}"/>
               </a:ext>
             </a:extLst>
           </p:cNvPr>
@@ -5193,7 +5193,7 @@
           <p:cNvPr id="15" name="">
             <a:extLst xmlns:a="http://schemas.openxmlformats.org/drawingml/2006/main">
               <a:ext uri="{FF2B5EF4-FFF2-40B4-BE49-F238E27FC236}">
-                <a16:creationId xmlns:a16="http://schemas.microsoft.com/office/drawing/2014/main" id="{703440D8-3E9B-4A0B-9974-E21F44A1ECD8}"/>
+                <a16:creationId xmlns:a16="http://schemas.microsoft.com/office/drawing/2014/main" id="{0467A5D8-110B-439E-9057-D39906CD6645}"/>
               </a:ext>
             </a:extLst>
           </p:cNvPr>
@@ -5347,7 +5347,7 @@
     </p:spTree>
     <p:extLst>
       <p:ext uri="{BB962C8B-B14F-4D97-AF65-F5344CB8AC3E}">
-        <p14:creationId xmlns:p14="http://schemas.microsoft.com/office/powerpoint/2010/main" val="1872730165"/>
+        <p14:creationId xmlns:p14="http://schemas.microsoft.com/office/powerpoint/2010/main" val="875605598"/>
       </p:ext>
     </p:extLst>
   </p:cSld>

</xml_diff>

<commit_message>
Add frozen synthetic robustness sweeps (B4)
</commit_message>
<xml_diff>
--- a/deliverables/CycleTwin_architecture.pptx
+++ b/deliverables/CycleTwin_architecture.pptx
@@ -2,13 +2,13 @@
 <file path=ppt/presentation.xml><?xml version="1.0" encoding="utf-8"?>
 <p:presentation xmlns:p="http://schemas.openxmlformats.org/presentationml/2006/main">
   <p:sldMasterIdLst>
-    <p:sldMasterId xmlns:r="http://schemas.openxmlformats.org/officeDocument/2006/relationships" id="2147483648" r:id="R8408a51494334647"/>
+    <p:sldMasterId xmlns:r="http://schemas.openxmlformats.org/officeDocument/2006/relationships" id="2147483648" r:id="Rbbede184bf654368"/>
   </p:sldMasterIdLst>
   <p:notesMasterIdLst>
-    <p:notesMasterId xmlns:r="http://schemas.openxmlformats.org/officeDocument/2006/relationships" r:id="R1de33d00e81543d1"/>
+    <p:notesMasterId xmlns:r="http://schemas.openxmlformats.org/officeDocument/2006/relationships" r:id="R3f8b2306841b4f54"/>
   </p:notesMasterIdLst>
   <p:sldIdLst>
-    <p:sldId xmlns:r="http://schemas.openxmlformats.org/officeDocument/2006/relationships" id="256" r:id="R78108ed53ec0480a"/>
+    <p:sldId xmlns:r="http://schemas.openxmlformats.org/officeDocument/2006/relationships" id="256" r:id="R9d9ebc75933541ae"/>
   </p:sldIdLst>
   <p:sldSz cx="12192000" cy="6858000"/>
   <p:notesSz cx="6858000" cy="9144000"/>
@@ -489,7 +489,7 @@
           <p:cNvPr id="3" name="Title">
             <a:extLst xmlns:a="http://schemas.openxmlformats.org/drawingml/2006/main">
               <a:ext uri="{FF2B5EF4-FFF2-40B4-BE49-F238E27FC236}">
-                <a16:creationId xmlns:a16="http://schemas.microsoft.com/office/drawing/2014/main" id="{AA39AF3E-8C8C-411A-A794-3068B2D78F5B}"/>
+                <a16:creationId xmlns:a16="http://schemas.microsoft.com/office/drawing/2014/main" id="{A38764FC-351A-4D6C-8D50-533721638DCF}"/>
               </a:ext>
             </a:extLst>
           </p:cNvPr>
@@ -718,7 +718,7 @@
           <p:cNvPr id="2" name="Subtitle">
             <a:extLst xmlns:a="http://schemas.openxmlformats.org/drawingml/2006/main">
               <a:ext uri="{FF2B5EF4-FFF2-40B4-BE49-F238E27FC236}">
-                <a16:creationId xmlns:a16="http://schemas.microsoft.com/office/drawing/2014/main" id="{56F52385-41F4-4FCF-801A-FB8A4D5AA2C6}"/>
+                <a16:creationId xmlns:a16="http://schemas.microsoft.com/office/drawing/2014/main" id="{8A60F78A-410D-442F-AAE0-1CEFEB7AD9F6}"/>
               </a:ext>
             </a:extLst>
           </p:cNvPr>
@@ -964,7 +964,7 @@
           <p:cNvPr id="2" name="Section title">
             <a:extLst xmlns:a="http://schemas.openxmlformats.org/drawingml/2006/main">
               <a:ext uri="{FF2B5EF4-FFF2-40B4-BE49-F238E27FC236}">
-                <a16:creationId xmlns:a16="http://schemas.microsoft.com/office/drawing/2014/main" id="{B19A239D-6C94-4DB0-9E84-86CA7BF1D484}"/>
+                <a16:creationId xmlns:a16="http://schemas.microsoft.com/office/drawing/2014/main" id="{3FA677C4-D82F-4717-BF20-AF7E23559273}"/>
               </a:ext>
             </a:extLst>
           </p:cNvPr>
@@ -1210,7 +1210,7 @@
           <p:cNvPr id="3" name="Title">
             <a:extLst xmlns:a="http://schemas.openxmlformats.org/drawingml/2006/main">
               <a:ext uri="{FF2B5EF4-FFF2-40B4-BE49-F238E27FC236}">
-                <a16:creationId xmlns:a16="http://schemas.microsoft.com/office/drawing/2014/main" id="{1BACC6C3-166E-4CE1-984B-D568CA955FB6}"/>
+                <a16:creationId xmlns:a16="http://schemas.microsoft.com/office/drawing/2014/main" id="{D913EE7A-221D-4D83-9870-D27A4F986CAC}"/>
               </a:ext>
             </a:extLst>
           </p:cNvPr>
@@ -1439,7 +1439,7 @@
           <p:cNvPr id="2" name="Body">
             <a:extLst xmlns:a="http://schemas.openxmlformats.org/drawingml/2006/main">
               <a:ext uri="{FF2B5EF4-FFF2-40B4-BE49-F238E27FC236}">
-                <a16:creationId xmlns:a16="http://schemas.microsoft.com/office/drawing/2014/main" id="{E81E12C6-42B4-408E-A72E-A2EF7A860AFD}"/>
+                <a16:creationId xmlns:a16="http://schemas.microsoft.com/office/drawing/2014/main" id="{4B79E89F-326E-48EE-8FEB-6168BA011285}"/>
               </a:ext>
             </a:extLst>
           </p:cNvPr>
@@ -1685,7 +1685,7 @@
           <p:cNvPr id="4" name="Title">
             <a:extLst xmlns:a="http://schemas.openxmlformats.org/drawingml/2006/main">
               <a:ext uri="{FF2B5EF4-FFF2-40B4-BE49-F238E27FC236}">
-                <a16:creationId xmlns:a16="http://schemas.microsoft.com/office/drawing/2014/main" id="{D86BD200-1239-44E7-AACE-67718DCC82C6}"/>
+                <a16:creationId xmlns:a16="http://schemas.microsoft.com/office/drawing/2014/main" id="{C68D99AF-5015-43B2-8150-1FAA35AB376F}"/>
               </a:ext>
             </a:extLst>
           </p:cNvPr>
@@ -1914,7 +1914,7 @@
           <p:cNvPr id="2" name="Left column">
             <a:extLst xmlns:a="http://schemas.openxmlformats.org/drawingml/2006/main">
               <a:ext uri="{FF2B5EF4-FFF2-40B4-BE49-F238E27FC236}">
-                <a16:creationId xmlns:a16="http://schemas.microsoft.com/office/drawing/2014/main" id="{8AB5255F-BF92-47B7-8EF9-80C2C1D4F1AF}"/>
+                <a16:creationId xmlns:a16="http://schemas.microsoft.com/office/drawing/2014/main" id="{6FA0895A-34C5-4157-BA7E-132A9ED57C76}"/>
               </a:ext>
             </a:extLst>
           </p:cNvPr>
@@ -2143,7 +2143,7 @@
           <p:cNvPr id="3" name="Right column">
             <a:extLst xmlns:a="http://schemas.openxmlformats.org/drawingml/2006/main">
               <a:ext uri="{FF2B5EF4-FFF2-40B4-BE49-F238E27FC236}">
-                <a16:creationId xmlns:a16="http://schemas.microsoft.com/office/drawing/2014/main" id="{381E2D94-8E9D-4674-AC1B-9E1FBF566A3E}"/>
+                <a16:creationId xmlns:a16="http://schemas.microsoft.com/office/drawing/2014/main" id="{AF6BC2BB-B45F-4FC4-A01C-FF52906AB519}"/>
               </a:ext>
             </a:extLst>
           </p:cNvPr>
@@ -2389,7 +2389,7 @@
           <p:cNvPr id="3" name="Title">
             <a:extLst xmlns:a="http://schemas.openxmlformats.org/drawingml/2006/main">
               <a:ext uri="{FF2B5EF4-FFF2-40B4-BE49-F238E27FC236}">
-                <a16:creationId xmlns:a16="http://schemas.microsoft.com/office/drawing/2014/main" id="{833B5593-2446-4289-BCDB-37D6BE2B9A4E}"/>
+                <a16:creationId xmlns:a16="http://schemas.microsoft.com/office/drawing/2014/main" id="{3D359AF8-A674-48F0-99AF-13140023089C}"/>
               </a:ext>
             </a:extLst>
           </p:cNvPr>
@@ -2618,7 +2618,7 @@
           <p:cNvPr id="2" name="Left column">
             <a:extLst xmlns:a="http://schemas.openxmlformats.org/drawingml/2006/main">
               <a:ext uri="{FF2B5EF4-FFF2-40B4-BE49-F238E27FC236}">
-                <a16:creationId xmlns:a16="http://schemas.microsoft.com/office/drawing/2014/main" id="{8FF72903-5997-4547-B356-F3E28ED5E19A}"/>
+                <a16:creationId xmlns:a16="http://schemas.microsoft.com/office/drawing/2014/main" id="{8CA73A2A-DCA9-4683-89B9-1D156C070215}"/>
               </a:ext>
             </a:extLst>
           </p:cNvPr>
@@ -2885,12 +2885,12 @@
   </p:cSld>
   <p:clrMap bg1="lt1" tx1="dk1" bg2="lt2" tx2="dk2" accent1="accent1" accent2="accent2" accent3="accent3" accent4="accent4" accent5="accent5" accent6="accent6" hlink="hlink" folHlink="folHlink"/>
   <p:sldLayoutIdLst>
-    <p:sldLayoutId xmlns:r="http://schemas.openxmlformats.org/officeDocument/2006/relationships" id="2147483649" r:id="Ree1ac80d3efc49e9"/>
-    <p:sldLayoutId xmlns:r="http://schemas.openxmlformats.org/officeDocument/2006/relationships" id="2147483650" r:id="Ra37448663e46435b"/>
-    <p:sldLayoutId xmlns:r="http://schemas.openxmlformats.org/officeDocument/2006/relationships" id="2147483651" r:id="R0c6e1b419a3c4275"/>
-    <p:sldLayoutId xmlns:r="http://schemas.openxmlformats.org/officeDocument/2006/relationships" id="2147483652" r:id="Rba787da387ee411b"/>
-    <p:sldLayoutId xmlns:r="http://schemas.openxmlformats.org/officeDocument/2006/relationships" id="2147483653" r:id="R8eab381c1eac4fd7"/>
-    <p:sldLayoutId xmlns:r="http://schemas.openxmlformats.org/officeDocument/2006/relationships" id="2147483654" r:id="R834a73e9bc7c4f22"/>
+    <p:sldLayoutId xmlns:r="http://schemas.openxmlformats.org/officeDocument/2006/relationships" id="2147483649" r:id="R2991a105a80641ca"/>
+    <p:sldLayoutId xmlns:r="http://schemas.openxmlformats.org/officeDocument/2006/relationships" id="2147483650" r:id="Rfc4e83f3b8744a5e"/>
+    <p:sldLayoutId xmlns:r="http://schemas.openxmlformats.org/officeDocument/2006/relationships" id="2147483651" r:id="Rdc8d3761dd0a4801"/>
+    <p:sldLayoutId xmlns:r="http://schemas.openxmlformats.org/officeDocument/2006/relationships" id="2147483652" r:id="R11878ba452b740d2"/>
+    <p:sldLayoutId xmlns:r="http://schemas.openxmlformats.org/officeDocument/2006/relationships" id="2147483653" r:id="R1691c55adc3e472e"/>
+    <p:sldLayoutId xmlns:r="http://schemas.openxmlformats.org/officeDocument/2006/relationships" id="2147483654" r:id="R7b82bf74242e4162"/>
   </p:sldLayoutIdLst>
   <p:txStyles>
     <p:titleStyle>
@@ -3441,7 +3441,7 @@
           <p:cNvPr id="14" name="">
             <a:extLst xmlns:a="http://schemas.openxmlformats.org/drawingml/2006/main">
               <a:ext uri="{FF2B5EF4-FFF2-40B4-BE49-F238E27FC236}">
-                <a16:creationId xmlns:a16="http://schemas.microsoft.com/office/drawing/2014/main" id="{C998EE1D-C587-49CF-BD68-4D9BE1566416}"/>
+                <a16:creationId xmlns:a16="http://schemas.microsoft.com/office/drawing/2014/main" id="{6D2FE2FF-4268-40BC-B9AB-2F4A5071012C}"/>
               </a:ext>
             </a:extLst>
           </p:cNvPr>
@@ -3472,7 +3472,7 @@
           <p:cNvPr id="13" name="">
             <a:extLst xmlns:a="http://schemas.openxmlformats.org/drawingml/2006/main">
               <a:ext uri="{FF2B5EF4-FFF2-40B4-BE49-F238E27FC236}">
-                <a16:creationId xmlns:a16="http://schemas.microsoft.com/office/drawing/2014/main" id="{EE975974-7022-4AFC-9240-35A72477A360}"/>
+                <a16:creationId xmlns:a16="http://schemas.microsoft.com/office/drawing/2014/main" id="{4F543C81-8CFE-4AD2-927F-0810B0C6FC4D}"/>
               </a:ext>
             </a:extLst>
           </p:cNvPr>
@@ -3503,7 +3503,7 @@
           <p:cNvPr id="12" name="">
             <a:extLst xmlns:a="http://schemas.openxmlformats.org/drawingml/2006/main">
               <a:ext uri="{FF2B5EF4-FFF2-40B4-BE49-F238E27FC236}">
-                <a16:creationId xmlns:a16="http://schemas.microsoft.com/office/drawing/2014/main" id="{0E648D35-DDC6-450F-AB6C-327F71FD92BB}"/>
+                <a16:creationId xmlns:a16="http://schemas.microsoft.com/office/drawing/2014/main" id="{27240802-E5BE-4D40-AC7A-FD2EDC33C45C}"/>
               </a:ext>
             </a:extLst>
           </p:cNvPr>
@@ -3534,7 +3534,7 @@
           <p:cNvPr id="11" name="">
             <a:extLst xmlns:a="http://schemas.openxmlformats.org/drawingml/2006/main">
               <a:ext uri="{FF2B5EF4-FFF2-40B4-BE49-F238E27FC236}">
-                <a16:creationId xmlns:a16="http://schemas.microsoft.com/office/drawing/2014/main" id="{C2F76EDE-E9C9-4BAF-91CD-83CBC741D7F8}"/>
+                <a16:creationId xmlns:a16="http://schemas.microsoft.com/office/drawing/2014/main" id="{427ABEDA-9D7A-41D4-AFA3-4A59FD12EFAC}"/>
               </a:ext>
             </a:extLst>
           </p:cNvPr>
@@ -3567,7 +3567,7 @@
           <p:cNvPr id="10" name="">
             <a:extLst xmlns:a="http://schemas.openxmlformats.org/drawingml/2006/main">
               <a:ext uri="{FF2B5EF4-FFF2-40B4-BE49-F238E27FC236}">
-                <a16:creationId xmlns:a16="http://schemas.microsoft.com/office/drawing/2014/main" id="{86C4A014-6B00-4689-953A-3B77FAAC41E8}"/>
+                <a16:creationId xmlns:a16="http://schemas.microsoft.com/office/drawing/2014/main" id="{3F9C3900-2694-4BDD-9CD8-411D8AC8DE8E}"/>
               </a:ext>
             </a:extLst>
           </p:cNvPr>
@@ -3600,7 +3600,7 @@
           <p:cNvPr id="16" name="">
             <a:extLst xmlns:a="http://schemas.openxmlformats.org/drawingml/2006/main">
               <a:ext uri="{FF2B5EF4-FFF2-40B4-BE49-F238E27FC236}">
-                <a16:creationId xmlns:a16="http://schemas.microsoft.com/office/drawing/2014/main" id="{9575D181-05B1-4AC0-86B9-97F69920F039}"/>
+                <a16:creationId xmlns:a16="http://schemas.microsoft.com/office/drawing/2014/main" id="{6AC36A46-3722-4823-81AA-5261266CF7C1}"/>
               </a:ext>
             </a:extLst>
           </p:cNvPr>
@@ -3756,7 +3756,7 @@
           <p:cNvPr id="2" name="">
             <a:extLst xmlns:a="http://schemas.openxmlformats.org/drawingml/2006/main">
               <a:ext uri="{FF2B5EF4-FFF2-40B4-BE49-F238E27FC236}">
-                <a16:creationId xmlns:a16="http://schemas.microsoft.com/office/drawing/2014/main" id="{DE05A43F-757D-486A-ADC5-8405DB114758}"/>
+                <a16:creationId xmlns:a16="http://schemas.microsoft.com/office/drawing/2014/main" id="{3409F59B-4C9D-4BB1-A781-2BF65811A22D}"/>
               </a:ext>
             </a:extLst>
           </p:cNvPr>
@@ -3912,7 +3912,7 @@
           <p:cNvPr id="3" name="">
             <a:extLst xmlns:a="http://schemas.openxmlformats.org/drawingml/2006/main">
               <a:ext uri="{FF2B5EF4-FFF2-40B4-BE49-F238E27FC236}">
-                <a16:creationId xmlns:a16="http://schemas.microsoft.com/office/drawing/2014/main" id="{445CA372-1D5E-49A0-8452-25ECD5A70023}"/>
+                <a16:creationId xmlns:a16="http://schemas.microsoft.com/office/drawing/2014/main" id="{35701496-4A2D-42AC-AD3B-0302DE68B9D3}"/>
               </a:ext>
             </a:extLst>
           </p:cNvPr>
@@ -4095,7 +4095,7 @@
           <p:cNvPr id="4" name="">
             <a:extLst xmlns:a="http://schemas.openxmlformats.org/drawingml/2006/main">
               <a:ext uri="{FF2B5EF4-FFF2-40B4-BE49-F238E27FC236}">
-                <a16:creationId xmlns:a16="http://schemas.microsoft.com/office/drawing/2014/main" id="{1C67B36A-F54E-4C94-B669-16B0E80E0CB9}"/>
+                <a16:creationId xmlns:a16="http://schemas.microsoft.com/office/drawing/2014/main" id="{0E31C3A5-2A30-46FC-A87D-2140C8157423}"/>
               </a:ext>
             </a:extLst>
           </p:cNvPr>
@@ -4278,7 +4278,7 @@
           <p:cNvPr id="5" name="">
             <a:extLst xmlns:a="http://schemas.openxmlformats.org/drawingml/2006/main">
               <a:ext uri="{FF2B5EF4-FFF2-40B4-BE49-F238E27FC236}">
-                <a16:creationId xmlns:a16="http://schemas.microsoft.com/office/drawing/2014/main" id="{ACB7A3F1-CE83-4154-9EFA-F2B4BE041CE6}"/>
+                <a16:creationId xmlns:a16="http://schemas.microsoft.com/office/drawing/2014/main" id="{0B713CAE-B270-410E-B3C4-2F52AA51A7F3}"/>
               </a:ext>
             </a:extLst>
           </p:cNvPr>
@@ -4461,7 +4461,7 @@
           <p:cNvPr id="6" name="">
             <a:extLst xmlns:a="http://schemas.openxmlformats.org/drawingml/2006/main">
               <a:ext uri="{FF2B5EF4-FFF2-40B4-BE49-F238E27FC236}">
-                <a16:creationId xmlns:a16="http://schemas.microsoft.com/office/drawing/2014/main" id="{BDCED6BB-ED89-484E-B11E-E023D2452C0B}"/>
+                <a16:creationId xmlns:a16="http://schemas.microsoft.com/office/drawing/2014/main" id="{AFB21A71-BB28-4011-86F5-97C89CD02B7C}"/>
               </a:ext>
             </a:extLst>
           </p:cNvPr>
@@ -4644,7 +4644,7 @@
           <p:cNvPr id="7" name="">
             <a:extLst xmlns:a="http://schemas.openxmlformats.org/drawingml/2006/main">
               <a:ext uri="{FF2B5EF4-FFF2-40B4-BE49-F238E27FC236}">
-                <a16:creationId xmlns:a16="http://schemas.microsoft.com/office/drawing/2014/main" id="{8A76F972-F253-4C93-B7B9-C6F99A22748F}"/>
+                <a16:creationId xmlns:a16="http://schemas.microsoft.com/office/drawing/2014/main" id="{B49ADFBD-29A3-4E40-AD91-B6BD6FF6F7DC}"/>
               </a:ext>
             </a:extLst>
           </p:cNvPr>
@@ -4827,7 +4827,7 @@
           <p:cNvPr id="8" name="">
             <a:extLst xmlns:a="http://schemas.openxmlformats.org/drawingml/2006/main">
               <a:ext uri="{FF2B5EF4-FFF2-40B4-BE49-F238E27FC236}">
-                <a16:creationId xmlns:a16="http://schemas.microsoft.com/office/drawing/2014/main" id="{61D014DD-1B9D-4DD5-8ADA-9E9CD2C08B4E}"/>
+                <a16:creationId xmlns:a16="http://schemas.microsoft.com/office/drawing/2014/main" id="{E1113DE0-7AE7-44C0-95DB-C68DED310A96}"/>
               </a:ext>
             </a:extLst>
           </p:cNvPr>
@@ -5010,7 +5010,7 @@
           <p:cNvPr id="9" name="">
             <a:extLst xmlns:a="http://schemas.openxmlformats.org/drawingml/2006/main">
               <a:ext uri="{FF2B5EF4-FFF2-40B4-BE49-F238E27FC236}">
-                <a16:creationId xmlns:a16="http://schemas.microsoft.com/office/drawing/2014/main" id="{82FAF77C-59E8-4EEA-BEE5-3BB794678261}"/>
+                <a16:creationId xmlns:a16="http://schemas.microsoft.com/office/drawing/2014/main" id="{7FD93C08-7A5A-455B-B6BF-BA63F8097350}"/>
               </a:ext>
             </a:extLst>
           </p:cNvPr>
@@ -5193,7 +5193,7 @@
           <p:cNvPr id="15" name="">
             <a:extLst xmlns:a="http://schemas.openxmlformats.org/drawingml/2006/main">
               <a:ext uri="{FF2B5EF4-FFF2-40B4-BE49-F238E27FC236}">
-                <a16:creationId xmlns:a16="http://schemas.microsoft.com/office/drawing/2014/main" id="{0467A5D8-110B-439E-9057-D39906CD6645}"/>
+                <a16:creationId xmlns:a16="http://schemas.microsoft.com/office/drawing/2014/main" id="{5EA45BEB-4C70-4448-985D-963A1F61FC9B}"/>
               </a:ext>
             </a:extLst>
           </p:cNvPr>
@@ -5347,7 +5347,7 @@
     </p:spTree>
     <p:extLst>
       <p:ext uri="{BB962C8B-B14F-4D97-AF65-F5344CB8AC3E}">
-        <p14:creationId xmlns:p14="http://schemas.microsoft.com/office/powerpoint/2010/main" val="875605598"/>
+        <p14:creationId xmlns:p14="http://schemas.microsoft.com/office/powerpoint/2010/main" val="1266793460"/>
       </p:ext>
     </p:extLst>
   </p:cSld>

</xml_diff>

<commit_message>
Evaluate Bayesian timing posterior on frozen data (B5)
</commit_message>
<xml_diff>
--- a/deliverables/CycleTwin_architecture.pptx
+++ b/deliverables/CycleTwin_architecture.pptx
@@ -2,13 +2,13 @@
 <file path=ppt/presentation.xml><?xml version="1.0" encoding="utf-8"?>
 <p:presentation xmlns:p="http://schemas.openxmlformats.org/presentationml/2006/main">
   <p:sldMasterIdLst>
-    <p:sldMasterId xmlns:r="http://schemas.openxmlformats.org/officeDocument/2006/relationships" id="2147483648" r:id="Rbbede184bf654368"/>
+    <p:sldMasterId xmlns:r="http://schemas.openxmlformats.org/officeDocument/2006/relationships" id="2147483648" r:id="Rae70fa5cd9984aeb"/>
   </p:sldMasterIdLst>
   <p:notesMasterIdLst>
-    <p:notesMasterId xmlns:r="http://schemas.openxmlformats.org/officeDocument/2006/relationships" r:id="R3f8b2306841b4f54"/>
+    <p:notesMasterId xmlns:r="http://schemas.openxmlformats.org/officeDocument/2006/relationships" r:id="R3d337d70f0354e2c"/>
   </p:notesMasterIdLst>
   <p:sldIdLst>
-    <p:sldId xmlns:r="http://schemas.openxmlformats.org/officeDocument/2006/relationships" id="256" r:id="R9d9ebc75933541ae"/>
+    <p:sldId xmlns:r="http://schemas.openxmlformats.org/officeDocument/2006/relationships" id="256" r:id="Rdef8dea5fc054b46"/>
   </p:sldIdLst>
   <p:sldSz cx="12192000" cy="6858000"/>
   <p:notesSz cx="6858000" cy="9144000"/>
@@ -489,7 +489,7 @@
           <p:cNvPr id="3" name="Title">
             <a:extLst xmlns:a="http://schemas.openxmlformats.org/drawingml/2006/main">
               <a:ext uri="{FF2B5EF4-FFF2-40B4-BE49-F238E27FC236}">
-                <a16:creationId xmlns:a16="http://schemas.microsoft.com/office/drawing/2014/main" id="{A38764FC-351A-4D6C-8D50-533721638DCF}"/>
+                <a16:creationId xmlns:a16="http://schemas.microsoft.com/office/drawing/2014/main" id="{DB92622B-994D-46C7-84D2-206F38C0A76A}"/>
               </a:ext>
             </a:extLst>
           </p:cNvPr>
@@ -718,7 +718,7 @@
           <p:cNvPr id="2" name="Subtitle">
             <a:extLst xmlns:a="http://schemas.openxmlformats.org/drawingml/2006/main">
               <a:ext uri="{FF2B5EF4-FFF2-40B4-BE49-F238E27FC236}">
-                <a16:creationId xmlns:a16="http://schemas.microsoft.com/office/drawing/2014/main" id="{8A60F78A-410D-442F-AAE0-1CEFEB7AD9F6}"/>
+                <a16:creationId xmlns:a16="http://schemas.microsoft.com/office/drawing/2014/main" id="{EAE75A22-EBBF-458C-9653-E8FE4E733D15}"/>
               </a:ext>
             </a:extLst>
           </p:cNvPr>
@@ -964,7 +964,7 @@
           <p:cNvPr id="2" name="Section title">
             <a:extLst xmlns:a="http://schemas.openxmlformats.org/drawingml/2006/main">
               <a:ext uri="{FF2B5EF4-FFF2-40B4-BE49-F238E27FC236}">
-                <a16:creationId xmlns:a16="http://schemas.microsoft.com/office/drawing/2014/main" id="{3FA677C4-D82F-4717-BF20-AF7E23559273}"/>
+                <a16:creationId xmlns:a16="http://schemas.microsoft.com/office/drawing/2014/main" id="{15A6AA55-0ED2-4FC8-A0B4-55C0958061E5}"/>
               </a:ext>
             </a:extLst>
           </p:cNvPr>
@@ -1210,7 +1210,7 @@
           <p:cNvPr id="3" name="Title">
             <a:extLst xmlns:a="http://schemas.openxmlformats.org/drawingml/2006/main">
               <a:ext uri="{FF2B5EF4-FFF2-40B4-BE49-F238E27FC236}">
-                <a16:creationId xmlns:a16="http://schemas.microsoft.com/office/drawing/2014/main" id="{D913EE7A-221D-4D83-9870-D27A4F986CAC}"/>
+                <a16:creationId xmlns:a16="http://schemas.microsoft.com/office/drawing/2014/main" id="{DBC1AF23-7095-49D3-899F-7986FEA706E7}"/>
               </a:ext>
             </a:extLst>
           </p:cNvPr>
@@ -1439,7 +1439,7 @@
           <p:cNvPr id="2" name="Body">
             <a:extLst xmlns:a="http://schemas.openxmlformats.org/drawingml/2006/main">
               <a:ext uri="{FF2B5EF4-FFF2-40B4-BE49-F238E27FC236}">
-                <a16:creationId xmlns:a16="http://schemas.microsoft.com/office/drawing/2014/main" id="{4B79E89F-326E-48EE-8FEB-6168BA011285}"/>
+                <a16:creationId xmlns:a16="http://schemas.microsoft.com/office/drawing/2014/main" id="{B6E03D99-DA54-4387-A374-9E77E9423103}"/>
               </a:ext>
             </a:extLst>
           </p:cNvPr>
@@ -1685,7 +1685,7 @@
           <p:cNvPr id="4" name="Title">
             <a:extLst xmlns:a="http://schemas.openxmlformats.org/drawingml/2006/main">
               <a:ext uri="{FF2B5EF4-FFF2-40B4-BE49-F238E27FC236}">
-                <a16:creationId xmlns:a16="http://schemas.microsoft.com/office/drawing/2014/main" id="{C68D99AF-5015-43B2-8150-1FAA35AB376F}"/>
+                <a16:creationId xmlns:a16="http://schemas.microsoft.com/office/drawing/2014/main" id="{447FB8AA-89CC-4525-8093-734464B37C70}"/>
               </a:ext>
             </a:extLst>
           </p:cNvPr>
@@ -1914,7 +1914,7 @@
           <p:cNvPr id="2" name="Left column">
             <a:extLst xmlns:a="http://schemas.openxmlformats.org/drawingml/2006/main">
               <a:ext uri="{FF2B5EF4-FFF2-40B4-BE49-F238E27FC236}">
-                <a16:creationId xmlns:a16="http://schemas.microsoft.com/office/drawing/2014/main" id="{6FA0895A-34C5-4157-BA7E-132A9ED57C76}"/>
+                <a16:creationId xmlns:a16="http://schemas.microsoft.com/office/drawing/2014/main" id="{4713126F-930F-4FE7-A0AB-21B767A4F31C}"/>
               </a:ext>
             </a:extLst>
           </p:cNvPr>
@@ -2143,7 +2143,7 @@
           <p:cNvPr id="3" name="Right column">
             <a:extLst xmlns:a="http://schemas.openxmlformats.org/drawingml/2006/main">
               <a:ext uri="{FF2B5EF4-FFF2-40B4-BE49-F238E27FC236}">
-                <a16:creationId xmlns:a16="http://schemas.microsoft.com/office/drawing/2014/main" id="{AF6BC2BB-B45F-4FC4-A01C-FF52906AB519}"/>
+                <a16:creationId xmlns:a16="http://schemas.microsoft.com/office/drawing/2014/main" id="{961C1DEE-A3AF-4070-A9AC-D5F9DB736086}"/>
               </a:ext>
             </a:extLst>
           </p:cNvPr>
@@ -2389,7 +2389,7 @@
           <p:cNvPr id="3" name="Title">
             <a:extLst xmlns:a="http://schemas.openxmlformats.org/drawingml/2006/main">
               <a:ext uri="{FF2B5EF4-FFF2-40B4-BE49-F238E27FC236}">
-                <a16:creationId xmlns:a16="http://schemas.microsoft.com/office/drawing/2014/main" id="{3D359AF8-A674-48F0-99AF-13140023089C}"/>
+                <a16:creationId xmlns:a16="http://schemas.microsoft.com/office/drawing/2014/main" id="{271AA172-DFB2-4723-9576-8E5F0D2383B8}"/>
               </a:ext>
             </a:extLst>
           </p:cNvPr>
@@ -2618,7 +2618,7 @@
           <p:cNvPr id="2" name="Left column">
             <a:extLst xmlns:a="http://schemas.openxmlformats.org/drawingml/2006/main">
               <a:ext uri="{FF2B5EF4-FFF2-40B4-BE49-F238E27FC236}">
-                <a16:creationId xmlns:a16="http://schemas.microsoft.com/office/drawing/2014/main" id="{8CA73A2A-DCA9-4683-89B9-1D156C070215}"/>
+                <a16:creationId xmlns:a16="http://schemas.microsoft.com/office/drawing/2014/main" id="{B79D2D60-1212-46A7-ABF9-FB5C233B3A90}"/>
               </a:ext>
             </a:extLst>
           </p:cNvPr>
@@ -2885,12 +2885,12 @@
   </p:cSld>
   <p:clrMap bg1="lt1" tx1="dk1" bg2="lt2" tx2="dk2" accent1="accent1" accent2="accent2" accent3="accent3" accent4="accent4" accent5="accent5" accent6="accent6" hlink="hlink" folHlink="folHlink"/>
   <p:sldLayoutIdLst>
-    <p:sldLayoutId xmlns:r="http://schemas.openxmlformats.org/officeDocument/2006/relationships" id="2147483649" r:id="R2991a105a80641ca"/>
-    <p:sldLayoutId xmlns:r="http://schemas.openxmlformats.org/officeDocument/2006/relationships" id="2147483650" r:id="Rfc4e83f3b8744a5e"/>
-    <p:sldLayoutId xmlns:r="http://schemas.openxmlformats.org/officeDocument/2006/relationships" id="2147483651" r:id="Rdc8d3761dd0a4801"/>
-    <p:sldLayoutId xmlns:r="http://schemas.openxmlformats.org/officeDocument/2006/relationships" id="2147483652" r:id="R11878ba452b740d2"/>
-    <p:sldLayoutId xmlns:r="http://schemas.openxmlformats.org/officeDocument/2006/relationships" id="2147483653" r:id="R1691c55adc3e472e"/>
-    <p:sldLayoutId xmlns:r="http://schemas.openxmlformats.org/officeDocument/2006/relationships" id="2147483654" r:id="R7b82bf74242e4162"/>
+    <p:sldLayoutId xmlns:r="http://schemas.openxmlformats.org/officeDocument/2006/relationships" id="2147483649" r:id="R42192a100bd54a39"/>
+    <p:sldLayoutId xmlns:r="http://schemas.openxmlformats.org/officeDocument/2006/relationships" id="2147483650" r:id="R45be05113583489b"/>
+    <p:sldLayoutId xmlns:r="http://schemas.openxmlformats.org/officeDocument/2006/relationships" id="2147483651" r:id="Rc54cca4b04374184"/>
+    <p:sldLayoutId xmlns:r="http://schemas.openxmlformats.org/officeDocument/2006/relationships" id="2147483652" r:id="R42df9de311a54774"/>
+    <p:sldLayoutId xmlns:r="http://schemas.openxmlformats.org/officeDocument/2006/relationships" id="2147483653" r:id="R0fa7d2be04bc43de"/>
+    <p:sldLayoutId xmlns:r="http://schemas.openxmlformats.org/officeDocument/2006/relationships" id="2147483654" r:id="Ra492f456501a4309"/>
   </p:sldLayoutIdLst>
   <p:txStyles>
     <p:titleStyle>
@@ -3441,7 +3441,7 @@
           <p:cNvPr id="14" name="">
             <a:extLst xmlns:a="http://schemas.openxmlformats.org/drawingml/2006/main">
               <a:ext uri="{FF2B5EF4-FFF2-40B4-BE49-F238E27FC236}">
-                <a16:creationId xmlns:a16="http://schemas.microsoft.com/office/drawing/2014/main" id="{6D2FE2FF-4268-40BC-B9AB-2F4A5071012C}"/>
+                <a16:creationId xmlns:a16="http://schemas.microsoft.com/office/drawing/2014/main" id="{258F9FD1-7895-470A-8208-A7311A1A758F}"/>
               </a:ext>
             </a:extLst>
           </p:cNvPr>
@@ -3472,7 +3472,7 @@
           <p:cNvPr id="13" name="">
             <a:extLst xmlns:a="http://schemas.openxmlformats.org/drawingml/2006/main">
               <a:ext uri="{FF2B5EF4-FFF2-40B4-BE49-F238E27FC236}">
-                <a16:creationId xmlns:a16="http://schemas.microsoft.com/office/drawing/2014/main" id="{4F543C81-8CFE-4AD2-927F-0810B0C6FC4D}"/>
+                <a16:creationId xmlns:a16="http://schemas.microsoft.com/office/drawing/2014/main" id="{EF6567D3-EBA4-48DB-B927-D5EAD54CEDDB}"/>
               </a:ext>
             </a:extLst>
           </p:cNvPr>
@@ -3503,7 +3503,7 @@
           <p:cNvPr id="12" name="">
             <a:extLst xmlns:a="http://schemas.openxmlformats.org/drawingml/2006/main">
               <a:ext uri="{FF2B5EF4-FFF2-40B4-BE49-F238E27FC236}">
-                <a16:creationId xmlns:a16="http://schemas.microsoft.com/office/drawing/2014/main" id="{27240802-E5BE-4D40-AC7A-FD2EDC33C45C}"/>
+                <a16:creationId xmlns:a16="http://schemas.microsoft.com/office/drawing/2014/main" id="{A59C6D0E-4C2C-40C3-9201-C6CD8E195634}"/>
               </a:ext>
             </a:extLst>
           </p:cNvPr>
@@ -3534,7 +3534,7 @@
           <p:cNvPr id="11" name="">
             <a:extLst xmlns:a="http://schemas.openxmlformats.org/drawingml/2006/main">
               <a:ext uri="{FF2B5EF4-FFF2-40B4-BE49-F238E27FC236}">
-                <a16:creationId xmlns:a16="http://schemas.microsoft.com/office/drawing/2014/main" id="{427ABEDA-9D7A-41D4-AFA3-4A59FD12EFAC}"/>
+                <a16:creationId xmlns:a16="http://schemas.microsoft.com/office/drawing/2014/main" id="{279810BA-3B96-446B-849F-6C8848B4FBDE}"/>
               </a:ext>
             </a:extLst>
           </p:cNvPr>
@@ -3567,7 +3567,7 @@
           <p:cNvPr id="10" name="">
             <a:extLst xmlns:a="http://schemas.openxmlformats.org/drawingml/2006/main">
               <a:ext uri="{FF2B5EF4-FFF2-40B4-BE49-F238E27FC236}">
-                <a16:creationId xmlns:a16="http://schemas.microsoft.com/office/drawing/2014/main" id="{3F9C3900-2694-4BDD-9CD8-411D8AC8DE8E}"/>
+                <a16:creationId xmlns:a16="http://schemas.microsoft.com/office/drawing/2014/main" id="{75450357-F4B1-40C3-939B-2D98D0CB4268}"/>
               </a:ext>
             </a:extLst>
           </p:cNvPr>
@@ -3600,7 +3600,7 @@
           <p:cNvPr id="16" name="">
             <a:extLst xmlns:a="http://schemas.openxmlformats.org/drawingml/2006/main">
               <a:ext uri="{FF2B5EF4-FFF2-40B4-BE49-F238E27FC236}">
-                <a16:creationId xmlns:a16="http://schemas.microsoft.com/office/drawing/2014/main" id="{6AC36A46-3722-4823-81AA-5261266CF7C1}"/>
+                <a16:creationId xmlns:a16="http://schemas.microsoft.com/office/drawing/2014/main" id="{61579C2D-9665-4DBC-B779-911AA3D60198}"/>
               </a:ext>
             </a:extLst>
           </p:cNvPr>
@@ -3756,7 +3756,7 @@
           <p:cNvPr id="2" name="">
             <a:extLst xmlns:a="http://schemas.openxmlformats.org/drawingml/2006/main">
               <a:ext uri="{FF2B5EF4-FFF2-40B4-BE49-F238E27FC236}">
-                <a16:creationId xmlns:a16="http://schemas.microsoft.com/office/drawing/2014/main" id="{3409F59B-4C9D-4BB1-A781-2BF65811A22D}"/>
+                <a16:creationId xmlns:a16="http://schemas.microsoft.com/office/drawing/2014/main" id="{0C41B313-609C-4D79-AD17-9C72FA0A91A0}"/>
               </a:ext>
             </a:extLst>
           </p:cNvPr>
@@ -3912,7 +3912,7 @@
           <p:cNvPr id="3" name="">
             <a:extLst xmlns:a="http://schemas.openxmlformats.org/drawingml/2006/main">
               <a:ext uri="{FF2B5EF4-FFF2-40B4-BE49-F238E27FC236}">
-                <a16:creationId xmlns:a16="http://schemas.microsoft.com/office/drawing/2014/main" id="{35701496-4A2D-42AC-AD3B-0302DE68B9D3}"/>
+                <a16:creationId xmlns:a16="http://schemas.microsoft.com/office/drawing/2014/main" id="{CBF56DC1-E5CD-48C8-A89D-E4363C9677DE}"/>
               </a:ext>
             </a:extLst>
           </p:cNvPr>
@@ -4095,7 +4095,7 @@
           <p:cNvPr id="4" name="">
             <a:extLst xmlns:a="http://schemas.openxmlformats.org/drawingml/2006/main">
               <a:ext uri="{FF2B5EF4-FFF2-40B4-BE49-F238E27FC236}">
-                <a16:creationId xmlns:a16="http://schemas.microsoft.com/office/drawing/2014/main" id="{0E31C3A5-2A30-46FC-A87D-2140C8157423}"/>
+                <a16:creationId xmlns:a16="http://schemas.microsoft.com/office/drawing/2014/main" id="{EBBD0B80-8403-4AA5-9C65-92D263044B7A}"/>
               </a:ext>
             </a:extLst>
           </p:cNvPr>
@@ -4278,7 +4278,7 @@
           <p:cNvPr id="5" name="">
             <a:extLst xmlns:a="http://schemas.openxmlformats.org/drawingml/2006/main">
               <a:ext uri="{FF2B5EF4-FFF2-40B4-BE49-F238E27FC236}">
-                <a16:creationId xmlns:a16="http://schemas.microsoft.com/office/drawing/2014/main" id="{0B713CAE-B270-410E-B3C4-2F52AA51A7F3}"/>
+                <a16:creationId xmlns:a16="http://schemas.microsoft.com/office/drawing/2014/main" id="{CC5CED8C-6B0F-4101-B42E-AF7F0F130412}"/>
               </a:ext>
             </a:extLst>
           </p:cNvPr>
@@ -4461,7 +4461,7 @@
           <p:cNvPr id="6" name="">
             <a:extLst xmlns:a="http://schemas.openxmlformats.org/drawingml/2006/main">
               <a:ext uri="{FF2B5EF4-FFF2-40B4-BE49-F238E27FC236}">
-                <a16:creationId xmlns:a16="http://schemas.microsoft.com/office/drawing/2014/main" id="{AFB21A71-BB28-4011-86F5-97C89CD02B7C}"/>
+                <a16:creationId xmlns:a16="http://schemas.microsoft.com/office/drawing/2014/main" id="{7C824276-B396-4B37-935A-1A9FB8B90A02}"/>
               </a:ext>
             </a:extLst>
           </p:cNvPr>
@@ -4644,7 +4644,7 @@
           <p:cNvPr id="7" name="">
             <a:extLst xmlns:a="http://schemas.openxmlformats.org/drawingml/2006/main">
               <a:ext uri="{FF2B5EF4-FFF2-40B4-BE49-F238E27FC236}">
-                <a16:creationId xmlns:a16="http://schemas.microsoft.com/office/drawing/2014/main" id="{B49ADFBD-29A3-4E40-AD91-B6BD6FF6F7DC}"/>
+                <a16:creationId xmlns:a16="http://schemas.microsoft.com/office/drawing/2014/main" id="{CE769C7A-C92D-4FD2-A54D-F86A945F385C}"/>
               </a:ext>
             </a:extLst>
           </p:cNvPr>
@@ -4827,7 +4827,7 @@
           <p:cNvPr id="8" name="">
             <a:extLst xmlns:a="http://schemas.openxmlformats.org/drawingml/2006/main">
               <a:ext uri="{FF2B5EF4-FFF2-40B4-BE49-F238E27FC236}">
-                <a16:creationId xmlns:a16="http://schemas.microsoft.com/office/drawing/2014/main" id="{E1113DE0-7AE7-44C0-95DB-C68DED310A96}"/>
+                <a16:creationId xmlns:a16="http://schemas.microsoft.com/office/drawing/2014/main" id="{96C99E0B-DD77-4507-AC73-DAC33FF4275B}"/>
               </a:ext>
             </a:extLst>
           </p:cNvPr>
@@ -5010,7 +5010,7 @@
           <p:cNvPr id="9" name="">
             <a:extLst xmlns:a="http://schemas.openxmlformats.org/drawingml/2006/main">
               <a:ext uri="{FF2B5EF4-FFF2-40B4-BE49-F238E27FC236}">
-                <a16:creationId xmlns:a16="http://schemas.microsoft.com/office/drawing/2014/main" id="{7FD93C08-7A5A-455B-B6BF-BA63F8097350}"/>
+                <a16:creationId xmlns:a16="http://schemas.microsoft.com/office/drawing/2014/main" id="{FCB994C9-E2A9-4751-83CD-A803B7F2F3F5}"/>
               </a:ext>
             </a:extLst>
           </p:cNvPr>
@@ -5193,7 +5193,7 @@
           <p:cNvPr id="15" name="">
             <a:extLst xmlns:a="http://schemas.openxmlformats.org/drawingml/2006/main">
               <a:ext uri="{FF2B5EF4-FFF2-40B4-BE49-F238E27FC236}">
-                <a16:creationId xmlns:a16="http://schemas.microsoft.com/office/drawing/2014/main" id="{5EA45BEB-4C70-4448-985D-963A1F61FC9B}"/>
+                <a16:creationId xmlns:a16="http://schemas.microsoft.com/office/drawing/2014/main" id="{6ADC50B6-2BF6-467A-B027-813B19336617}"/>
               </a:ext>
             </a:extLst>
           </p:cNvPr>
@@ -5347,7 +5347,7 @@
     </p:spTree>
     <p:extLst>
       <p:ext uri="{BB962C8B-B14F-4D97-AF65-F5344CB8AC3E}">
-        <p14:creationId xmlns:p14="http://schemas.microsoft.com/office/powerpoint/2010/main" val="1266793460"/>
+        <p14:creationId xmlns:p14="http://schemas.microsoft.com/office/powerpoint/2010/main" val="1692237149"/>
       </p:ext>
     </p:extLst>
   </p:cSld>

</xml_diff>

<commit_message>
Add simulated assay-like extension (B6)
</commit_message>
<xml_diff>
--- a/deliverables/CycleTwin_architecture.pptx
+++ b/deliverables/CycleTwin_architecture.pptx
@@ -2,13 +2,13 @@
 <file path=ppt/presentation.xml><?xml version="1.0" encoding="utf-8"?>
 <p:presentation xmlns:p="http://schemas.openxmlformats.org/presentationml/2006/main">
   <p:sldMasterIdLst>
-    <p:sldMasterId xmlns:r="http://schemas.openxmlformats.org/officeDocument/2006/relationships" id="2147483648" r:id="Rae70fa5cd9984aeb"/>
+    <p:sldMasterId xmlns:r="http://schemas.openxmlformats.org/officeDocument/2006/relationships" id="2147483648" r:id="Rbbaa731bb7e04ed4"/>
   </p:sldMasterIdLst>
   <p:notesMasterIdLst>
-    <p:notesMasterId xmlns:r="http://schemas.openxmlformats.org/officeDocument/2006/relationships" r:id="R3d337d70f0354e2c"/>
+    <p:notesMasterId xmlns:r="http://schemas.openxmlformats.org/officeDocument/2006/relationships" r:id="Reab88ce803074734"/>
   </p:notesMasterIdLst>
   <p:sldIdLst>
-    <p:sldId xmlns:r="http://schemas.openxmlformats.org/officeDocument/2006/relationships" id="256" r:id="Rdef8dea5fc054b46"/>
+    <p:sldId xmlns:r="http://schemas.openxmlformats.org/officeDocument/2006/relationships" id="256" r:id="Rd17fbc372a2e4a6e"/>
   </p:sldIdLst>
   <p:sldSz cx="12192000" cy="6858000"/>
   <p:notesSz cx="6858000" cy="9144000"/>
@@ -489,7 +489,7 @@
           <p:cNvPr id="3" name="Title">
             <a:extLst xmlns:a="http://schemas.openxmlformats.org/drawingml/2006/main">
               <a:ext uri="{FF2B5EF4-FFF2-40B4-BE49-F238E27FC236}">
-                <a16:creationId xmlns:a16="http://schemas.microsoft.com/office/drawing/2014/main" id="{DB92622B-994D-46C7-84D2-206F38C0A76A}"/>
+                <a16:creationId xmlns:a16="http://schemas.microsoft.com/office/drawing/2014/main" id="{D9409868-1DFF-4C94-932F-4238B1D2882E}"/>
               </a:ext>
             </a:extLst>
           </p:cNvPr>
@@ -718,7 +718,7 @@
           <p:cNvPr id="2" name="Subtitle">
             <a:extLst xmlns:a="http://schemas.openxmlformats.org/drawingml/2006/main">
               <a:ext uri="{FF2B5EF4-FFF2-40B4-BE49-F238E27FC236}">
-                <a16:creationId xmlns:a16="http://schemas.microsoft.com/office/drawing/2014/main" id="{EAE75A22-EBBF-458C-9653-E8FE4E733D15}"/>
+                <a16:creationId xmlns:a16="http://schemas.microsoft.com/office/drawing/2014/main" id="{9D5D2144-46C0-4A2D-BB97-A0F1B101F39F}"/>
               </a:ext>
             </a:extLst>
           </p:cNvPr>
@@ -964,7 +964,7 @@
           <p:cNvPr id="2" name="Section title">
             <a:extLst xmlns:a="http://schemas.openxmlformats.org/drawingml/2006/main">
               <a:ext uri="{FF2B5EF4-FFF2-40B4-BE49-F238E27FC236}">
-                <a16:creationId xmlns:a16="http://schemas.microsoft.com/office/drawing/2014/main" id="{15A6AA55-0ED2-4FC8-A0B4-55C0958061E5}"/>
+                <a16:creationId xmlns:a16="http://schemas.microsoft.com/office/drawing/2014/main" id="{AE3619D5-D00E-4F4B-8C50-8368AD9AD9D7}"/>
               </a:ext>
             </a:extLst>
           </p:cNvPr>
@@ -1210,7 +1210,7 @@
           <p:cNvPr id="3" name="Title">
             <a:extLst xmlns:a="http://schemas.openxmlformats.org/drawingml/2006/main">
               <a:ext uri="{FF2B5EF4-FFF2-40B4-BE49-F238E27FC236}">
-                <a16:creationId xmlns:a16="http://schemas.microsoft.com/office/drawing/2014/main" id="{DBC1AF23-7095-49D3-899F-7986FEA706E7}"/>
+                <a16:creationId xmlns:a16="http://schemas.microsoft.com/office/drawing/2014/main" id="{77B481BB-CA1F-45F1-BED1-59FDB6301B4B}"/>
               </a:ext>
             </a:extLst>
           </p:cNvPr>
@@ -1439,7 +1439,7 @@
           <p:cNvPr id="2" name="Body">
             <a:extLst xmlns:a="http://schemas.openxmlformats.org/drawingml/2006/main">
               <a:ext uri="{FF2B5EF4-FFF2-40B4-BE49-F238E27FC236}">
-                <a16:creationId xmlns:a16="http://schemas.microsoft.com/office/drawing/2014/main" id="{B6E03D99-DA54-4387-A374-9E77E9423103}"/>
+                <a16:creationId xmlns:a16="http://schemas.microsoft.com/office/drawing/2014/main" id="{CC7A8921-FA65-40CC-816B-2C59C8FE8865}"/>
               </a:ext>
             </a:extLst>
           </p:cNvPr>
@@ -1685,7 +1685,7 @@
           <p:cNvPr id="4" name="Title">
             <a:extLst xmlns:a="http://schemas.openxmlformats.org/drawingml/2006/main">
               <a:ext uri="{FF2B5EF4-FFF2-40B4-BE49-F238E27FC236}">
-                <a16:creationId xmlns:a16="http://schemas.microsoft.com/office/drawing/2014/main" id="{447FB8AA-89CC-4525-8093-734464B37C70}"/>
+                <a16:creationId xmlns:a16="http://schemas.microsoft.com/office/drawing/2014/main" id="{9CC9B02E-22D5-44AC-B822-B110C0AA09F8}"/>
               </a:ext>
             </a:extLst>
           </p:cNvPr>
@@ -1914,7 +1914,7 @@
           <p:cNvPr id="2" name="Left column">
             <a:extLst xmlns:a="http://schemas.openxmlformats.org/drawingml/2006/main">
               <a:ext uri="{FF2B5EF4-FFF2-40B4-BE49-F238E27FC236}">
-                <a16:creationId xmlns:a16="http://schemas.microsoft.com/office/drawing/2014/main" id="{4713126F-930F-4FE7-A0AB-21B767A4F31C}"/>
+                <a16:creationId xmlns:a16="http://schemas.microsoft.com/office/drawing/2014/main" id="{211D650B-B5CC-4C4E-AE02-1CE50588FC54}"/>
               </a:ext>
             </a:extLst>
           </p:cNvPr>
@@ -2143,7 +2143,7 @@
           <p:cNvPr id="3" name="Right column">
             <a:extLst xmlns:a="http://schemas.openxmlformats.org/drawingml/2006/main">
               <a:ext uri="{FF2B5EF4-FFF2-40B4-BE49-F238E27FC236}">
-                <a16:creationId xmlns:a16="http://schemas.microsoft.com/office/drawing/2014/main" id="{961C1DEE-A3AF-4070-A9AC-D5F9DB736086}"/>
+                <a16:creationId xmlns:a16="http://schemas.microsoft.com/office/drawing/2014/main" id="{632F2F95-AA2C-4A98-9BA0-323CEEBF254E}"/>
               </a:ext>
             </a:extLst>
           </p:cNvPr>
@@ -2389,7 +2389,7 @@
           <p:cNvPr id="3" name="Title">
             <a:extLst xmlns:a="http://schemas.openxmlformats.org/drawingml/2006/main">
               <a:ext uri="{FF2B5EF4-FFF2-40B4-BE49-F238E27FC236}">
-                <a16:creationId xmlns:a16="http://schemas.microsoft.com/office/drawing/2014/main" id="{271AA172-DFB2-4723-9576-8E5F0D2383B8}"/>
+                <a16:creationId xmlns:a16="http://schemas.microsoft.com/office/drawing/2014/main" id="{DDAF5F51-6B6D-499C-8240-E0E89C268EFF}"/>
               </a:ext>
             </a:extLst>
           </p:cNvPr>
@@ -2618,7 +2618,7 @@
           <p:cNvPr id="2" name="Left column">
             <a:extLst xmlns:a="http://schemas.openxmlformats.org/drawingml/2006/main">
               <a:ext uri="{FF2B5EF4-FFF2-40B4-BE49-F238E27FC236}">
-                <a16:creationId xmlns:a16="http://schemas.microsoft.com/office/drawing/2014/main" id="{B79D2D60-1212-46A7-ABF9-FB5C233B3A90}"/>
+                <a16:creationId xmlns:a16="http://schemas.microsoft.com/office/drawing/2014/main" id="{8976B003-4D31-4BFC-89F6-5EB0A81C6568}"/>
               </a:ext>
             </a:extLst>
           </p:cNvPr>
@@ -2885,12 +2885,12 @@
   </p:cSld>
   <p:clrMap bg1="lt1" tx1="dk1" bg2="lt2" tx2="dk2" accent1="accent1" accent2="accent2" accent3="accent3" accent4="accent4" accent5="accent5" accent6="accent6" hlink="hlink" folHlink="folHlink"/>
   <p:sldLayoutIdLst>
-    <p:sldLayoutId xmlns:r="http://schemas.openxmlformats.org/officeDocument/2006/relationships" id="2147483649" r:id="R42192a100bd54a39"/>
-    <p:sldLayoutId xmlns:r="http://schemas.openxmlformats.org/officeDocument/2006/relationships" id="2147483650" r:id="R45be05113583489b"/>
-    <p:sldLayoutId xmlns:r="http://schemas.openxmlformats.org/officeDocument/2006/relationships" id="2147483651" r:id="Rc54cca4b04374184"/>
-    <p:sldLayoutId xmlns:r="http://schemas.openxmlformats.org/officeDocument/2006/relationships" id="2147483652" r:id="R42df9de311a54774"/>
-    <p:sldLayoutId xmlns:r="http://schemas.openxmlformats.org/officeDocument/2006/relationships" id="2147483653" r:id="R0fa7d2be04bc43de"/>
-    <p:sldLayoutId xmlns:r="http://schemas.openxmlformats.org/officeDocument/2006/relationships" id="2147483654" r:id="Ra492f456501a4309"/>
+    <p:sldLayoutId xmlns:r="http://schemas.openxmlformats.org/officeDocument/2006/relationships" id="2147483649" r:id="R439b1017d0e342ab"/>
+    <p:sldLayoutId xmlns:r="http://schemas.openxmlformats.org/officeDocument/2006/relationships" id="2147483650" r:id="Rf937e246e80343d7"/>
+    <p:sldLayoutId xmlns:r="http://schemas.openxmlformats.org/officeDocument/2006/relationships" id="2147483651" r:id="R04b685e25f074b62"/>
+    <p:sldLayoutId xmlns:r="http://schemas.openxmlformats.org/officeDocument/2006/relationships" id="2147483652" r:id="Rcd622b34e5f04237"/>
+    <p:sldLayoutId xmlns:r="http://schemas.openxmlformats.org/officeDocument/2006/relationships" id="2147483653" r:id="R04d0198504c54f64"/>
+    <p:sldLayoutId xmlns:r="http://schemas.openxmlformats.org/officeDocument/2006/relationships" id="2147483654" r:id="R7b0a5c14db7442aa"/>
   </p:sldLayoutIdLst>
   <p:txStyles>
     <p:titleStyle>
@@ -3441,7 +3441,7 @@
           <p:cNvPr id="14" name="">
             <a:extLst xmlns:a="http://schemas.openxmlformats.org/drawingml/2006/main">
               <a:ext uri="{FF2B5EF4-FFF2-40B4-BE49-F238E27FC236}">
-                <a16:creationId xmlns:a16="http://schemas.microsoft.com/office/drawing/2014/main" id="{258F9FD1-7895-470A-8208-A7311A1A758F}"/>
+                <a16:creationId xmlns:a16="http://schemas.microsoft.com/office/drawing/2014/main" id="{A986E577-96EE-414D-B724-E0EDAA7E6901}"/>
               </a:ext>
             </a:extLst>
           </p:cNvPr>
@@ -3472,7 +3472,7 @@
           <p:cNvPr id="13" name="">
             <a:extLst xmlns:a="http://schemas.openxmlformats.org/drawingml/2006/main">
               <a:ext uri="{FF2B5EF4-FFF2-40B4-BE49-F238E27FC236}">
-                <a16:creationId xmlns:a16="http://schemas.microsoft.com/office/drawing/2014/main" id="{EF6567D3-EBA4-48DB-B927-D5EAD54CEDDB}"/>
+                <a16:creationId xmlns:a16="http://schemas.microsoft.com/office/drawing/2014/main" id="{B6C85AE4-7682-458E-9A1B-5CB2027BA227}"/>
               </a:ext>
             </a:extLst>
           </p:cNvPr>
@@ -3503,7 +3503,7 @@
           <p:cNvPr id="12" name="">
             <a:extLst xmlns:a="http://schemas.openxmlformats.org/drawingml/2006/main">
               <a:ext uri="{FF2B5EF4-FFF2-40B4-BE49-F238E27FC236}">
-                <a16:creationId xmlns:a16="http://schemas.microsoft.com/office/drawing/2014/main" id="{A59C6D0E-4C2C-40C3-9201-C6CD8E195634}"/>
+                <a16:creationId xmlns:a16="http://schemas.microsoft.com/office/drawing/2014/main" id="{0922161F-7480-4B03-9E79-BD3D03320E0E}"/>
               </a:ext>
             </a:extLst>
           </p:cNvPr>
@@ -3534,7 +3534,7 @@
           <p:cNvPr id="11" name="">
             <a:extLst xmlns:a="http://schemas.openxmlformats.org/drawingml/2006/main">
               <a:ext uri="{FF2B5EF4-FFF2-40B4-BE49-F238E27FC236}">
-                <a16:creationId xmlns:a16="http://schemas.microsoft.com/office/drawing/2014/main" id="{279810BA-3B96-446B-849F-6C8848B4FBDE}"/>
+                <a16:creationId xmlns:a16="http://schemas.microsoft.com/office/drawing/2014/main" id="{58D81981-5103-4EF5-B02B-CDF0282FA3F5}"/>
               </a:ext>
             </a:extLst>
           </p:cNvPr>
@@ -3567,7 +3567,7 @@
           <p:cNvPr id="10" name="">
             <a:extLst xmlns:a="http://schemas.openxmlformats.org/drawingml/2006/main">
               <a:ext uri="{FF2B5EF4-FFF2-40B4-BE49-F238E27FC236}">
-                <a16:creationId xmlns:a16="http://schemas.microsoft.com/office/drawing/2014/main" id="{75450357-F4B1-40C3-939B-2D98D0CB4268}"/>
+                <a16:creationId xmlns:a16="http://schemas.microsoft.com/office/drawing/2014/main" id="{B7DA1782-D0BD-4C07-8CDF-F5EACCC93C29}"/>
               </a:ext>
             </a:extLst>
           </p:cNvPr>
@@ -3600,7 +3600,7 @@
           <p:cNvPr id="16" name="">
             <a:extLst xmlns:a="http://schemas.openxmlformats.org/drawingml/2006/main">
               <a:ext uri="{FF2B5EF4-FFF2-40B4-BE49-F238E27FC236}">
-                <a16:creationId xmlns:a16="http://schemas.microsoft.com/office/drawing/2014/main" id="{61579C2D-9665-4DBC-B779-911AA3D60198}"/>
+                <a16:creationId xmlns:a16="http://schemas.microsoft.com/office/drawing/2014/main" id="{D5CE0725-E2CF-4269-BE10-425579315865}"/>
               </a:ext>
             </a:extLst>
           </p:cNvPr>
@@ -3756,7 +3756,7 @@
           <p:cNvPr id="2" name="">
             <a:extLst xmlns:a="http://schemas.openxmlformats.org/drawingml/2006/main">
               <a:ext uri="{FF2B5EF4-FFF2-40B4-BE49-F238E27FC236}">
-                <a16:creationId xmlns:a16="http://schemas.microsoft.com/office/drawing/2014/main" id="{0C41B313-609C-4D79-AD17-9C72FA0A91A0}"/>
+                <a16:creationId xmlns:a16="http://schemas.microsoft.com/office/drawing/2014/main" id="{DAE13209-0E1D-427F-94E7-32749EF518CB}"/>
               </a:ext>
             </a:extLst>
           </p:cNvPr>
@@ -3912,7 +3912,7 @@
           <p:cNvPr id="3" name="">
             <a:extLst xmlns:a="http://schemas.openxmlformats.org/drawingml/2006/main">
               <a:ext uri="{FF2B5EF4-FFF2-40B4-BE49-F238E27FC236}">
-                <a16:creationId xmlns:a16="http://schemas.microsoft.com/office/drawing/2014/main" id="{CBF56DC1-E5CD-48C8-A89D-E4363C9677DE}"/>
+                <a16:creationId xmlns:a16="http://schemas.microsoft.com/office/drawing/2014/main" id="{68B15B66-080B-43D7-93EF-9CB8645E3E0B}"/>
               </a:ext>
             </a:extLst>
           </p:cNvPr>
@@ -4095,7 +4095,7 @@
           <p:cNvPr id="4" name="">
             <a:extLst xmlns:a="http://schemas.openxmlformats.org/drawingml/2006/main">
               <a:ext uri="{FF2B5EF4-FFF2-40B4-BE49-F238E27FC236}">
-                <a16:creationId xmlns:a16="http://schemas.microsoft.com/office/drawing/2014/main" id="{EBBD0B80-8403-4AA5-9C65-92D263044B7A}"/>
+                <a16:creationId xmlns:a16="http://schemas.microsoft.com/office/drawing/2014/main" id="{F1749150-EE08-402C-8430-162E4B5D10C1}"/>
               </a:ext>
             </a:extLst>
           </p:cNvPr>
@@ -4278,7 +4278,7 @@
           <p:cNvPr id="5" name="">
             <a:extLst xmlns:a="http://schemas.openxmlformats.org/drawingml/2006/main">
               <a:ext uri="{FF2B5EF4-FFF2-40B4-BE49-F238E27FC236}">
-                <a16:creationId xmlns:a16="http://schemas.microsoft.com/office/drawing/2014/main" id="{CC5CED8C-6B0F-4101-B42E-AF7F0F130412}"/>
+                <a16:creationId xmlns:a16="http://schemas.microsoft.com/office/drawing/2014/main" id="{B038305E-0510-4F07-8F6F-E2055BF3A803}"/>
               </a:ext>
             </a:extLst>
           </p:cNvPr>
@@ -4461,7 +4461,7 @@
           <p:cNvPr id="6" name="">
             <a:extLst xmlns:a="http://schemas.openxmlformats.org/drawingml/2006/main">
               <a:ext uri="{FF2B5EF4-FFF2-40B4-BE49-F238E27FC236}">
-                <a16:creationId xmlns:a16="http://schemas.microsoft.com/office/drawing/2014/main" id="{7C824276-B396-4B37-935A-1A9FB8B90A02}"/>
+                <a16:creationId xmlns:a16="http://schemas.microsoft.com/office/drawing/2014/main" id="{A0455A91-9603-4930-98A0-E7637BE58133}"/>
               </a:ext>
             </a:extLst>
           </p:cNvPr>
@@ -4644,7 +4644,7 @@
           <p:cNvPr id="7" name="">
             <a:extLst xmlns:a="http://schemas.openxmlformats.org/drawingml/2006/main">
               <a:ext uri="{FF2B5EF4-FFF2-40B4-BE49-F238E27FC236}">
-                <a16:creationId xmlns:a16="http://schemas.microsoft.com/office/drawing/2014/main" id="{CE769C7A-C92D-4FD2-A54D-F86A945F385C}"/>
+                <a16:creationId xmlns:a16="http://schemas.microsoft.com/office/drawing/2014/main" id="{84B06BD6-CEF7-4DA0-B98D-1C4748806DD4}"/>
               </a:ext>
             </a:extLst>
           </p:cNvPr>
@@ -4827,7 +4827,7 @@
           <p:cNvPr id="8" name="">
             <a:extLst xmlns:a="http://schemas.openxmlformats.org/drawingml/2006/main">
               <a:ext uri="{FF2B5EF4-FFF2-40B4-BE49-F238E27FC236}">
-                <a16:creationId xmlns:a16="http://schemas.microsoft.com/office/drawing/2014/main" id="{96C99E0B-DD77-4507-AC73-DAC33FF4275B}"/>
+                <a16:creationId xmlns:a16="http://schemas.microsoft.com/office/drawing/2014/main" id="{36548C94-3078-487C-B0F5-C8C10B3B23F5}"/>
               </a:ext>
             </a:extLst>
           </p:cNvPr>
@@ -5010,7 +5010,7 @@
           <p:cNvPr id="9" name="">
             <a:extLst xmlns:a="http://schemas.openxmlformats.org/drawingml/2006/main">
               <a:ext uri="{FF2B5EF4-FFF2-40B4-BE49-F238E27FC236}">
-                <a16:creationId xmlns:a16="http://schemas.microsoft.com/office/drawing/2014/main" id="{FCB994C9-E2A9-4751-83CD-A803B7F2F3F5}"/>
+                <a16:creationId xmlns:a16="http://schemas.microsoft.com/office/drawing/2014/main" id="{C2FE4AD4-37A4-47AE-9FD5-CB93DE98CA07}"/>
               </a:ext>
             </a:extLst>
           </p:cNvPr>
@@ -5193,7 +5193,7 @@
           <p:cNvPr id="15" name="">
             <a:extLst xmlns:a="http://schemas.openxmlformats.org/drawingml/2006/main">
               <a:ext uri="{FF2B5EF4-FFF2-40B4-BE49-F238E27FC236}">
-                <a16:creationId xmlns:a16="http://schemas.microsoft.com/office/drawing/2014/main" id="{6ADC50B6-2BF6-467A-B027-813B19336617}"/>
+                <a16:creationId xmlns:a16="http://schemas.microsoft.com/office/drawing/2014/main" id="{2135E5B5-B0BD-4D35-90FA-2974C3B94744}"/>
               </a:ext>
             </a:extLst>
           </p:cNvPr>
@@ -5347,7 +5347,7 @@
     </p:spTree>
     <p:extLst>
       <p:ext uri="{BB962C8B-B14F-4D97-AF65-F5344CB8AC3E}">
-        <p14:creationId xmlns:p14="http://schemas.microsoft.com/office/powerpoint/2010/main" val="1692237149"/>
+        <p14:creationId xmlns:p14="http://schemas.microsoft.com/office/powerpoint/2010/main" val="657242633"/>
       </p:ext>
     </p:extLst>
   </p:cSld>

</xml_diff>

<commit_message>
Record local persisted inference operations (B7)
</commit_message>
<xml_diff>
--- a/deliverables/CycleTwin_architecture.pptx
+++ b/deliverables/CycleTwin_architecture.pptx
@@ -2,13 +2,13 @@
 <file path=ppt/presentation.xml><?xml version="1.0" encoding="utf-8"?>
 <p:presentation xmlns:p="http://schemas.openxmlformats.org/presentationml/2006/main">
   <p:sldMasterIdLst>
-    <p:sldMasterId xmlns:r="http://schemas.openxmlformats.org/officeDocument/2006/relationships" id="2147483648" r:id="Rbbaa731bb7e04ed4"/>
+    <p:sldMasterId xmlns:r="http://schemas.openxmlformats.org/officeDocument/2006/relationships" id="2147483648" r:id="R07004ee5df0c4731"/>
   </p:sldMasterIdLst>
   <p:notesMasterIdLst>
-    <p:notesMasterId xmlns:r="http://schemas.openxmlformats.org/officeDocument/2006/relationships" r:id="Reab88ce803074734"/>
+    <p:notesMasterId xmlns:r="http://schemas.openxmlformats.org/officeDocument/2006/relationships" r:id="Rc14667d6aa694cb1"/>
   </p:notesMasterIdLst>
   <p:sldIdLst>
-    <p:sldId xmlns:r="http://schemas.openxmlformats.org/officeDocument/2006/relationships" id="256" r:id="Rd17fbc372a2e4a6e"/>
+    <p:sldId xmlns:r="http://schemas.openxmlformats.org/officeDocument/2006/relationships" id="256" r:id="R8a9e6a927d9142d0"/>
   </p:sldIdLst>
   <p:sldSz cx="12192000" cy="6858000"/>
   <p:notesSz cx="6858000" cy="9144000"/>
@@ -489,7 +489,7 @@
           <p:cNvPr id="3" name="Title">
             <a:extLst xmlns:a="http://schemas.openxmlformats.org/drawingml/2006/main">
               <a:ext uri="{FF2B5EF4-FFF2-40B4-BE49-F238E27FC236}">
-                <a16:creationId xmlns:a16="http://schemas.microsoft.com/office/drawing/2014/main" id="{D9409868-1DFF-4C94-932F-4238B1D2882E}"/>
+                <a16:creationId xmlns:a16="http://schemas.microsoft.com/office/drawing/2014/main" id="{7A0848E4-02E2-4647-8EFB-C00CF8948142}"/>
               </a:ext>
             </a:extLst>
           </p:cNvPr>
@@ -718,7 +718,7 @@
           <p:cNvPr id="2" name="Subtitle">
             <a:extLst xmlns:a="http://schemas.openxmlformats.org/drawingml/2006/main">
               <a:ext uri="{FF2B5EF4-FFF2-40B4-BE49-F238E27FC236}">
-                <a16:creationId xmlns:a16="http://schemas.microsoft.com/office/drawing/2014/main" id="{9D5D2144-46C0-4A2D-BB97-A0F1B101F39F}"/>
+                <a16:creationId xmlns:a16="http://schemas.microsoft.com/office/drawing/2014/main" id="{1799E8A2-0C11-4BF6-A74E-60B77ABFCCE0}"/>
               </a:ext>
             </a:extLst>
           </p:cNvPr>
@@ -964,7 +964,7 @@
           <p:cNvPr id="2" name="Section title">
             <a:extLst xmlns:a="http://schemas.openxmlformats.org/drawingml/2006/main">
               <a:ext uri="{FF2B5EF4-FFF2-40B4-BE49-F238E27FC236}">
-                <a16:creationId xmlns:a16="http://schemas.microsoft.com/office/drawing/2014/main" id="{AE3619D5-D00E-4F4B-8C50-8368AD9AD9D7}"/>
+                <a16:creationId xmlns:a16="http://schemas.microsoft.com/office/drawing/2014/main" id="{2B2DF751-75D5-4592-8DC3-3A28F6423BEE}"/>
               </a:ext>
             </a:extLst>
           </p:cNvPr>
@@ -1210,7 +1210,7 @@
           <p:cNvPr id="3" name="Title">
             <a:extLst xmlns:a="http://schemas.openxmlformats.org/drawingml/2006/main">
               <a:ext uri="{FF2B5EF4-FFF2-40B4-BE49-F238E27FC236}">
-                <a16:creationId xmlns:a16="http://schemas.microsoft.com/office/drawing/2014/main" id="{77B481BB-CA1F-45F1-BED1-59FDB6301B4B}"/>
+                <a16:creationId xmlns:a16="http://schemas.microsoft.com/office/drawing/2014/main" id="{7734FB36-212C-488A-8FCD-BA59E81E2AA9}"/>
               </a:ext>
             </a:extLst>
           </p:cNvPr>
@@ -1439,7 +1439,7 @@
           <p:cNvPr id="2" name="Body">
             <a:extLst xmlns:a="http://schemas.openxmlformats.org/drawingml/2006/main">
               <a:ext uri="{FF2B5EF4-FFF2-40B4-BE49-F238E27FC236}">
-                <a16:creationId xmlns:a16="http://schemas.microsoft.com/office/drawing/2014/main" id="{CC7A8921-FA65-40CC-816B-2C59C8FE8865}"/>
+                <a16:creationId xmlns:a16="http://schemas.microsoft.com/office/drawing/2014/main" id="{1CA79364-E8F3-4050-8D6A-D3C9D4EC1B9D}"/>
               </a:ext>
             </a:extLst>
           </p:cNvPr>
@@ -1685,7 +1685,7 @@
           <p:cNvPr id="4" name="Title">
             <a:extLst xmlns:a="http://schemas.openxmlformats.org/drawingml/2006/main">
               <a:ext uri="{FF2B5EF4-FFF2-40B4-BE49-F238E27FC236}">
-                <a16:creationId xmlns:a16="http://schemas.microsoft.com/office/drawing/2014/main" id="{9CC9B02E-22D5-44AC-B822-B110C0AA09F8}"/>
+                <a16:creationId xmlns:a16="http://schemas.microsoft.com/office/drawing/2014/main" id="{9EA2D202-F6B4-4123-BB84-96195EB38054}"/>
               </a:ext>
             </a:extLst>
           </p:cNvPr>
@@ -1914,7 +1914,7 @@
           <p:cNvPr id="2" name="Left column">
             <a:extLst xmlns:a="http://schemas.openxmlformats.org/drawingml/2006/main">
               <a:ext uri="{FF2B5EF4-FFF2-40B4-BE49-F238E27FC236}">
-                <a16:creationId xmlns:a16="http://schemas.microsoft.com/office/drawing/2014/main" id="{211D650B-B5CC-4C4E-AE02-1CE50588FC54}"/>
+                <a16:creationId xmlns:a16="http://schemas.microsoft.com/office/drawing/2014/main" id="{942695C0-7E47-4B74-8874-852F168CAC53}"/>
               </a:ext>
             </a:extLst>
           </p:cNvPr>
@@ -2143,7 +2143,7 @@
           <p:cNvPr id="3" name="Right column">
             <a:extLst xmlns:a="http://schemas.openxmlformats.org/drawingml/2006/main">
               <a:ext uri="{FF2B5EF4-FFF2-40B4-BE49-F238E27FC236}">
-                <a16:creationId xmlns:a16="http://schemas.microsoft.com/office/drawing/2014/main" id="{632F2F95-AA2C-4A98-9BA0-323CEEBF254E}"/>
+                <a16:creationId xmlns:a16="http://schemas.microsoft.com/office/drawing/2014/main" id="{4B8A8825-4AE6-4C31-9304-76585FF3C9A6}"/>
               </a:ext>
             </a:extLst>
           </p:cNvPr>
@@ -2389,7 +2389,7 @@
           <p:cNvPr id="3" name="Title">
             <a:extLst xmlns:a="http://schemas.openxmlformats.org/drawingml/2006/main">
               <a:ext uri="{FF2B5EF4-FFF2-40B4-BE49-F238E27FC236}">
-                <a16:creationId xmlns:a16="http://schemas.microsoft.com/office/drawing/2014/main" id="{DDAF5F51-6B6D-499C-8240-E0E89C268EFF}"/>
+                <a16:creationId xmlns:a16="http://schemas.microsoft.com/office/drawing/2014/main" id="{B1B4671F-D3F7-4584-A71C-3205E24059B7}"/>
               </a:ext>
             </a:extLst>
           </p:cNvPr>
@@ -2618,7 +2618,7 @@
           <p:cNvPr id="2" name="Left column">
             <a:extLst xmlns:a="http://schemas.openxmlformats.org/drawingml/2006/main">
               <a:ext uri="{FF2B5EF4-FFF2-40B4-BE49-F238E27FC236}">
-                <a16:creationId xmlns:a16="http://schemas.microsoft.com/office/drawing/2014/main" id="{8976B003-4D31-4BFC-89F6-5EB0A81C6568}"/>
+                <a16:creationId xmlns:a16="http://schemas.microsoft.com/office/drawing/2014/main" id="{E44E95EB-598B-4949-A606-DAC9F4F56AEC}"/>
               </a:ext>
             </a:extLst>
           </p:cNvPr>
@@ -2885,12 +2885,12 @@
   </p:cSld>
   <p:clrMap bg1="lt1" tx1="dk1" bg2="lt2" tx2="dk2" accent1="accent1" accent2="accent2" accent3="accent3" accent4="accent4" accent5="accent5" accent6="accent6" hlink="hlink" folHlink="folHlink"/>
   <p:sldLayoutIdLst>
-    <p:sldLayoutId xmlns:r="http://schemas.openxmlformats.org/officeDocument/2006/relationships" id="2147483649" r:id="R439b1017d0e342ab"/>
-    <p:sldLayoutId xmlns:r="http://schemas.openxmlformats.org/officeDocument/2006/relationships" id="2147483650" r:id="Rf937e246e80343d7"/>
-    <p:sldLayoutId xmlns:r="http://schemas.openxmlformats.org/officeDocument/2006/relationships" id="2147483651" r:id="R04b685e25f074b62"/>
-    <p:sldLayoutId xmlns:r="http://schemas.openxmlformats.org/officeDocument/2006/relationships" id="2147483652" r:id="Rcd622b34e5f04237"/>
-    <p:sldLayoutId xmlns:r="http://schemas.openxmlformats.org/officeDocument/2006/relationships" id="2147483653" r:id="R04d0198504c54f64"/>
-    <p:sldLayoutId xmlns:r="http://schemas.openxmlformats.org/officeDocument/2006/relationships" id="2147483654" r:id="R7b0a5c14db7442aa"/>
+    <p:sldLayoutId xmlns:r="http://schemas.openxmlformats.org/officeDocument/2006/relationships" id="2147483649" r:id="R6d1d6a552190429d"/>
+    <p:sldLayoutId xmlns:r="http://schemas.openxmlformats.org/officeDocument/2006/relationships" id="2147483650" r:id="Re1b82858a91046ad"/>
+    <p:sldLayoutId xmlns:r="http://schemas.openxmlformats.org/officeDocument/2006/relationships" id="2147483651" r:id="R03693753c2874d14"/>
+    <p:sldLayoutId xmlns:r="http://schemas.openxmlformats.org/officeDocument/2006/relationships" id="2147483652" r:id="R4b65e7937c1447b9"/>
+    <p:sldLayoutId xmlns:r="http://schemas.openxmlformats.org/officeDocument/2006/relationships" id="2147483653" r:id="R5df62c06aaa8420b"/>
+    <p:sldLayoutId xmlns:r="http://schemas.openxmlformats.org/officeDocument/2006/relationships" id="2147483654" r:id="R099899cd0c8e43a2"/>
   </p:sldLayoutIdLst>
   <p:txStyles>
     <p:titleStyle>
@@ -3441,7 +3441,7 @@
           <p:cNvPr id="14" name="">
             <a:extLst xmlns:a="http://schemas.openxmlformats.org/drawingml/2006/main">
               <a:ext uri="{FF2B5EF4-FFF2-40B4-BE49-F238E27FC236}">
-                <a16:creationId xmlns:a16="http://schemas.microsoft.com/office/drawing/2014/main" id="{A986E577-96EE-414D-B724-E0EDAA7E6901}"/>
+                <a16:creationId xmlns:a16="http://schemas.microsoft.com/office/drawing/2014/main" id="{2237D5D0-3555-4E4B-A971-25959C597557}"/>
               </a:ext>
             </a:extLst>
           </p:cNvPr>
@@ -3472,7 +3472,7 @@
           <p:cNvPr id="13" name="">
             <a:extLst xmlns:a="http://schemas.openxmlformats.org/drawingml/2006/main">
               <a:ext uri="{FF2B5EF4-FFF2-40B4-BE49-F238E27FC236}">
-                <a16:creationId xmlns:a16="http://schemas.microsoft.com/office/drawing/2014/main" id="{B6C85AE4-7682-458E-9A1B-5CB2027BA227}"/>
+                <a16:creationId xmlns:a16="http://schemas.microsoft.com/office/drawing/2014/main" id="{042E6D4A-AC4D-4302-97A2-6116253125D7}"/>
               </a:ext>
             </a:extLst>
           </p:cNvPr>
@@ -3503,7 +3503,7 @@
           <p:cNvPr id="12" name="">
             <a:extLst xmlns:a="http://schemas.openxmlformats.org/drawingml/2006/main">
               <a:ext uri="{FF2B5EF4-FFF2-40B4-BE49-F238E27FC236}">
-                <a16:creationId xmlns:a16="http://schemas.microsoft.com/office/drawing/2014/main" id="{0922161F-7480-4B03-9E79-BD3D03320E0E}"/>
+                <a16:creationId xmlns:a16="http://schemas.microsoft.com/office/drawing/2014/main" id="{AF347908-C692-4E74-AE57-A09B9F87857D}"/>
               </a:ext>
             </a:extLst>
           </p:cNvPr>
@@ -3534,7 +3534,7 @@
           <p:cNvPr id="11" name="">
             <a:extLst xmlns:a="http://schemas.openxmlformats.org/drawingml/2006/main">
               <a:ext uri="{FF2B5EF4-FFF2-40B4-BE49-F238E27FC236}">
-                <a16:creationId xmlns:a16="http://schemas.microsoft.com/office/drawing/2014/main" id="{58D81981-5103-4EF5-B02B-CDF0282FA3F5}"/>
+                <a16:creationId xmlns:a16="http://schemas.microsoft.com/office/drawing/2014/main" id="{C8316B6C-7847-471E-9F1B-B86A8DF49F12}"/>
               </a:ext>
             </a:extLst>
           </p:cNvPr>
@@ -3567,7 +3567,7 @@
           <p:cNvPr id="10" name="">
             <a:extLst xmlns:a="http://schemas.openxmlformats.org/drawingml/2006/main">
               <a:ext uri="{FF2B5EF4-FFF2-40B4-BE49-F238E27FC236}">
-                <a16:creationId xmlns:a16="http://schemas.microsoft.com/office/drawing/2014/main" id="{B7DA1782-D0BD-4C07-8CDF-F5EACCC93C29}"/>
+                <a16:creationId xmlns:a16="http://schemas.microsoft.com/office/drawing/2014/main" id="{9FF6EBCC-E5BE-4A65-A516-65DB0816AC96}"/>
               </a:ext>
             </a:extLst>
           </p:cNvPr>
@@ -3600,7 +3600,7 @@
           <p:cNvPr id="16" name="">
             <a:extLst xmlns:a="http://schemas.openxmlformats.org/drawingml/2006/main">
               <a:ext uri="{FF2B5EF4-FFF2-40B4-BE49-F238E27FC236}">
-                <a16:creationId xmlns:a16="http://schemas.microsoft.com/office/drawing/2014/main" id="{D5CE0725-E2CF-4269-BE10-425579315865}"/>
+                <a16:creationId xmlns:a16="http://schemas.microsoft.com/office/drawing/2014/main" id="{39E4E7E1-5109-471A-86A7-502E47785DD4}"/>
               </a:ext>
             </a:extLst>
           </p:cNvPr>
@@ -3756,7 +3756,7 @@
           <p:cNvPr id="2" name="">
             <a:extLst xmlns:a="http://schemas.openxmlformats.org/drawingml/2006/main">
               <a:ext uri="{FF2B5EF4-FFF2-40B4-BE49-F238E27FC236}">
-                <a16:creationId xmlns:a16="http://schemas.microsoft.com/office/drawing/2014/main" id="{DAE13209-0E1D-427F-94E7-32749EF518CB}"/>
+                <a16:creationId xmlns:a16="http://schemas.microsoft.com/office/drawing/2014/main" id="{1F1B1667-3A69-45B7-9EB7-89E5A7266F73}"/>
               </a:ext>
             </a:extLst>
           </p:cNvPr>
@@ -3912,7 +3912,7 @@
           <p:cNvPr id="3" name="">
             <a:extLst xmlns:a="http://schemas.openxmlformats.org/drawingml/2006/main">
               <a:ext uri="{FF2B5EF4-FFF2-40B4-BE49-F238E27FC236}">
-                <a16:creationId xmlns:a16="http://schemas.microsoft.com/office/drawing/2014/main" id="{68B15B66-080B-43D7-93EF-9CB8645E3E0B}"/>
+                <a16:creationId xmlns:a16="http://schemas.microsoft.com/office/drawing/2014/main" id="{8B959201-A223-4B18-89EB-6768477BC7F4}"/>
               </a:ext>
             </a:extLst>
           </p:cNvPr>
@@ -4095,7 +4095,7 @@
           <p:cNvPr id="4" name="">
             <a:extLst xmlns:a="http://schemas.openxmlformats.org/drawingml/2006/main">
               <a:ext uri="{FF2B5EF4-FFF2-40B4-BE49-F238E27FC236}">
-                <a16:creationId xmlns:a16="http://schemas.microsoft.com/office/drawing/2014/main" id="{F1749150-EE08-402C-8430-162E4B5D10C1}"/>
+                <a16:creationId xmlns:a16="http://schemas.microsoft.com/office/drawing/2014/main" id="{B7278497-0A96-4DEC-82FB-A3144A601C64}"/>
               </a:ext>
             </a:extLst>
           </p:cNvPr>
@@ -4278,7 +4278,7 @@
           <p:cNvPr id="5" name="">
             <a:extLst xmlns:a="http://schemas.openxmlformats.org/drawingml/2006/main">
               <a:ext uri="{FF2B5EF4-FFF2-40B4-BE49-F238E27FC236}">
-                <a16:creationId xmlns:a16="http://schemas.microsoft.com/office/drawing/2014/main" id="{B038305E-0510-4F07-8F6F-E2055BF3A803}"/>
+                <a16:creationId xmlns:a16="http://schemas.microsoft.com/office/drawing/2014/main" id="{A0000E36-0944-4271-8C5A-F4ECAEA2B0AB}"/>
               </a:ext>
             </a:extLst>
           </p:cNvPr>
@@ -4461,7 +4461,7 @@
           <p:cNvPr id="6" name="">
             <a:extLst xmlns:a="http://schemas.openxmlformats.org/drawingml/2006/main">
               <a:ext uri="{FF2B5EF4-FFF2-40B4-BE49-F238E27FC236}">
-                <a16:creationId xmlns:a16="http://schemas.microsoft.com/office/drawing/2014/main" id="{A0455A91-9603-4930-98A0-E7637BE58133}"/>
+                <a16:creationId xmlns:a16="http://schemas.microsoft.com/office/drawing/2014/main" id="{61A0348E-0EFA-436B-A1B3-610056709807}"/>
               </a:ext>
             </a:extLst>
           </p:cNvPr>
@@ -4644,7 +4644,7 @@
           <p:cNvPr id="7" name="">
             <a:extLst xmlns:a="http://schemas.openxmlformats.org/drawingml/2006/main">
               <a:ext uri="{FF2B5EF4-FFF2-40B4-BE49-F238E27FC236}">
-                <a16:creationId xmlns:a16="http://schemas.microsoft.com/office/drawing/2014/main" id="{84B06BD6-CEF7-4DA0-B98D-1C4748806DD4}"/>
+                <a16:creationId xmlns:a16="http://schemas.microsoft.com/office/drawing/2014/main" id="{B998CAEC-53F7-49AA-A2DF-074E837E296A}"/>
               </a:ext>
             </a:extLst>
           </p:cNvPr>
@@ -4827,7 +4827,7 @@
           <p:cNvPr id="8" name="">
             <a:extLst xmlns:a="http://schemas.openxmlformats.org/drawingml/2006/main">
               <a:ext uri="{FF2B5EF4-FFF2-40B4-BE49-F238E27FC236}">
-                <a16:creationId xmlns:a16="http://schemas.microsoft.com/office/drawing/2014/main" id="{36548C94-3078-487C-B0F5-C8C10B3B23F5}"/>
+                <a16:creationId xmlns:a16="http://schemas.microsoft.com/office/drawing/2014/main" id="{1030F5E8-353A-4BB1-9BEB-52791FB4AE43}"/>
               </a:ext>
             </a:extLst>
           </p:cNvPr>
@@ -5010,7 +5010,7 @@
           <p:cNvPr id="9" name="">
             <a:extLst xmlns:a="http://schemas.openxmlformats.org/drawingml/2006/main">
               <a:ext uri="{FF2B5EF4-FFF2-40B4-BE49-F238E27FC236}">
-                <a16:creationId xmlns:a16="http://schemas.microsoft.com/office/drawing/2014/main" id="{C2FE4AD4-37A4-47AE-9FD5-CB93DE98CA07}"/>
+                <a16:creationId xmlns:a16="http://schemas.microsoft.com/office/drawing/2014/main" id="{434CEAEC-24A9-4210-B721-2E28E61EEA09}"/>
               </a:ext>
             </a:extLst>
           </p:cNvPr>
@@ -5193,7 +5193,7 @@
           <p:cNvPr id="15" name="">
             <a:extLst xmlns:a="http://schemas.openxmlformats.org/drawingml/2006/main">
               <a:ext uri="{FF2B5EF4-FFF2-40B4-BE49-F238E27FC236}">
-                <a16:creationId xmlns:a16="http://schemas.microsoft.com/office/drawing/2014/main" id="{2135E5B5-B0BD-4D35-90FA-2974C3B94744}"/>
+                <a16:creationId xmlns:a16="http://schemas.microsoft.com/office/drawing/2014/main" id="{93D94160-5D47-48B5-A0D7-827F1003B9E2}"/>
               </a:ext>
             </a:extLst>
           </p:cNvPr>
@@ -5347,7 +5347,7 @@
     </p:spTree>
     <p:extLst>
       <p:ext uri="{BB962C8B-B14F-4D97-AF65-F5344CB8AC3E}">
-        <p14:creationId xmlns:p14="http://schemas.microsoft.com/office/powerpoint/2010/main" val="657242633"/>
+        <p14:creationId xmlns:p14="http://schemas.microsoft.com/office/powerpoint/2010/main" val="804261581"/>
       </p:ext>
     </p:extLst>
   </p:cSld>

</xml_diff>

<commit_message>
Report frozen conformal coverage (B8)
</commit_message>
<xml_diff>
--- a/deliverables/CycleTwin_architecture.pptx
+++ b/deliverables/CycleTwin_architecture.pptx
@@ -2,13 +2,13 @@
 <file path=ppt/presentation.xml><?xml version="1.0" encoding="utf-8"?>
 <p:presentation xmlns:p="http://schemas.openxmlformats.org/presentationml/2006/main">
   <p:sldMasterIdLst>
-    <p:sldMasterId xmlns:r="http://schemas.openxmlformats.org/officeDocument/2006/relationships" id="2147483648" r:id="R07004ee5df0c4731"/>
+    <p:sldMasterId xmlns:r="http://schemas.openxmlformats.org/officeDocument/2006/relationships" id="2147483648" r:id="R2c4d4a2d61bf467b"/>
   </p:sldMasterIdLst>
   <p:notesMasterIdLst>
-    <p:notesMasterId xmlns:r="http://schemas.openxmlformats.org/officeDocument/2006/relationships" r:id="Rc14667d6aa694cb1"/>
+    <p:notesMasterId xmlns:r="http://schemas.openxmlformats.org/officeDocument/2006/relationships" r:id="Rf7f18a86d22c4bb3"/>
   </p:notesMasterIdLst>
   <p:sldIdLst>
-    <p:sldId xmlns:r="http://schemas.openxmlformats.org/officeDocument/2006/relationships" id="256" r:id="R8a9e6a927d9142d0"/>
+    <p:sldId xmlns:r="http://schemas.openxmlformats.org/officeDocument/2006/relationships" id="256" r:id="R75245360f46e495a"/>
   </p:sldIdLst>
   <p:sldSz cx="12192000" cy="6858000"/>
   <p:notesSz cx="6858000" cy="9144000"/>
@@ -489,7 +489,7 @@
           <p:cNvPr id="3" name="Title">
             <a:extLst xmlns:a="http://schemas.openxmlformats.org/drawingml/2006/main">
               <a:ext uri="{FF2B5EF4-FFF2-40B4-BE49-F238E27FC236}">
-                <a16:creationId xmlns:a16="http://schemas.microsoft.com/office/drawing/2014/main" id="{7A0848E4-02E2-4647-8EFB-C00CF8948142}"/>
+                <a16:creationId xmlns:a16="http://schemas.microsoft.com/office/drawing/2014/main" id="{EC908894-1D86-490C-A059-34963EF0B20B}"/>
               </a:ext>
             </a:extLst>
           </p:cNvPr>
@@ -718,7 +718,7 @@
           <p:cNvPr id="2" name="Subtitle">
             <a:extLst xmlns:a="http://schemas.openxmlformats.org/drawingml/2006/main">
               <a:ext uri="{FF2B5EF4-FFF2-40B4-BE49-F238E27FC236}">
-                <a16:creationId xmlns:a16="http://schemas.microsoft.com/office/drawing/2014/main" id="{1799E8A2-0C11-4BF6-A74E-60B77ABFCCE0}"/>
+                <a16:creationId xmlns:a16="http://schemas.microsoft.com/office/drawing/2014/main" id="{F1DEFDB2-5066-4056-8B7A-11A8BF948084}"/>
               </a:ext>
             </a:extLst>
           </p:cNvPr>
@@ -964,7 +964,7 @@
           <p:cNvPr id="2" name="Section title">
             <a:extLst xmlns:a="http://schemas.openxmlformats.org/drawingml/2006/main">
               <a:ext uri="{FF2B5EF4-FFF2-40B4-BE49-F238E27FC236}">
-                <a16:creationId xmlns:a16="http://schemas.microsoft.com/office/drawing/2014/main" id="{2B2DF751-75D5-4592-8DC3-3A28F6423BEE}"/>
+                <a16:creationId xmlns:a16="http://schemas.microsoft.com/office/drawing/2014/main" id="{A4AB1A51-DF91-43FC-A704-BBA2329E9BD8}"/>
               </a:ext>
             </a:extLst>
           </p:cNvPr>
@@ -1210,7 +1210,7 @@
           <p:cNvPr id="3" name="Title">
             <a:extLst xmlns:a="http://schemas.openxmlformats.org/drawingml/2006/main">
               <a:ext uri="{FF2B5EF4-FFF2-40B4-BE49-F238E27FC236}">
-                <a16:creationId xmlns:a16="http://schemas.microsoft.com/office/drawing/2014/main" id="{7734FB36-212C-488A-8FCD-BA59E81E2AA9}"/>
+                <a16:creationId xmlns:a16="http://schemas.microsoft.com/office/drawing/2014/main" id="{D670C518-8BC7-42DF-BC17-39764622F54A}"/>
               </a:ext>
             </a:extLst>
           </p:cNvPr>
@@ -1439,7 +1439,7 @@
           <p:cNvPr id="2" name="Body">
             <a:extLst xmlns:a="http://schemas.openxmlformats.org/drawingml/2006/main">
               <a:ext uri="{FF2B5EF4-FFF2-40B4-BE49-F238E27FC236}">
-                <a16:creationId xmlns:a16="http://schemas.microsoft.com/office/drawing/2014/main" id="{1CA79364-E8F3-4050-8D6A-D3C9D4EC1B9D}"/>
+                <a16:creationId xmlns:a16="http://schemas.microsoft.com/office/drawing/2014/main" id="{5A0F8148-800D-4CC1-BB60-82556E737EAC}"/>
               </a:ext>
             </a:extLst>
           </p:cNvPr>
@@ -1685,7 +1685,7 @@
           <p:cNvPr id="4" name="Title">
             <a:extLst xmlns:a="http://schemas.openxmlformats.org/drawingml/2006/main">
               <a:ext uri="{FF2B5EF4-FFF2-40B4-BE49-F238E27FC236}">
-                <a16:creationId xmlns:a16="http://schemas.microsoft.com/office/drawing/2014/main" id="{9EA2D202-F6B4-4123-BB84-96195EB38054}"/>
+                <a16:creationId xmlns:a16="http://schemas.microsoft.com/office/drawing/2014/main" id="{B8AAF36B-4A29-46AB-B1A1-A81931B87BBE}"/>
               </a:ext>
             </a:extLst>
           </p:cNvPr>
@@ -1914,7 +1914,7 @@
           <p:cNvPr id="2" name="Left column">
             <a:extLst xmlns:a="http://schemas.openxmlformats.org/drawingml/2006/main">
               <a:ext uri="{FF2B5EF4-FFF2-40B4-BE49-F238E27FC236}">
-                <a16:creationId xmlns:a16="http://schemas.microsoft.com/office/drawing/2014/main" id="{942695C0-7E47-4B74-8874-852F168CAC53}"/>
+                <a16:creationId xmlns:a16="http://schemas.microsoft.com/office/drawing/2014/main" id="{CCDC1C89-F272-4225-8955-B1B02FC52060}"/>
               </a:ext>
             </a:extLst>
           </p:cNvPr>
@@ -2143,7 +2143,7 @@
           <p:cNvPr id="3" name="Right column">
             <a:extLst xmlns:a="http://schemas.openxmlformats.org/drawingml/2006/main">
               <a:ext uri="{FF2B5EF4-FFF2-40B4-BE49-F238E27FC236}">
-                <a16:creationId xmlns:a16="http://schemas.microsoft.com/office/drawing/2014/main" id="{4B8A8825-4AE6-4C31-9304-76585FF3C9A6}"/>
+                <a16:creationId xmlns:a16="http://schemas.microsoft.com/office/drawing/2014/main" id="{BD618839-D983-42A8-A1E3-399D81E57738}"/>
               </a:ext>
             </a:extLst>
           </p:cNvPr>
@@ -2389,7 +2389,7 @@
           <p:cNvPr id="3" name="Title">
             <a:extLst xmlns:a="http://schemas.openxmlformats.org/drawingml/2006/main">
               <a:ext uri="{FF2B5EF4-FFF2-40B4-BE49-F238E27FC236}">
-                <a16:creationId xmlns:a16="http://schemas.microsoft.com/office/drawing/2014/main" id="{B1B4671F-D3F7-4584-A71C-3205E24059B7}"/>
+                <a16:creationId xmlns:a16="http://schemas.microsoft.com/office/drawing/2014/main" id="{CBF51F84-A3D6-4932-85D5-B830DB5B8F8A}"/>
               </a:ext>
             </a:extLst>
           </p:cNvPr>
@@ -2618,7 +2618,7 @@
           <p:cNvPr id="2" name="Left column">
             <a:extLst xmlns:a="http://schemas.openxmlformats.org/drawingml/2006/main">
               <a:ext uri="{FF2B5EF4-FFF2-40B4-BE49-F238E27FC236}">
-                <a16:creationId xmlns:a16="http://schemas.microsoft.com/office/drawing/2014/main" id="{E44E95EB-598B-4949-A606-DAC9F4F56AEC}"/>
+                <a16:creationId xmlns:a16="http://schemas.microsoft.com/office/drawing/2014/main" id="{6DB9177E-24EB-42E3-A77F-87DD29595C37}"/>
               </a:ext>
             </a:extLst>
           </p:cNvPr>
@@ -2885,12 +2885,12 @@
   </p:cSld>
   <p:clrMap bg1="lt1" tx1="dk1" bg2="lt2" tx2="dk2" accent1="accent1" accent2="accent2" accent3="accent3" accent4="accent4" accent5="accent5" accent6="accent6" hlink="hlink" folHlink="folHlink"/>
   <p:sldLayoutIdLst>
-    <p:sldLayoutId xmlns:r="http://schemas.openxmlformats.org/officeDocument/2006/relationships" id="2147483649" r:id="R6d1d6a552190429d"/>
-    <p:sldLayoutId xmlns:r="http://schemas.openxmlformats.org/officeDocument/2006/relationships" id="2147483650" r:id="Re1b82858a91046ad"/>
-    <p:sldLayoutId xmlns:r="http://schemas.openxmlformats.org/officeDocument/2006/relationships" id="2147483651" r:id="R03693753c2874d14"/>
-    <p:sldLayoutId xmlns:r="http://schemas.openxmlformats.org/officeDocument/2006/relationships" id="2147483652" r:id="R4b65e7937c1447b9"/>
-    <p:sldLayoutId xmlns:r="http://schemas.openxmlformats.org/officeDocument/2006/relationships" id="2147483653" r:id="R5df62c06aaa8420b"/>
-    <p:sldLayoutId xmlns:r="http://schemas.openxmlformats.org/officeDocument/2006/relationships" id="2147483654" r:id="R099899cd0c8e43a2"/>
+    <p:sldLayoutId xmlns:r="http://schemas.openxmlformats.org/officeDocument/2006/relationships" id="2147483649" r:id="R0b32296566844b2d"/>
+    <p:sldLayoutId xmlns:r="http://schemas.openxmlformats.org/officeDocument/2006/relationships" id="2147483650" r:id="Rf80ed8fd0c2d4e34"/>
+    <p:sldLayoutId xmlns:r="http://schemas.openxmlformats.org/officeDocument/2006/relationships" id="2147483651" r:id="Rbe2a4bb456f043e8"/>
+    <p:sldLayoutId xmlns:r="http://schemas.openxmlformats.org/officeDocument/2006/relationships" id="2147483652" r:id="R91b8e806cc044e5b"/>
+    <p:sldLayoutId xmlns:r="http://schemas.openxmlformats.org/officeDocument/2006/relationships" id="2147483653" r:id="Rd849dafa938047bd"/>
+    <p:sldLayoutId xmlns:r="http://schemas.openxmlformats.org/officeDocument/2006/relationships" id="2147483654" r:id="Rf5a1ada626534f77"/>
   </p:sldLayoutIdLst>
   <p:txStyles>
     <p:titleStyle>
@@ -3441,7 +3441,7 @@
           <p:cNvPr id="14" name="">
             <a:extLst xmlns:a="http://schemas.openxmlformats.org/drawingml/2006/main">
               <a:ext uri="{FF2B5EF4-FFF2-40B4-BE49-F238E27FC236}">
-                <a16:creationId xmlns:a16="http://schemas.microsoft.com/office/drawing/2014/main" id="{2237D5D0-3555-4E4B-A971-25959C597557}"/>
+                <a16:creationId xmlns:a16="http://schemas.microsoft.com/office/drawing/2014/main" id="{23B7F7DC-3D33-4FA7-87B2-9D16F3E4BFC9}"/>
               </a:ext>
             </a:extLst>
           </p:cNvPr>
@@ -3472,7 +3472,7 @@
           <p:cNvPr id="13" name="">
             <a:extLst xmlns:a="http://schemas.openxmlformats.org/drawingml/2006/main">
               <a:ext uri="{FF2B5EF4-FFF2-40B4-BE49-F238E27FC236}">
-                <a16:creationId xmlns:a16="http://schemas.microsoft.com/office/drawing/2014/main" id="{042E6D4A-AC4D-4302-97A2-6116253125D7}"/>
+                <a16:creationId xmlns:a16="http://schemas.microsoft.com/office/drawing/2014/main" id="{E7F8343C-9B97-48E5-A387-25BA2844851E}"/>
               </a:ext>
             </a:extLst>
           </p:cNvPr>
@@ -3503,7 +3503,7 @@
           <p:cNvPr id="12" name="">
             <a:extLst xmlns:a="http://schemas.openxmlformats.org/drawingml/2006/main">
               <a:ext uri="{FF2B5EF4-FFF2-40B4-BE49-F238E27FC236}">
-                <a16:creationId xmlns:a16="http://schemas.microsoft.com/office/drawing/2014/main" id="{AF347908-C692-4E74-AE57-A09B9F87857D}"/>
+                <a16:creationId xmlns:a16="http://schemas.microsoft.com/office/drawing/2014/main" id="{D6F31B72-5715-4E0D-8A21-B367CAEDA7E1}"/>
               </a:ext>
             </a:extLst>
           </p:cNvPr>
@@ -3534,7 +3534,7 @@
           <p:cNvPr id="11" name="">
             <a:extLst xmlns:a="http://schemas.openxmlformats.org/drawingml/2006/main">
               <a:ext uri="{FF2B5EF4-FFF2-40B4-BE49-F238E27FC236}">
-                <a16:creationId xmlns:a16="http://schemas.microsoft.com/office/drawing/2014/main" id="{C8316B6C-7847-471E-9F1B-B86A8DF49F12}"/>
+                <a16:creationId xmlns:a16="http://schemas.microsoft.com/office/drawing/2014/main" id="{5EB5E786-AF4E-4290-8EE8-228767C67B90}"/>
               </a:ext>
             </a:extLst>
           </p:cNvPr>
@@ -3567,7 +3567,7 @@
           <p:cNvPr id="10" name="">
             <a:extLst xmlns:a="http://schemas.openxmlformats.org/drawingml/2006/main">
               <a:ext uri="{FF2B5EF4-FFF2-40B4-BE49-F238E27FC236}">
-                <a16:creationId xmlns:a16="http://schemas.microsoft.com/office/drawing/2014/main" id="{9FF6EBCC-E5BE-4A65-A516-65DB0816AC96}"/>
+                <a16:creationId xmlns:a16="http://schemas.microsoft.com/office/drawing/2014/main" id="{5DB5631F-91D4-4B81-9AB8-2877E269C76F}"/>
               </a:ext>
             </a:extLst>
           </p:cNvPr>
@@ -3600,7 +3600,7 @@
           <p:cNvPr id="16" name="">
             <a:extLst xmlns:a="http://schemas.openxmlformats.org/drawingml/2006/main">
               <a:ext uri="{FF2B5EF4-FFF2-40B4-BE49-F238E27FC236}">
-                <a16:creationId xmlns:a16="http://schemas.microsoft.com/office/drawing/2014/main" id="{39E4E7E1-5109-471A-86A7-502E47785DD4}"/>
+                <a16:creationId xmlns:a16="http://schemas.microsoft.com/office/drawing/2014/main" id="{10E62164-2672-420E-86AD-3796FFC28F84}"/>
               </a:ext>
             </a:extLst>
           </p:cNvPr>
@@ -3756,7 +3756,7 @@
           <p:cNvPr id="2" name="">
             <a:extLst xmlns:a="http://schemas.openxmlformats.org/drawingml/2006/main">
               <a:ext uri="{FF2B5EF4-FFF2-40B4-BE49-F238E27FC236}">
-                <a16:creationId xmlns:a16="http://schemas.microsoft.com/office/drawing/2014/main" id="{1F1B1667-3A69-45B7-9EB7-89E5A7266F73}"/>
+                <a16:creationId xmlns:a16="http://schemas.microsoft.com/office/drawing/2014/main" id="{FB2FA589-ED90-4470-A877-A84220705B6A}"/>
               </a:ext>
             </a:extLst>
           </p:cNvPr>
@@ -3912,7 +3912,7 @@
           <p:cNvPr id="3" name="">
             <a:extLst xmlns:a="http://schemas.openxmlformats.org/drawingml/2006/main">
               <a:ext uri="{FF2B5EF4-FFF2-40B4-BE49-F238E27FC236}">
-                <a16:creationId xmlns:a16="http://schemas.microsoft.com/office/drawing/2014/main" id="{8B959201-A223-4B18-89EB-6768477BC7F4}"/>
+                <a16:creationId xmlns:a16="http://schemas.microsoft.com/office/drawing/2014/main" id="{C4B58250-ABB8-4DF2-9D5D-D9DCF704B7C3}"/>
               </a:ext>
             </a:extLst>
           </p:cNvPr>
@@ -4095,7 +4095,7 @@
           <p:cNvPr id="4" name="">
             <a:extLst xmlns:a="http://schemas.openxmlformats.org/drawingml/2006/main">
               <a:ext uri="{FF2B5EF4-FFF2-40B4-BE49-F238E27FC236}">
-                <a16:creationId xmlns:a16="http://schemas.microsoft.com/office/drawing/2014/main" id="{B7278497-0A96-4DEC-82FB-A3144A601C64}"/>
+                <a16:creationId xmlns:a16="http://schemas.microsoft.com/office/drawing/2014/main" id="{82FF84BB-3C7F-4212-B614-5E29E084B05D}"/>
               </a:ext>
             </a:extLst>
           </p:cNvPr>
@@ -4278,7 +4278,7 @@
           <p:cNvPr id="5" name="">
             <a:extLst xmlns:a="http://schemas.openxmlformats.org/drawingml/2006/main">
               <a:ext uri="{FF2B5EF4-FFF2-40B4-BE49-F238E27FC236}">
-                <a16:creationId xmlns:a16="http://schemas.microsoft.com/office/drawing/2014/main" id="{A0000E36-0944-4271-8C5A-F4ECAEA2B0AB}"/>
+                <a16:creationId xmlns:a16="http://schemas.microsoft.com/office/drawing/2014/main" id="{9252FE47-C144-4855-880B-A9704B7F5095}"/>
               </a:ext>
             </a:extLst>
           </p:cNvPr>
@@ -4461,7 +4461,7 @@
           <p:cNvPr id="6" name="">
             <a:extLst xmlns:a="http://schemas.openxmlformats.org/drawingml/2006/main">
               <a:ext uri="{FF2B5EF4-FFF2-40B4-BE49-F238E27FC236}">
-                <a16:creationId xmlns:a16="http://schemas.microsoft.com/office/drawing/2014/main" id="{61A0348E-0EFA-436B-A1B3-610056709807}"/>
+                <a16:creationId xmlns:a16="http://schemas.microsoft.com/office/drawing/2014/main" id="{8FBCF2DF-052C-4426-B68C-6BF6B95DC78D}"/>
               </a:ext>
             </a:extLst>
           </p:cNvPr>
@@ -4644,7 +4644,7 @@
           <p:cNvPr id="7" name="">
             <a:extLst xmlns:a="http://schemas.openxmlformats.org/drawingml/2006/main">
               <a:ext uri="{FF2B5EF4-FFF2-40B4-BE49-F238E27FC236}">
-                <a16:creationId xmlns:a16="http://schemas.microsoft.com/office/drawing/2014/main" id="{B998CAEC-53F7-49AA-A2DF-074E837E296A}"/>
+                <a16:creationId xmlns:a16="http://schemas.microsoft.com/office/drawing/2014/main" id="{01AFACA6-9946-4242-BA9C-2D59EB8128DC}"/>
               </a:ext>
             </a:extLst>
           </p:cNvPr>
@@ -4827,7 +4827,7 @@
           <p:cNvPr id="8" name="">
             <a:extLst xmlns:a="http://schemas.openxmlformats.org/drawingml/2006/main">
               <a:ext uri="{FF2B5EF4-FFF2-40B4-BE49-F238E27FC236}">
-                <a16:creationId xmlns:a16="http://schemas.microsoft.com/office/drawing/2014/main" id="{1030F5E8-353A-4BB1-9BEB-52791FB4AE43}"/>
+                <a16:creationId xmlns:a16="http://schemas.microsoft.com/office/drawing/2014/main" id="{7F3E6DCB-1DC1-486C-A327-385648EF5725}"/>
               </a:ext>
             </a:extLst>
           </p:cNvPr>
@@ -5010,7 +5010,7 @@
           <p:cNvPr id="9" name="">
             <a:extLst xmlns:a="http://schemas.openxmlformats.org/drawingml/2006/main">
               <a:ext uri="{FF2B5EF4-FFF2-40B4-BE49-F238E27FC236}">
-                <a16:creationId xmlns:a16="http://schemas.microsoft.com/office/drawing/2014/main" id="{434CEAEC-24A9-4210-B721-2E28E61EEA09}"/>
+                <a16:creationId xmlns:a16="http://schemas.microsoft.com/office/drawing/2014/main" id="{B424CBF3-D18F-40E6-A85C-AE06B88E4486}"/>
               </a:ext>
             </a:extLst>
           </p:cNvPr>
@@ -5193,7 +5193,7 @@
           <p:cNvPr id="15" name="">
             <a:extLst xmlns:a="http://schemas.openxmlformats.org/drawingml/2006/main">
               <a:ext uri="{FF2B5EF4-FFF2-40B4-BE49-F238E27FC236}">
-                <a16:creationId xmlns:a16="http://schemas.microsoft.com/office/drawing/2014/main" id="{93D94160-5D47-48B5-A0D7-827F1003B9E2}"/>
+                <a16:creationId xmlns:a16="http://schemas.microsoft.com/office/drawing/2014/main" id="{123F5800-3BB0-42D4-8DA9-16786E59E424}"/>
               </a:ext>
             </a:extLst>
           </p:cNvPr>
@@ -5347,7 +5347,7 @@
     </p:spTree>
     <p:extLst>
       <p:ext uri="{BB962C8B-B14F-4D97-AF65-F5344CB8AC3E}">
-        <p14:creationId xmlns:p14="http://schemas.microsoft.com/office/powerpoint/2010/main" val="804261581"/>
+        <p14:creationId xmlns:p14="http://schemas.microsoft.com/office/powerpoint/2010/main" val="637863061"/>
       </p:ext>
     </p:extLst>
   </p:cSld>

</xml_diff>

<commit_message>
Synchronize final evidence documentation
</commit_message>
<xml_diff>
--- a/deliverables/CycleTwin_architecture.pptx
+++ b/deliverables/CycleTwin_architecture.pptx
@@ -2,13 +2,13 @@
 <file path=ppt/presentation.xml><?xml version="1.0" encoding="utf-8"?>
 <p:presentation xmlns:p="http://schemas.openxmlformats.org/presentationml/2006/main">
   <p:sldMasterIdLst>
-    <p:sldMasterId xmlns:r="http://schemas.openxmlformats.org/officeDocument/2006/relationships" id="2147483648" r:id="R2c4d4a2d61bf467b"/>
+    <p:sldMasterId xmlns:r="http://schemas.openxmlformats.org/officeDocument/2006/relationships" id="2147483648" r:id="R4238572c23914cbd"/>
   </p:sldMasterIdLst>
   <p:notesMasterIdLst>
-    <p:notesMasterId xmlns:r="http://schemas.openxmlformats.org/officeDocument/2006/relationships" r:id="Rf7f18a86d22c4bb3"/>
+    <p:notesMasterId xmlns:r="http://schemas.openxmlformats.org/officeDocument/2006/relationships" r:id="Rb8209ce889b448f7"/>
   </p:notesMasterIdLst>
   <p:sldIdLst>
-    <p:sldId xmlns:r="http://schemas.openxmlformats.org/officeDocument/2006/relationships" id="256" r:id="R75245360f46e495a"/>
+    <p:sldId xmlns:r="http://schemas.openxmlformats.org/officeDocument/2006/relationships" id="256" r:id="R923f6e6baa5b44d5"/>
   </p:sldIdLst>
   <p:sldSz cx="12192000" cy="6858000"/>
   <p:notesSz cx="6858000" cy="9144000"/>
@@ -489,7 +489,7 @@
           <p:cNvPr id="3" name="Title">
             <a:extLst xmlns:a="http://schemas.openxmlformats.org/drawingml/2006/main">
               <a:ext uri="{FF2B5EF4-FFF2-40B4-BE49-F238E27FC236}">
-                <a16:creationId xmlns:a16="http://schemas.microsoft.com/office/drawing/2014/main" id="{EC908894-1D86-490C-A059-34963EF0B20B}"/>
+                <a16:creationId xmlns:a16="http://schemas.microsoft.com/office/drawing/2014/main" id="{0C58B712-8D68-43AD-B54A-EAE71CD59BD5}"/>
               </a:ext>
             </a:extLst>
           </p:cNvPr>
@@ -718,7 +718,7 @@
           <p:cNvPr id="2" name="Subtitle">
             <a:extLst xmlns:a="http://schemas.openxmlformats.org/drawingml/2006/main">
               <a:ext uri="{FF2B5EF4-FFF2-40B4-BE49-F238E27FC236}">
-                <a16:creationId xmlns:a16="http://schemas.microsoft.com/office/drawing/2014/main" id="{F1DEFDB2-5066-4056-8B7A-11A8BF948084}"/>
+                <a16:creationId xmlns:a16="http://schemas.microsoft.com/office/drawing/2014/main" id="{44B8E436-16BD-4A85-91DA-269E1BC49F8E}"/>
               </a:ext>
             </a:extLst>
           </p:cNvPr>
@@ -964,7 +964,7 @@
           <p:cNvPr id="2" name="Section title">
             <a:extLst xmlns:a="http://schemas.openxmlformats.org/drawingml/2006/main">
               <a:ext uri="{FF2B5EF4-FFF2-40B4-BE49-F238E27FC236}">
-                <a16:creationId xmlns:a16="http://schemas.microsoft.com/office/drawing/2014/main" id="{A4AB1A51-DF91-43FC-A704-BBA2329E9BD8}"/>
+                <a16:creationId xmlns:a16="http://schemas.microsoft.com/office/drawing/2014/main" id="{280D5A77-7377-4EB7-83D5-21DED51A5D36}"/>
               </a:ext>
             </a:extLst>
           </p:cNvPr>
@@ -1210,7 +1210,7 @@
           <p:cNvPr id="3" name="Title">
             <a:extLst xmlns:a="http://schemas.openxmlformats.org/drawingml/2006/main">
               <a:ext uri="{FF2B5EF4-FFF2-40B4-BE49-F238E27FC236}">
-                <a16:creationId xmlns:a16="http://schemas.microsoft.com/office/drawing/2014/main" id="{D670C518-8BC7-42DF-BC17-39764622F54A}"/>
+                <a16:creationId xmlns:a16="http://schemas.microsoft.com/office/drawing/2014/main" id="{40486ED9-B89B-45B0-BBC4-6A79D973221A}"/>
               </a:ext>
             </a:extLst>
           </p:cNvPr>
@@ -1439,7 +1439,7 @@
           <p:cNvPr id="2" name="Body">
             <a:extLst xmlns:a="http://schemas.openxmlformats.org/drawingml/2006/main">
               <a:ext uri="{FF2B5EF4-FFF2-40B4-BE49-F238E27FC236}">
-                <a16:creationId xmlns:a16="http://schemas.microsoft.com/office/drawing/2014/main" id="{5A0F8148-800D-4CC1-BB60-82556E737EAC}"/>
+                <a16:creationId xmlns:a16="http://schemas.microsoft.com/office/drawing/2014/main" id="{9B5ADB82-3840-441B-A082-1B65C8795813}"/>
               </a:ext>
             </a:extLst>
           </p:cNvPr>
@@ -1685,7 +1685,7 @@
           <p:cNvPr id="4" name="Title">
             <a:extLst xmlns:a="http://schemas.openxmlformats.org/drawingml/2006/main">
               <a:ext uri="{FF2B5EF4-FFF2-40B4-BE49-F238E27FC236}">
-                <a16:creationId xmlns:a16="http://schemas.microsoft.com/office/drawing/2014/main" id="{B8AAF36B-4A29-46AB-B1A1-A81931B87BBE}"/>
+                <a16:creationId xmlns:a16="http://schemas.microsoft.com/office/drawing/2014/main" id="{2EA92A03-E38A-4E80-B06C-6D272DB13C44}"/>
               </a:ext>
             </a:extLst>
           </p:cNvPr>
@@ -1914,7 +1914,7 @@
           <p:cNvPr id="2" name="Left column">
             <a:extLst xmlns:a="http://schemas.openxmlformats.org/drawingml/2006/main">
               <a:ext uri="{FF2B5EF4-FFF2-40B4-BE49-F238E27FC236}">
-                <a16:creationId xmlns:a16="http://schemas.microsoft.com/office/drawing/2014/main" id="{CCDC1C89-F272-4225-8955-B1B02FC52060}"/>
+                <a16:creationId xmlns:a16="http://schemas.microsoft.com/office/drawing/2014/main" id="{4F101EFA-08A0-4610-8273-DFF8E6233BE3}"/>
               </a:ext>
             </a:extLst>
           </p:cNvPr>
@@ -2143,7 +2143,7 @@
           <p:cNvPr id="3" name="Right column">
             <a:extLst xmlns:a="http://schemas.openxmlformats.org/drawingml/2006/main">
               <a:ext uri="{FF2B5EF4-FFF2-40B4-BE49-F238E27FC236}">
-                <a16:creationId xmlns:a16="http://schemas.microsoft.com/office/drawing/2014/main" id="{BD618839-D983-42A8-A1E3-399D81E57738}"/>
+                <a16:creationId xmlns:a16="http://schemas.microsoft.com/office/drawing/2014/main" id="{55C3A721-BC9A-4FBC-98C5-BD798E5EE795}"/>
               </a:ext>
             </a:extLst>
           </p:cNvPr>
@@ -2389,7 +2389,7 @@
           <p:cNvPr id="3" name="Title">
             <a:extLst xmlns:a="http://schemas.openxmlformats.org/drawingml/2006/main">
               <a:ext uri="{FF2B5EF4-FFF2-40B4-BE49-F238E27FC236}">
-                <a16:creationId xmlns:a16="http://schemas.microsoft.com/office/drawing/2014/main" id="{CBF51F84-A3D6-4932-85D5-B830DB5B8F8A}"/>
+                <a16:creationId xmlns:a16="http://schemas.microsoft.com/office/drawing/2014/main" id="{909C67A2-AAEA-4579-B5F4-B805D994F271}"/>
               </a:ext>
             </a:extLst>
           </p:cNvPr>
@@ -2618,7 +2618,7 @@
           <p:cNvPr id="2" name="Left column">
             <a:extLst xmlns:a="http://schemas.openxmlformats.org/drawingml/2006/main">
               <a:ext uri="{FF2B5EF4-FFF2-40B4-BE49-F238E27FC236}">
-                <a16:creationId xmlns:a16="http://schemas.microsoft.com/office/drawing/2014/main" id="{6DB9177E-24EB-42E3-A77F-87DD29595C37}"/>
+                <a16:creationId xmlns:a16="http://schemas.microsoft.com/office/drawing/2014/main" id="{05071BEA-1AB4-4130-98D0-2C9A9F5552C7}"/>
               </a:ext>
             </a:extLst>
           </p:cNvPr>
@@ -2885,12 +2885,12 @@
   </p:cSld>
   <p:clrMap bg1="lt1" tx1="dk1" bg2="lt2" tx2="dk2" accent1="accent1" accent2="accent2" accent3="accent3" accent4="accent4" accent5="accent5" accent6="accent6" hlink="hlink" folHlink="folHlink"/>
   <p:sldLayoutIdLst>
-    <p:sldLayoutId xmlns:r="http://schemas.openxmlformats.org/officeDocument/2006/relationships" id="2147483649" r:id="R0b32296566844b2d"/>
-    <p:sldLayoutId xmlns:r="http://schemas.openxmlformats.org/officeDocument/2006/relationships" id="2147483650" r:id="Rf80ed8fd0c2d4e34"/>
-    <p:sldLayoutId xmlns:r="http://schemas.openxmlformats.org/officeDocument/2006/relationships" id="2147483651" r:id="Rbe2a4bb456f043e8"/>
-    <p:sldLayoutId xmlns:r="http://schemas.openxmlformats.org/officeDocument/2006/relationships" id="2147483652" r:id="R91b8e806cc044e5b"/>
-    <p:sldLayoutId xmlns:r="http://schemas.openxmlformats.org/officeDocument/2006/relationships" id="2147483653" r:id="Rd849dafa938047bd"/>
-    <p:sldLayoutId xmlns:r="http://schemas.openxmlformats.org/officeDocument/2006/relationships" id="2147483654" r:id="Rf5a1ada626534f77"/>
+    <p:sldLayoutId xmlns:r="http://schemas.openxmlformats.org/officeDocument/2006/relationships" id="2147483649" r:id="R8f9a11f207c74e76"/>
+    <p:sldLayoutId xmlns:r="http://schemas.openxmlformats.org/officeDocument/2006/relationships" id="2147483650" r:id="R2e14467c341e4cd0"/>
+    <p:sldLayoutId xmlns:r="http://schemas.openxmlformats.org/officeDocument/2006/relationships" id="2147483651" r:id="R6f07ebe2c6b3424a"/>
+    <p:sldLayoutId xmlns:r="http://schemas.openxmlformats.org/officeDocument/2006/relationships" id="2147483652" r:id="Rff76b4b151e748bc"/>
+    <p:sldLayoutId xmlns:r="http://schemas.openxmlformats.org/officeDocument/2006/relationships" id="2147483653" r:id="R195e12b1b75841b9"/>
+    <p:sldLayoutId xmlns:r="http://schemas.openxmlformats.org/officeDocument/2006/relationships" id="2147483654" r:id="R66cc102819134bfa"/>
   </p:sldLayoutIdLst>
   <p:txStyles>
     <p:titleStyle>
@@ -3441,7 +3441,7 @@
           <p:cNvPr id="14" name="">
             <a:extLst xmlns:a="http://schemas.openxmlformats.org/drawingml/2006/main">
               <a:ext uri="{FF2B5EF4-FFF2-40B4-BE49-F238E27FC236}">
-                <a16:creationId xmlns:a16="http://schemas.microsoft.com/office/drawing/2014/main" id="{23B7F7DC-3D33-4FA7-87B2-9D16F3E4BFC9}"/>
+                <a16:creationId xmlns:a16="http://schemas.microsoft.com/office/drawing/2014/main" id="{A9B9186F-1B64-4C8D-AC7B-1C6A22D24E5A}"/>
               </a:ext>
             </a:extLst>
           </p:cNvPr>
@@ -3472,7 +3472,7 @@
           <p:cNvPr id="13" name="">
             <a:extLst xmlns:a="http://schemas.openxmlformats.org/drawingml/2006/main">
               <a:ext uri="{FF2B5EF4-FFF2-40B4-BE49-F238E27FC236}">
-                <a16:creationId xmlns:a16="http://schemas.microsoft.com/office/drawing/2014/main" id="{E7F8343C-9B97-48E5-A387-25BA2844851E}"/>
+                <a16:creationId xmlns:a16="http://schemas.microsoft.com/office/drawing/2014/main" id="{0E320303-DEAB-4DD9-9C79-5D08F7B11695}"/>
               </a:ext>
             </a:extLst>
           </p:cNvPr>
@@ -3503,7 +3503,7 @@
           <p:cNvPr id="12" name="">
             <a:extLst xmlns:a="http://schemas.openxmlformats.org/drawingml/2006/main">
               <a:ext uri="{FF2B5EF4-FFF2-40B4-BE49-F238E27FC236}">
-                <a16:creationId xmlns:a16="http://schemas.microsoft.com/office/drawing/2014/main" id="{D6F31B72-5715-4E0D-8A21-B367CAEDA7E1}"/>
+                <a16:creationId xmlns:a16="http://schemas.microsoft.com/office/drawing/2014/main" id="{FAB8437B-BF30-4623-BD6F-A48591C2DC34}"/>
               </a:ext>
             </a:extLst>
           </p:cNvPr>
@@ -3534,7 +3534,7 @@
           <p:cNvPr id="11" name="">
             <a:extLst xmlns:a="http://schemas.openxmlformats.org/drawingml/2006/main">
               <a:ext uri="{FF2B5EF4-FFF2-40B4-BE49-F238E27FC236}">
-                <a16:creationId xmlns:a16="http://schemas.microsoft.com/office/drawing/2014/main" id="{5EB5E786-AF4E-4290-8EE8-228767C67B90}"/>
+                <a16:creationId xmlns:a16="http://schemas.microsoft.com/office/drawing/2014/main" id="{0996511D-F447-4235-9369-D8A276C4CC0F}"/>
               </a:ext>
             </a:extLst>
           </p:cNvPr>
@@ -3567,7 +3567,7 @@
           <p:cNvPr id="10" name="">
             <a:extLst xmlns:a="http://schemas.openxmlformats.org/drawingml/2006/main">
               <a:ext uri="{FF2B5EF4-FFF2-40B4-BE49-F238E27FC236}">
-                <a16:creationId xmlns:a16="http://schemas.microsoft.com/office/drawing/2014/main" id="{5DB5631F-91D4-4B81-9AB8-2877E269C76F}"/>
+                <a16:creationId xmlns:a16="http://schemas.microsoft.com/office/drawing/2014/main" id="{9F7FCF44-44F6-4572-BFF4-41C67896690D}"/>
               </a:ext>
             </a:extLst>
           </p:cNvPr>
@@ -3600,7 +3600,7 @@
           <p:cNvPr id="16" name="">
             <a:extLst xmlns:a="http://schemas.openxmlformats.org/drawingml/2006/main">
               <a:ext uri="{FF2B5EF4-FFF2-40B4-BE49-F238E27FC236}">
-                <a16:creationId xmlns:a16="http://schemas.microsoft.com/office/drawing/2014/main" id="{10E62164-2672-420E-86AD-3796FFC28F84}"/>
+                <a16:creationId xmlns:a16="http://schemas.microsoft.com/office/drawing/2014/main" id="{CBA6E173-15BD-4B87-9A32-090DCEA19890}"/>
               </a:ext>
             </a:extLst>
           </p:cNvPr>
@@ -3756,7 +3756,7 @@
           <p:cNvPr id="2" name="">
             <a:extLst xmlns:a="http://schemas.openxmlformats.org/drawingml/2006/main">
               <a:ext uri="{FF2B5EF4-FFF2-40B4-BE49-F238E27FC236}">
-                <a16:creationId xmlns:a16="http://schemas.microsoft.com/office/drawing/2014/main" id="{FB2FA589-ED90-4470-A877-A84220705B6A}"/>
+                <a16:creationId xmlns:a16="http://schemas.microsoft.com/office/drawing/2014/main" id="{56A20044-508C-4B14-84A2-EDAA6647B325}"/>
               </a:ext>
             </a:extLst>
           </p:cNvPr>
@@ -3912,7 +3912,7 @@
           <p:cNvPr id="3" name="">
             <a:extLst xmlns:a="http://schemas.openxmlformats.org/drawingml/2006/main">
               <a:ext uri="{FF2B5EF4-FFF2-40B4-BE49-F238E27FC236}">
-                <a16:creationId xmlns:a16="http://schemas.microsoft.com/office/drawing/2014/main" id="{C4B58250-ABB8-4DF2-9D5D-D9DCF704B7C3}"/>
+                <a16:creationId xmlns:a16="http://schemas.microsoft.com/office/drawing/2014/main" id="{B8F7CA2F-DACC-491A-ABC2-2686E834EF98}"/>
               </a:ext>
             </a:extLst>
           </p:cNvPr>
@@ -4095,7 +4095,7 @@
           <p:cNvPr id="4" name="">
             <a:extLst xmlns:a="http://schemas.openxmlformats.org/drawingml/2006/main">
               <a:ext uri="{FF2B5EF4-FFF2-40B4-BE49-F238E27FC236}">
-                <a16:creationId xmlns:a16="http://schemas.microsoft.com/office/drawing/2014/main" id="{82FF84BB-3C7F-4212-B614-5E29E084B05D}"/>
+                <a16:creationId xmlns:a16="http://schemas.microsoft.com/office/drawing/2014/main" id="{18ABBD26-E4E7-4AF6-A393-5905DA542DF7}"/>
               </a:ext>
             </a:extLst>
           </p:cNvPr>
@@ -4278,7 +4278,7 @@
           <p:cNvPr id="5" name="">
             <a:extLst xmlns:a="http://schemas.openxmlformats.org/drawingml/2006/main">
               <a:ext uri="{FF2B5EF4-FFF2-40B4-BE49-F238E27FC236}">
-                <a16:creationId xmlns:a16="http://schemas.microsoft.com/office/drawing/2014/main" id="{9252FE47-C144-4855-880B-A9704B7F5095}"/>
+                <a16:creationId xmlns:a16="http://schemas.microsoft.com/office/drawing/2014/main" id="{DC496161-D9DC-4581-9AEB-6A8B92CE672C}"/>
               </a:ext>
             </a:extLst>
           </p:cNvPr>
@@ -4461,7 +4461,7 @@
           <p:cNvPr id="6" name="">
             <a:extLst xmlns:a="http://schemas.openxmlformats.org/drawingml/2006/main">
               <a:ext uri="{FF2B5EF4-FFF2-40B4-BE49-F238E27FC236}">
-                <a16:creationId xmlns:a16="http://schemas.microsoft.com/office/drawing/2014/main" id="{8FBCF2DF-052C-4426-B68C-6BF6B95DC78D}"/>
+                <a16:creationId xmlns:a16="http://schemas.microsoft.com/office/drawing/2014/main" id="{7CD40E19-996D-4717-B239-B865AD68DDF9}"/>
               </a:ext>
             </a:extLst>
           </p:cNvPr>
@@ -4644,7 +4644,7 @@
           <p:cNvPr id="7" name="">
             <a:extLst xmlns:a="http://schemas.openxmlformats.org/drawingml/2006/main">
               <a:ext uri="{FF2B5EF4-FFF2-40B4-BE49-F238E27FC236}">
-                <a16:creationId xmlns:a16="http://schemas.microsoft.com/office/drawing/2014/main" id="{01AFACA6-9946-4242-BA9C-2D59EB8128DC}"/>
+                <a16:creationId xmlns:a16="http://schemas.microsoft.com/office/drawing/2014/main" id="{40301CDD-0341-4AA1-AD0E-56F8C9759952}"/>
               </a:ext>
             </a:extLst>
           </p:cNvPr>
@@ -4827,7 +4827,7 @@
           <p:cNvPr id="8" name="">
             <a:extLst xmlns:a="http://schemas.openxmlformats.org/drawingml/2006/main">
               <a:ext uri="{FF2B5EF4-FFF2-40B4-BE49-F238E27FC236}">
-                <a16:creationId xmlns:a16="http://schemas.microsoft.com/office/drawing/2014/main" id="{7F3E6DCB-1DC1-486C-A327-385648EF5725}"/>
+                <a16:creationId xmlns:a16="http://schemas.microsoft.com/office/drawing/2014/main" id="{93B36FEE-7268-4C67-8988-EA473C79FE91}"/>
               </a:ext>
             </a:extLst>
           </p:cNvPr>
@@ -5010,7 +5010,7 @@
           <p:cNvPr id="9" name="">
             <a:extLst xmlns:a="http://schemas.openxmlformats.org/drawingml/2006/main">
               <a:ext uri="{FF2B5EF4-FFF2-40B4-BE49-F238E27FC236}">
-                <a16:creationId xmlns:a16="http://schemas.microsoft.com/office/drawing/2014/main" id="{B424CBF3-D18F-40E6-A85C-AE06B88E4486}"/>
+                <a16:creationId xmlns:a16="http://schemas.microsoft.com/office/drawing/2014/main" id="{4BD7F4FA-CB31-4247-B236-350F482740D4}"/>
               </a:ext>
             </a:extLst>
           </p:cNvPr>
@@ -5193,7 +5193,7 @@
           <p:cNvPr id="15" name="">
             <a:extLst xmlns:a="http://schemas.openxmlformats.org/drawingml/2006/main">
               <a:ext uri="{FF2B5EF4-FFF2-40B4-BE49-F238E27FC236}">
-                <a16:creationId xmlns:a16="http://schemas.microsoft.com/office/drawing/2014/main" id="{123F5800-3BB0-42D4-8DA9-16786E59E424}"/>
+                <a16:creationId xmlns:a16="http://schemas.microsoft.com/office/drawing/2014/main" id="{885FAA90-B5A5-40CB-A59F-7ECF8C972430}"/>
               </a:ext>
             </a:extLst>
           </p:cNvPr>
@@ -5347,7 +5347,7 @@
     </p:spTree>
     <p:extLst>
       <p:ext uri="{BB962C8B-B14F-4D97-AF65-F5344CB8AC3E}">
-        <p14:creationId xmlns:p14="http://schemas.microsoft.com/office/powerpoint/2010/main" val="637863061"/>
+        <p14:creationId xmlns:p14="http://schemas.microsoft.com/office/powerpoint/2010/main" val="1746040678"/>
       </p:ext>
     </p:extLst>
   </p:cSld>

</xml_diff>

<commit_message>
Improve deck evidence explanations
</commit_message>
<xml_diff>
--- a/deliverables/CycleTwin_architecture.pptx
+++ b/deliverables/CycleTwin_architecture.pptx
@@ -2,13 +2,13 @@
 <file path=ppt/presentation.xml><?xml version="1.0" encoding="utf-8"?>
 <p:presentation xmlns:p="http://schemas.openxmlformats.org/presentationml/2006/main">
   <p:sldMasterIdLst>
-    <p:sldMasterId xmlns:r="http://schemas.openxmlformats.org/officeDocument/2006/relationships" id="2147483648" r:id="R4238572c23914cbd"/>
+    <p:sldMasterId xmlns:r="http://schemas.openxmlformats.org/officeDocument/2006/relationships" id="2147483648" r:id="Ra489ee49092f4b9b"/>
   </p:sldMasterIdLst>
   <p:notesMasterIdLst>
-    <p:notesMasterId xmlns:r="http://schemas.openxmlformats.org/officeDocument/2006/relationships" r:id="Rb8209ce889b448f7"/>
+    <p:notesMasterId xmlns:r="http://schemas.openxmlformats.org/officeDocument/2006/relationships" r:id="R436ec766098b4e0a"/>
   </p:notesMasterIdLst>
   <p:sldIdLst>
-    <p:sldId xmlns:r="http://schemas.openxmlformats.org/officeDocument/2006/relationships" id="256" r:id="R923f6e6baa5b44d5"/>
+    <p:sldId xmlns:r="http://schemas.openxmlformats.org/officeDocument/2006/relationships" id="256" r:id="Re49ad578d67e489b"/>
   </p:sldIdLst>
   <p:sldSz cx="12192000" cy="6858000"/>
   <p:notesSz cx="6858000" cy="9144000"/>
@@ -489,7 +489,7 @@
           <p:cNvPr id="3" name="Title">
             <a:extLst xmlns:a="http://schemas.openxmlformats.org/drawingml/2006/main">
               <a:ext uri="{FF2B5EF4-FFF2-40B4-BE49-F238E27FC236}">
-                <a16:creationId xmlns:a16="http://schemas.microsoft.com/office/drawing/2014/main" id="{0C58B712-8D68-43AD-B54A-EAE71CD59BD5}"/>
+                <a16:creationId xmlns:a16="http://schemas.microsoft.com/office/drawing/2014/main" id="{8DC20123-AAF2-4E9B-988E-556A4BDACDD8}"/>
               </a:ext>
             </a:extLst>
           </p:cNvPr>
@@ -718,7 +718,7 @@
           <p:cNvPr id="2" name="Subtitle">
             <a:extLst xmlns:a="http://schemas.openxmlformats.org/drawingml/2006/main">
               <a:ext uri="{FF2B5EF4-FFF2-40B4-BE49-F238E27FC236}">
-                <a16:creationId xmlns:a16="http://schemas.microsoft.com/office/drawing/2014/main" id="{44B8E436-16BD-4A85-91DA-269E1BC49F8E}"/>
+                <a16:creationId xmlns:a16="http://schemas.microsoft.com/office/drawing/2014/main" id="{0A89C23D-2B94-45F9-8C95-132DF45F2CC3}"/>
               </a:ext>
             </a:extLst>
           </p:cNvPr>
@@ -964,7 +964,7 @@
           <p:cNvPr id="2" name="Section title">
             <a:extLst xmlns:a="http://schemas.openxmlformats.org/drawingml/2006/main">
               <a:ext uri="{FF2B5EF4-FFF2-40B4-BE49-F238E27FC236}">
-                <a16:creationId xmlns:a16="http://schemas.microsoft.com/office/drawing/2014/main" id="{280D5A77-7377-4EB7-83D5-21DED51A5D36}"/>
+                <a16:creationId xmlns:a16="http://schemas.microsoft.com/office/drawing/2014/main" id="{FCF5FE39-92CC-4E22-BA65-C7C27AC55D87}"/>
               </a:ext>
             </a:extLst>
           </p:cNvPr>
@@ -1210,7 +1210,7 @@
           <p:cNvPr id="3" name="Title">
             <a:extLst xmlns:a="http://schemas.openxmlformats.org/drawingml/2006/main">
               <a:ext uri="{FF2B5EF4-FFF2-40B4-BE49-F238E27FC236}">
-                <a16:creationId xmlns:a16="http://schemas.microsoft.com/office/drawing/2014/main" id="{40486ED9-B89B-45B0-BBC4-6A79D973221A}"/>
+                <a16:creationId xmlns:a16="http://schemas.microsoft.com/office/drawing/2014/main" id="{C8D2BA07-BBEB-4376-8CB2-FAD9F23C36AB}"/>
               </a:ext>
             </a:extLst>
           </p:cNvPr>
@@ -1439,7 +1439,7 @@
           <p:cNvPr id="2" name="Body">
             <a:extLst xmlns:a="http://schemas.openxmlformats.org/drawingml/2006/main">
               <a:ext uri="{FF2B5EF4-FFF2-40B4-BE49-F238E27FC236}">
-                <a16:creationId xmlns:a16="http://schemas.microsoft.com/office/drawing/2014/main" id="{9B5ADB82-3840-441B-A082-1B65C8795813}"/>
+                <a16:creationId xmlns:a16="http://schemas.microsoft.com/office/drawing/2014/main" id="{49153648-BFD2-4981-BA78-BB989E5A607A}"/>
               </a:ext>
             </a:extLst>
           </p:cNvPr>
@@ -1685,7 +1685,7 @@
           <p:cNvPr id="4" name="Title">
             <a:extLst xmlns:a="http://schemas.openxmlformats.org/drawingml/2006/main">
               <a:ext uri="{FF2B5EF4-FFF2-40B4-BE49-F238E27FC236}">
-                <a16:creationId xmlns:a16="http://schemas.microsoft.com/office/drawing/2014/main" id="{2EA92A03-E38A-4E80-B06C-6D272DB13C44}"/>
+                <a16:creationId xmlns:a16="http://schemas.microsoft.com/office/drawing/2014/main" id="{AEDE0127-953B-42A3-8574-12CDF6E5424E}"/>
               </a:ext>
             </a:extLst>
           </p:cNvPr>
@@ -1914,7 +1914,7 @@
           <p:cNvPr id="2" name="Left column">
             <a:extLst xmlns:a="http://schemas.openxmlformats.org/drawingml/2006/main">
               <a:ext uri="{FF2B5EF4-FFF2-40B4-BE49-F238E27FC236}">
-                <a16:creationId xmlns:a16="http://schemas.microsoft.com/office/drawing/2014/main" id="{4F101EFA-08A0-4610-8273-DFF8E6233BE3}"/>
+                <a16:creationId xmlns:a16="http://schemas.microsoft.com/office/drawing/2014/main" id="{036D7A33-CBD0-40EA-AE63-F915C4541C52}"/>
               </a:ext>
             </a:extLst>
           </p:cNvPr>
@@ -2143,7 +2143,7 @@
           <p:cNvPr id="3" name="Right column">
             <a:extLst xmlns:a="http://schemas.openxmlformats.org/drawingml/2006/main">
               <a:ext uri="{FF2B5EF4-FFF2-40B4-BE49-F238E27FC236}">
-                <a16:creationId xmlns:a16="http://schemas.microsoft.com/office/drawing/2014/main" id="{55C3A721-BC9A-4FBC-98C5-BD798E5EE795}"/>
+                <a16:creationId xmlns:a16="http://schemas.microsoft.com/office/drawing/2014/main" id="{C3C0B585-25DE-4D4B-AFAF-0EC019EAD473}"/>
               </a:ext>
             </a:extLst>
           </p:cNvPr>
@@ -2389,7 +2389,7 @@
           <p:cNvPr id="3" name="Title">
             <a:extLst xmlns:a="http://schemas.openxmlformats.org/drawingml/2006/main">
               <a:ext uri="{FF2B5EF4-FFF2-40B4-BE49-F238E27FC236}">
-                <a16:creationId xmlns:a16="http://schemas.microsoft.com/office/drawing/2014/main" id="{909C67A2-AAEA-4579-B5F4-B805D994F271}"/>
+                <a16:creationId xmlns:a16="http://schemas.microsoft.com/office/drawing/2014/main" id="{12F606D9-07A8-411D-97CB-6AB0A69BE1B2}"/>
               </a:ext>
             </a:extLst>
           </p:cNvPr>
@@ -2618,7 +2618,7 @@
           <p:cNvPr id="2" name="Left column">
             <a:extLst xmlns:a="http://schemas.openxmlformats.org/drawingml/2006/main">
               <a:ext uri="{FF2B5EF4-FFF2-40B4-BE49-F238E27FC236}">
-                <a16:creationId xmlns:a16="http://schemas.microsoft.com/office/drawing/2014/main" id="{05071BEA-1AB4-4130-98D0-2C9A9F5552C7}"/>
+                <a16:creationId xmlns:a16="http://schemas.microsoft.com/office/drawing/2014/main" id="{CAE00E4A-34E9-4A03-903C-1CF733172773}"/>
               </a:ext>
             </a:extLst>
           </p:cNvPr>
@@ -2885,12 +2885,12 @@
   </p:cSld>
   <p:clrMap bg1="lt1" tx1="dk1" bg2="lt2" tx2="dk2" accent1="accent1" accent2="accent2" accent3="accent3" accent4="accent4" accent5="accent5" accent6="accent6" hlink="hlink" folHlink="folHlink"/>
   <p:sldLayoutIdLst>
-    <p:sldLayoutId xmlns:r="http://schemas.openxmlformats.org/officeDocument/2006/relationships" id="2147483649" r:id="R8f9a11f207c74e76"/>
-    <p:sldLayoutId xmlns:r="http://schemas.openxmlformats.org/officeDocument/2006/relationships" id="2147483650" r:id="R2e14467c341e4cd0"/>
-    <p:sldLayoutId xmlns:r="http://schemas.openxmlformats.org/officeDocument/2006/relationships" id="2147483651" r:id="R6f07ebe2c6b3424a"/>
-    <p:sldLayoutId xmlns:r="http://schemas.openxmlformats.org/officeDocument/2006/relationships" id="2147483652" r:id="Rff76b4b151e748bc"/>
-    <p:sldLayoutId xmlns:r="http://schemas.openxmlformats.org/officeDocument/2006/relationships" id="2147483653" r:id="R195e12b1b75841b9"/>
-    <p:sldLayoutId xmlns:r="http://schemas.openxmlformats.org/officeDocument/2006/relationships" id="2147483654" r:id="R66cc102819134bfa"/>
+    <p:sldLayoutId xmlns:r="http://schemas.openxmlformats.org/officeDocument/2006/relationships" id="2147483649" r:id="R642da518d7984d08"/>
+    <p:sldLayoutId xmlns:r="http://schemas.openxmlformats.org/officeDocument/2006/relationships" id="2147483650" r:id="Ra12b7de4f2474e80"/>
+    <p:sldLayoutId xmlns:r="http://schemas.openxmlformats.org/officeDocument/2006/relationships" id="2147483651" r:id="R1ac83b64f91c4dbc"/>
+    <p:sldLayoutId xmlns:r="http://schemas.openxmlformats.org/officeDocument/2006/relationships" id="2147483652" r:id="R82d034f59c614283"/>
+    <p:sldLayoutId xmlns:r="http://schemas.openxmlformats.org/officeDocument/2006/relationships" id="2147483653" r:id="Rd952947887e64b10"/>
+    <p:sldLayoutId xmlns:r="http://schemas.openxmlformats.org/officeDocument/2006/relationships" id="2147483654" r:id="R98cde746778a49bf"/>
   </p:sldLayoutIdLst>
   <p:txStyles>
     <p:titleStyle>
@@ -3438,10 +3438,10 @@
       </p:grpSpPr>
       <p:cxnSp>
         <p:nvCxnSpPr>
-          <p:cNvPr id="14" name="">
+          <p:cNvPr id="15" name="">
             <a:extLst xmlns:a="http://schemas.openxmlformats.org/drawingml/2006/main">
               <a:ext uri="{FF2B5EF4-FFF2-40B4-BE49-F238E27FC236}">
-                <a16:creationId xmlns:a16="http://schemas.microsoft.com/office/drawing/2014/main" id="{A9B9186F-1B64-4C8D-AC7B-1C6A22D24E5A}"/>
+                <a16:creationId xmlns:a16="http://schemas.microsoft.com/office/drawing/2014/main" id="{75277BA4-E33D-4483-9513-31E9DB58FC00}"/>
               </a:ext>
             </a:extLst>
           </p:cNvPr>
@@ -3453,8 +3453,39 @@
         </p:nvCxnSpPr>
         <p:spPr>
           <a:xfrm xmlns:a="http://schemas.openxmlformats.org/drawingml/2006/main" flipH="1">
-            <a:off x="7620000" y="5214938"/>
+            <a:off x="7620000" y="4953000"/>
             <a:ext cx="714375" cy="0"/>
+          </a:xfrm>
+          <a:prstGeom xmlns:a="http://schemas.openxmlformats.org/drawingml/2006/main" prst="straightConnector1">
+            <a:avLst/>
+          </a:prstGeom>
+          <a:ln xmlns:a="http://schemas.openxmlformats.org/drawingml/2006/main" w="19050">
+            <a:solidFill>
+              <a:srgbClr val="0E766E"/>
+            </a:solidFill>
+            <a:tailEnd type="arrow" w="med" len="med"/>
+          </a:ln>
+        </p:spPr>
+      </p:cxnSp>
+      <p:cxnSp>
+        <p:nvCxnSpPr>
+          <p:cNvPr id="14" name="">
+            <a:extLst xmlns:a="http://schemas.openxmlformats.org/drawingml/2006/main">
+              <a:ext uri="{FF2B5EF4-FFF2-40B4-BE49-F238E27FC236}">
+                <a16:creationId xmlns:a16="http://schemas.microsoft.com/office/drawing/2014/main" id="{9A8D643D-0555-43C0-81FF-3EBFBCBA5A12}"/>
+              </a:ext>
+            </a:extLst>
+          </p:cNvPr>
+          <p:cNvCxnSpPr>
+            <a:stCxn xmlns:a="http://schemas.openxmlformats.org/drawingml/2006/main" id="6" idx="2"/>
+            <a:endCxn xmlns:a="http://schemas.openxmlformats.org/drawingml/2006/main" id="7" idx="0"/>
+          </p:cNvCxnSpPr>
+          <p:nvPr/>
+        </p:nvCxnSpPr>
+        <p:spPr>
+          <a:xfrm xmlns:a="http://schemas.openxmlformats.org/drawingml/2006/main">
+            <a:off x="9906000" y="3857625"/>
+            <a:ext cx="0" cy="619125"/>
           </a:xfrm>
           <a:prstGeom xmlns:a="http://schemas.openxmlformats.org/drawingml/2006/main" prst="straightConnector1">
             <a:avLst/>
@@ -3472,20 +3503,20 @@
           <p:cNvPr id="13" name="">
             <a:extLst xmlns:a="http://schemas.openxmlformats.org/drawingml/2006/main">
               <a:ext uri="{FF2B5EF4-FFF2-40B4-BE49-F238E27FC236}">
-                <a16:creationId xmlns:a16="http://schemas.microsoft.com/office/drawing/2014/main" id="{0E320303-DEAB-4DD9-9C79-5D08F7B11695}"/>
+                <a16:creationId xmlns:a16="http://schemas.microsoft.com/office/drawing/2014/main" id="{DB021F6F-919D-4F48-82D3-14B7E0E84138}"/>
               </a:ext>
             </a:extLst>
           </p:cNvPr>
           <p:cNvCxnSpPr>
-            <a:stCxn xmlns:a="http://schemas.openxmlformats.org/drawingml/2006/main" id="6" idx="2"/>
-            <a:endCxn xmlns:a="http://schemas.openxmlformats.org/drawingml/2006/main" id="7" idx="0"/>
+            <a:stCxn xmlns:a="http://schemas.openxmlformats.org/drawingml/2006/main" id="5" idx="3"/>
+            <a:endCxn xmlns:a="http://schemas.openxmlformats.org/drawingml/2006/main" id="6" idx="1"/>
           </p:cNvCxnSpPr>
           <p:nvPr/>
         </p:nvCxnSpPr>
         <p:spPr>
           <a:xfrm xmlns:a="http://schemas.openxmlformats.org/drawingml/2006/main">
-            <a:off x="9906000" y="4000500"/>
-            <a:ext cx="0" cy="714375"/>
+            <a:off x="7620000" y="3286125"/>
+            <a:ext cx="714375" cy="0"/>
           </a:xfrm>
           <a:prstGeom xmlns:a="http://schemas.openxmlformats.org/drawingml/2006/main" prst="straightConnector1">
             <a:avLst/>
@@ -3503,38 +3534,7 @@
           <p:cNvPr id="12" name="">
             <a:extLst xmlns:a="http://schemas.openxmlformats.org/drawingml/2006/main">
               <a:ext uri="{FF2B5EF4-FFF2-40B4-BE49-F238E27FC236}">
-                <a16:creationId xmlns:a16="http://schemas.microsoft.com/office/drawing/2014/main" id="{FAB8437B-BF30-4623-BD6F-A48591C2DC34}"/>
-              </a:ext>
-            </a:extLst>
-          </p:cNvPr>
-          <p:cNvCxnSpPr>
-            <a:stCxn xmlns:a="http://schemas.openxmlformats.org/drawingml/2006/main" id="5" idx="3"/>
-            <a:endCxn xmlns:a="http://schemas.openxmlformats.org/drawingml/2006/main" id="6" idx="1"/>
-          </p:cNvCxnSpPr>
-          <p:nvPr/>
-        </p:nvCxnSpPr>
-        <p:spPr>
-          <a:xfrm xmlns:a="http://schemas.openxmlformats.org/drawingml/2006/main">
-            <a:off x="7620000" y="3429000"/>
-            <a:ext cx="714375" cy="0"/>
-          </a:xfrm>
-          <a:prstGeom xmlns:a="http://schemas.openxmlformats.org/drawingml/2006/main" prst="straightConnector1">
-            <a:avLst/>
-          </a:prstGeom>
-          <a:ln xmlns:a="http://schemas.openxmlformats.org/drawingml/2006/main" w="19050">
-            <a:solidFill>
-              <a:srgbClr val="0E766E"/>
-            </a:solidFill>
-            <a:tailEnd type="arrow" w="med" len="med"/>
-          </a:ln>
-        </p:spPr>
-      </p:cxnSp>
-      <p:cxnSp>
-        <p:nvCxnSpPr>
-          <p:cNvPr id="11" name="">
-            <a:extLst xmlns:a="http://schemas.openxmlformats.org/drawingml/2006/main">
-              <a:ext uri="{FF2B5EF4-FFF2-40B4-BE49-F238E27FC236}">
-                <a16:creationId xmlns:a16="http://schemas.microsoft.com/office/drawing/2014/main" id="{0996511D-F447-4235-9369-D8A276C4CC0F}"/>
+                <a16:creationId xmlns:a16="http://schemas.microsoft.com/office/drawing/2014/main" id="{84557CCA-84DA-421A-B8C7-E1B08628AE87}"/>
               </a:ext>
             </a:extLst>
           </p:cNvPr>
@@ -3546,8 +3546,8 @@
         </p:nvCxnSpPr>
         <p:spPr>
           <a:xfrm xmlns:a="http://schemas.openxmlformats.org/drawingml/2006/main" flipV="1">
-            <a:off x="3762375" y="3429000"/>
-            <a:ext cx="714375" cy="738188"/>
+            <a:off x="3762375" y="3286125"/>
+            <a:ext cx="714375" cy="690563"/>
           </a:xfrm>
           <a:prstGeom xmlns:a="http://schemas.openxmlformats.org/drawingml/2006/main" prst="bentConnector3">
             <a:avLst>
@@ -3564,10 +3564,10 @@
       </p:cxnSp>
       <p:cxnSp>
         <p:nvCxnSpPr>
-          <p:cNvPr id="10" name="">
+          <p:cNvPr id="11" name="">
             <a:extLst xmlns:a="http://schemas.openxmlformats.org/drawingml/2006/main">
               <a:ext uri="{FF2B5EF4-FFF2-40B4-BE49-F238E27FC236}">
-                <a16:creationId xmlns:a16="http://schemas.microsoft.com/office/drawing/2014/main" id="{9F7FCF44-44F6-4572-BFF4-41C67896690D}"/>
+                <a16:creationId xmlns:a16="http://schemas.microsoft.com/office/drawing/2014/main" id="{D6F60A7F-A683-4229-B381-E4D910E13CC1}"/>
               </a:ext>
             </a:extLst>
           </p:cNvPr>
@@ -3579,8 +3579,8 @@
         </p:nvCxnSpPr>
         <p:spPr>
           <a:xfrm xmlns:a="http://schemas.openxmlformats.org/drawingml/2006/main">
-            <a:off x="3762375" y="2738438"/>
-            <a:ext cx="714375" cy="690563"/>
+            <a:off x="3762375" y="2690813"/>
+            <a:ext cx="714375" cy="595313"/>
           </a:xfrm>
           <a:prstGeom xmlns:a="http://schemas.openxmlformats.org/drawingml/2006/main" prst="bentConnector3">
             <a:avLst>
@@ -3597,10 +3597,10 @@
       </p:cxnSp>
       <p:sp>
         <p:nvSpPr>
-          <p:cNvPr id="16" name="">
+          <p:cNvPr id="17" name="">
             <a:extLst xmlns:a="http://schemas.openxmlformats.org/drawingml/2006/main">
               <a:ext uri="{FF2B5EF4-FFF2-40B4-BE49-F238E27FC236}">
-                <a16:creationId xmlns:a16="http://schemas.microsoft.com/office/drawing/2014/main" id="{CBA6E173-15BD-4B87-9A32-090DCEA19890}"/>
+                <a16:creationId xmlns:a16="http://schemas.microsoft.com/office/drawing/2014/main" id="{4F2F30C5-D6CA-429D-807F-ADD04A660A52}"/>
               </a:ext>
             </a:extLst>
           </p:cNvPr>
@@ -3756,7 +3756,7 @@
           <p:cNvPr id="2" name="">
             <a:extLst xmlns:a="http://schemas.openxmlformats.org/drawingml/2006/main">
               <a:ext uri="{FF2B5EF4-FFF2-40B4-BE49-F238E27FC236}">
-                <a16:creationId xmlns:a16="http://schemas.microsoft.com/office/drawing/2014/main" id="{56A20044-508C-4B14-84A2-EDAA6647B325}"/>
+                <a16:creationId xmlns:a16="http://schemas.microsoft.com/office/drawing/2014/main" id="{2AAD155B-7516-4177-86C3-35FF5630A806}"/>
               </a:ext>
             </a:extLst>
           </p:cNvPr>
@@ -3912,7 +3912,7 @@
           <p:cNvPr id="3" name="">
             <a:extLst xmlns:a="http://schemas.openxmlformats.org/drawingml/2006/main">
               <a:ext uri="{FF2B5EF4-FFF2-40B4-BE49-F238E27FC236}">
-                <a16:creationId xmlns:a16="http://schemas.microsoft.com/office/drawing/2014/main" id="{B8F7CA2F-DACC-491A-ABC2-2686E834EF98}"/>
+                <a16:creationId xmlns:a16="http://schemas.microsoft.com/office/drawing/2014/main" id="{63280DF0-4046-484E-9E0B-E3FF9EE08DC3}"/>
               </a:ext>
             </a:extLst>
           </p:cNvPr>
@@ -3923,7 +3923,7 @@
         </p:nvSpPr>
         <p:spPr>
           <a:xfrm xmlns:a="http://schemas.openxmlformats.org/drawingml/2006/main">
-            <a:off x="619125" y="2238375"/>
+            <a:off x="619125" y="2190750"/>
             <a:ext cx="3143250" cy="1000125"/>
           </a:xfrm>
           <a:prstGeom xmlns:a="http://schemas.openxmlformats.org/drawingml/2006/main" prst="rect">
@@ -4095,7 +4095,7 @@
           <p:cNvPr id="4" name="">
             <a:extLst xmlns:a="http://schemas.openxmlformats.org/drawingml/2006/main">
               <a:ext uri="{FF2B5EF4-FFF2-40B4-BE49-F238E27FC236}">
-                <a16:creationId xmlns:a16="http://schemas.microsoft.com/office/drawing/2014/main" id="{18ABBD26-E4E7-4AF6-A393-5905DA542DF7}"/>
+                <a16:creationId xmlns:a16="http://schemas.microsoft.com/office/drawing/2014/main" id="{39CEFD96-1544-4503-9247-B71BBF2C2689}"/>
               </a:ext>
             </a:extLst>
           </p:cNvPr>
@@ -4106,7 +4106,7 @@
         </p:nvSpPr>
         <p:spPr>
           <a:xfrm xmlns:a="http://schemas.openxmlformats.org/drawingml/2006/main">
-            <a:off x="619125" y="3667125"/>
+            <a:off x="619125" y="3476625"/>
             <a:ext cx="3143250" cy="1000125"/>
           </a:xfrm>
           <a:prstGeom xmlns:a="http://schemas.openxmlformats.org/drawingml/2006/main" prst="rect">
@@ -4278,7 +4278,7 @@
           <p:cNvPr id="5" name="">
             <a:extLst xmlns:a="http://schemas.openxmlformats.org/drawingml/2006/main">
               <a:ext uri="{FF2B5EF4-FFF2-40B4-BE49-F238E27FC236}">
-                <a16:creationId xmlns:a16="http://schemas.microsoft.com/office/drawing/2014/main" id="{DC496161-D9DC-4581-9AEB-6A8B92CE672C}"/>
+                <a16:creationId xmlns:a16="http://schemas.microsoft.com/office/drawing/2014/main" id="{935F9E46-0EB2-4E59-9FEC-DA9A05502A8A}"/>
               </a:ext>
             </a:extLst>
           </p:cNvPr>
@@ -4289,7 +4289,7 @@
         </p:nvSpPr>
         <p:spPr>
           <a:xfrm xmlns:a="http://schemas.openxmlformats.org/drawingml/2006/main">
-            <a:off x="4476750" y="2857500"/>
+            <a:off x="4476750" y="2714625"/>
             <a:ext cx="3143250" cy="1143000"/>
           </a:xfrm>
           <a:prstGeom xmlns:a="http://schemas.openxmlformats.org/drawingml/2006/main" prst="rect">
@@ -4461,7 +4461,7 @@
           <p:cNvPr id="6" name="">
             <a:extLst xmlns:a="http://schemas.openxmlformats.org/drawingml/2006/main">
               <a:ext uri="{FF2B5EF4-FFF2-40B4-BE49-F238E27FC236}">
-                <a16:creationId xmlns:a16="http://schemas.microsoft.com/office/drawing/2014/main" id="{7CD40E19-996D-4717-B239-B865AD68DDF9}"/>
+                <a16:creationId xmlns:a16="http://schemas.microsoft.com/office/drawing/2014/main" id="{379915C9-BB0E-468C-8CBE-429BAF229FAB}"/>
               </a:ext>
             </a:extLst>
           </p:cNvPr>
@@ -4472,7 +4472,7 @@
         </p:nvSpPr>
         <p:spPr>
           <a:xfrm xmlns:a="http://schemas.openxmlformats.org/drawingml/2006/main">
-            <a:off x="8334375" y="2857500"/>
+            <a:off x="8334375" y="2714625"/>
             <a:ext cx="3143250" cy="1143000"/>
           </a:xfrm>
           <a:prstGeom xmlns:a="http://schemas.openxmlformats.org/drawingml/2006/main" prst="rect">
@@ -4644,7 +4644,7 @@
           <p:cNvPr id="7" name="">
             <a:extLst xmlns:a="http://schemas.openxmlformats.org/drawingml/2006/main">
               <a:ext uri="{FF2B5EF4-FFF2-40B4-BE49-F238E27FC236}">
-                <a16:creationId xmlns:a16="http://schemas.microsoft.com/office/drawing/2014/main" id="{40301CDD-0341-4AA1-AD0E-56F8C9759952}"/>
+                <a16:creationId xmlns:a16="http://schemas.microsoft.com/office/drawing/2014/main" id="{954CA461-619C-4C21-95B1-2E45BC4A3A1E}"/>
               </a:ext>
             </a:extLst>
           </p:cNvPr>
@@ -4655,8 +4655,8 @@
         </p:nvSpPr>
         <p:spPr>
           <a:xfrm xmlns:a="http://schemas.openxmlformats.org/drawingml/2006/main">
-            <a:off x="8334375" y="4714875"/>
-            <a:ext cx="3143250" cy="1000125"/>
+            <a:off x="8334375" y="4476750"/>
+            <a:ext cx="3143250" cy="952500"/>
           </a:xfrm>
           <a:prstGeom xmlns:a="http://schemas.openxmlformats.org/drawingml/2006/main" prst="rect">
             <a:avLst/>
@@ -4827,7 +4827,7 @@
           <p:cNvPr id="8" name="">
             <a:extLst xmlns:a="http://schemas.openxmlformats.org/drawingml/2006/main">
               <a:ext uri="{FF2B5EF4-FFF2-40B4-BE49-F238E27FC236}">
-                <a16:creationId xmlns:a16="http://schemas.microsoft.com/office/drawing/2014/main" id="{93B36FEE-7268-4C67-8988-EA473C79FE91}"/>
+                <a16:creationId xmlns:a16="http://schemas.microsoft.com/office/drawing/2014/main" id="{9BEA3652-E4F0-49D8-9DD8-F30415DF414D}"/>
               </a:ext>
             </a:extLst>
           </p:cNvPr>
@@ -4838,8 +4838,8 @@
         </p:nvSpPr>
         <p:spPr>
           <a:xfrm xmlns:a="http://schemas.openxmlformats.org/drawingml/2006/main">
-            <a:off x="4476750" y="4714875"/>
-            <a:ext cx="3143250" cy="1000125"/>
+            <a:off x="4476750" y="4476750"/>
+            <a:ext cx="3143250" cy="952500"/>
           </a:xfrm>
           <a:prstGeom xmlns:a="http://schemas.openxmlformats.org/drawingml/2006/main" prst="rect">
             <a:avLst/>
@@ -5010,7 +5010,7 @@
           <p:cNvPr id="9" name="">
             <a:extLst xmlns:a="http://schemas.openxmlformats.org/drawingml/2006/main">
               <a:ext uri="{FF2B5EF4-FFF2-40B4-BE49-F238E27FC236}">
-                <a16:creationId xmlns:a16="http://schemas.microsoft.com/office/drawing/2014/main" id="{4BD7F4FA-CB31-4247-B236-350F482740D4}"/>
+                <a16:creationId xmlns:a16="http://schemas.microsoft.com/office/drawing/2014/main" id="{1598BA16-E6AD-4327-8E02-A180B1CEB0A4}"/>
               </a:ext>
             </a:extLst>
           </p:cNvPr>
@@ -5021,8 +5021,8 @@
         </p:nvSpPr>
         <p:spPr>
           <a:xfrm xmlns:a="http://schemas.openxmlformats.org/drawingml/2006/main">
-            <a:off x="619125" y="5191125"/>
-            <a:ext cx="3143250" cy="762000"/>
+            <a:off x="619125" y="5095875"/>
+            <a:ext cx="3143250" cy="666750"/>
           </a:xfrm>
           <a:prstGeom xmlns:a="http://schemas.openxmlformats.org/drawingml/2006/main" prst="rect">
             <a:avLst/>
@@ -5040,7 +5040,7 @@
           <a:bodyPr xmlns:a="http://schemas.openxmlformats.org/drawingml/2006/main"/>
           <a:lstStyle xmlns:a="http://schemas.openxmlformats.org/drawingml/2006/main">
             <a:defPPr>
-              <a:defRPr sz="1650">
+              <a:defRPr sz="1350">
                 <a:solidFill>
                   <a:srgbClr val="17242B"/>
                 </a:solidFill>
@@ -5050,7 +5050,7 @@
               </a:defRPr>
             </a:defPPr>
             <a:lvl1pPr>
-              <a:defRPr sz="1650">
+              <a:defRPr sz="1350">
                 <a:solidFill>
                   <a:srgbClr val="17242B"/>
                 </a:solidFill>
@@ -5060,7 +5060,7 @@
               </a:defRPr>
             </a:lvl1pPr>
             <a:lvl2pPr>
-              <a:defRPr sz="1650">
+              <a:defRPr sz="1350">
                 <a:solidFill>
                   <a:srgbClr val="17242B"/>
                 </a:solidFill>
@@ -5070,7 +5070,7 @@
               </a:defRPr>
             </a:lvl2pPr>
             <a:lvl3pPr>
-              <a:defRPr sz="1650">
+              <a:defRPr sz="1350">
                 <a:solidFill>
                   <a:srgbClr val="17242B"/>
                 </a:solidFill>
@@ -5080,7 +5080,7 @@
               </a:defRPr>
             </a:lvl3pPr>
             <a:lvl4pPr>
-              <a:defRPr sz="1650">
+              <a:defRPr sz="1350">
                 <a:solidFill>
                   <a:srgbClr val="17242B"/>
                 </a:solidFill>
@@ -5090,7 +5090,7 @@
               </a:defRPr>
             </a:lvl4pPr>
             <a:lvl5pPr>
-              <a:defRPr sz="1650">
+              <a:defRPr sz="1350">
                 <a:solidFill>
                   <a:srgbClr val="17242B"/>
                 </a:solidFill>
@@ -5100,7 +5100,7 @@
               </a:defRPr>
             </a:lvl5pPr>
             <a:lvl6pPr>
-              <a:defRPr sz="1650">
+              <a:defRPr sz="1350">
                 <a:solidFill>
                   <a:srgbClr val="17242B"/>
                 </a:solidFill>
@@ -5110,7 +5110,7 @@
               </a:defRPr>
             </a:lvl6pPr>
             <a:lvl7pPr>
-              <a:defRPr sz="1650">
+              <a:defRPr sz="1350">
                 <a:solidFill>
                   <a:srgbClr val="17242B"/>
                 </a:solidFill>
@@ -5120,7 +5120,7 @@
               </a:defRPr>
             </a:lvl7pPr>
             <a:lvl8pPr>
-              <a:defRPr sz="1650">
+              <a:defRPr sz="1350">
                 <a:solidFill>
                   <a:srgbClr val="17242B"/>
                 </a:solidFill>
@@ -5130,7 +5130,7 @@
               </a:defRPr>
             </a:lvl8pPr>
             <a:lvl9pPr>
-              <a:defRPr sz="1650">
+              <a:defRPr sz="1350">
                 <a:solidFill>
                   <a:srgbClr val="17242B"/>
                 </a:solidFill>
@@ -5142,7 +5142,7 @@
           </a:lstStyle>
           <a:p xmlns:a="http://schemas.openxmlformats.org/drawingml/2006/main">
             <a:pPr>
-              <a:defRPr sz="1650">
+              <a:defRPr sz="1350">
                 <a:solidFill>
                   <a:srgbClr val="17242B"/>
                 </a:solidFill>
@@ -5152,7 +5152,7 @@
               </a:defRPr>
             </a:pPr>
             <a:r>
-              <a:rPr sz="1650">
+              <a:rPr sz="1350">
                 <a:solidFill>
                   <a:srgbClr val="17242B"/>
                 </a:solidFill>
@@ -5165,7 +5165,7 @@
           </a:p>
           <a:p xmlns:a="http://schemas.openxmlformats.org/drawingml/2006/main">
             <a:pPr>
-              <a:defRPr sz="1650">
+              <a:defRPr sz="1350">
                 <a:solidFill>
                   <a:srgbClr val="17242B"/>
                 </a:solidFill>
@@ -5175,7 +5175,7 @@
               </a:defRPr>
             </a:pPr>
             <a:r>
-              <a:rPr sz="1650">
+              <a:rPr sz="1350">
                 <a:solidFill>
                   <a:srgbClr val="17242B"/>
                 </a:solidFill>
@@ -5190,10 +5190,216 @@
       </p:sp>
       <p:sp>
         <p:nvSpPr>
-          <p:cNvPr id="15" name="">
+          <p:cNvPr id="10" name="">
             <a:extLst xmlns:a="http://schemas.openxmlformats.org/drawingml/2006/main">
               <a:ext uri="{FF2B5EF4-FFF2-40B4-BE49-F238E27FC236}">
-                <a16:creationId xmlns:a16="http://schemas.microsoft.com/office/drawing/2014/main" id="{885FAA90-B5A5-40CB-A59F-7ECF8C972430}"/>
+                <a16:creationId xmlns:a16="http://schemas.microsoft.com/office/drawing/2014/main" id="{3E677F2C-9509-4CC1-B5A5-960E523C388B}"/>
+              </a:ext>
+            </a:extLst>
+          </p:cNvPr>
+          <p:cNvSpPr>
+            <a:spLocks xmlns:a="http://schemas.openxmlformats.org/drawingml/2006/main" noGrp="1"/>
+          </p:cNvSpPr>
+          <p:nvPr/>
+        </p:nvSpPr>
+        <p:spPr>
+          <a:xfrm xmlns:a="http://schemas.openxmlformats.org/drawingml/2006/main">
+            <a:off x="4476750" y="5524500"/>
+            <a:ext cx="3143250" cy="714375"/>
+          </a:xfrm>
+          <a:prstGeom xmlns:a="http://schemas.openxmlformats.org/drawingml/2006/main" prst="rect">
+            <a:avLst/>
+          </a:prstGeom>
+          <a:solidFill xmlns:a="http://schemas.openxmlformats.org/drawingml/2006/main">
+            <a:srgbClr val="F1F2EF"/>
+          </a:solidFill>
+          <a:ln xmlns:a="http://schemas.openxmlformats.org/drawingml/2006/main" w="9525">
+            <a:solidFill>
+              <a:srgbClr val="C8DCD5"/>
+            </a:solidFill>
+          </a:ln>
+        </p:spPr>
+        <p:txBody>
+          <a:bodyPr xmlns:a="http://schemas.openxmlformats.org/drawingml/2006/main"/>
+          <a:lstStyle xmlns:a="http://schemas.openxmlformats.org/drawingml/2006/main">
+            <a:defPPr>
+              <a:defRPr sz="1050">
+                <a:solidFill>
+                  <a:srgbClr val="17242B"/>
+                </a:solidFill>
+                <a:latin typeface="Arial"/>
+                <a:ea typeface="Arial"/>
+                <a:cs typeface="Arial"/>
+              </a:defRPr>
+            </a:defPPr>
+            <a:lvl1pPr>
+              <a:defRPr sz="1050">
+                <a:solidFill>
+                  <a:srgbClr val="17242B"/>
+                </a:solidFill>
+                <a:latin typeface="Arial"/>
+                <a:ea typeface="Arial"/>
+                <a:cs typeface="Arial"/>
+              </a:defRPr>
+            </a:lvl1pPr>
+            <a:lvl2pPr>
+              <a:defRPr sz="1050">
+                <a:solidFill>
+                  <a:srgbClr val="17242B"/>
+                </a:solidFill>
+                <a:latin typeface="Arial"/>
+                <a:ea typeface="Arial"/>
+                <a:cs typeface="Arial"/>
+              </a:defRPr>
+            </a:lvl2pPr>
+            <a:lvl3pPr>
+              <a:defRPr sz="1050">
+                <a:solidFill>
+                  <a:srgbClr val="17242B"/>
+                </a:solidFill>
+                <a:latin typeface="Arial"/>
+                <a:ea typeface="Arial"/>
+                <a:cs typeface="Arial"/>
+              </a:defRPr>
+            </a:lvl3pPr>
+            <a:lvl4pPr>
+              <a:defRPr sz="1050">
+                <a:solidFill>
+                  <a:srgbClr val="17242B"/>
+                </a:solidFill>
+                <a:latin typeface="Arial"/>
+                <a:ea typeface="Arial"/>
+                <a:cs typeface="Arial"/>
+              </a:defRPr>
+            </a:lvl4pPr>
+            <a:lvl5pPr>
+              <a:defRPr sz="1050">
+                <a:solidFill>
+                  <a:srgbClr val="17242B"/>
+                </a:solidFill>
+                <a:latin typeface="Arial"/>
+                <a:ea typeface="Arial"/>
+                <a:cs typeface="Arial"/>
+              </a:defRPr>
+            </a:lvl5pPr>
+            <a:lvl6pPr>
+              <a:defRPr sz="1050">
+                <a:solidFill>
+                  <a:srgbClr val="17242B"/>
+                </a:solidFill>
+                <a:latin typeface="Arial"/>
+                <a:ea typeface="Arial"/>
+                <a:cs typeface="Arial"/>
+              </a:defRPr>
+            </a:lvl6pPr>
+            <a:lvl7pPr>
+              <a:defRPr sz="1050">
+                <a:solidFill>
+                  <a:srgbClr val="17242B"/>
+                </a:solidFill>
+                <a:latin typeface="Arial"/>
+                <a:ea typeface="Arial"/>
+                <a:cs typeface="Arial"/>
+              </a:defRPr>
+            </a:lvl7pPr>
+            <a:lvl8pPr>
+              <a:defRPr sz="1050">
+                <a:solidFill>
+                  <a:srgbClr val="17242B"/>
+                </a:solidFill>
+                <a:latin typeface="Arial"/>
+                <a:ea typeface="Arial"/>
+                <a:cs typeface="Arial"/>
+              </a:defRPr>
+            </a:lvl8pPr>
+            <a:lvl9pPr>
+              <a:defRPr sz="1050">
+                <a:solidFill>
+                  <a:srgbClr val="17242B"/>
+                </a:solidFill>
+                <a:latin typeface="Arial"/>
+                <a:ea typeface="Arial"/>
+                <a:cs typeface="Arial"/>
+              </a:defRPr>
+            </a:lvl9pPr>
+          </a:lstStyle>
+          <a:p xmlns:a="http://schemas.openxmlformats.org/drawingml/2006/main">
+            <a:pPr>
+              <a:defRPr sz="1050">
+                <a:solidFill>
+                  <a:srgbClr val="17242B"/>
+                </a:solidFill>
+                <a:latin typeface="Arial"/>
+                <a:ea typeface="Arial"/>
+                <a:cs typeface="Arial"/>
+              </a:defRPr>
+            </a:pPr>
+            <a:r>
+              <a:rPr sz="1050">
+                <a:solidFill>
+                  <a:srgbClr val="17242B"/>
+                </a:solidFill>
+                <a:latin typeface="Arial"/>
+                <a:ea typeface="Arial"/>
+                <a:cs typeface="Arial"/>
+              </a:rPr>
+              <a:t>Bayesian timing posterior</a:t>
+            </a:r>
+          </a:p>
+          <a:p xmlns:a="http://schemas.openxmlformats.org/drawingml/2006/main">
+            <a:pPr>
+              <a:defRPr sz="1050">
+                <a:solidFill>
+                  <a:srgbClr val="17242B"/>
+                </a:solidFill>
+                <a:latin typeface="Arial"/>
+                <a:ea typeface="Arial"/>
+                <a:cs typeface="Arial"/>
+              </a:defRPr>
+            </a:pPr>
+            <a:r>
+              <a:rPr sz="1050">
+                <a:solidFill>
+                  <a:srgbClr val="17242B"/>
+                </a:solidFill>
+                <a:latin typeface="Arial"/>
+                <a:ea typeface="Arial"/>
+                <a:cs typeface="Arial"/>
+              </a:rPr>
+              <a:t>Evaluated separately; not used in score or alerts</a:t>
+            </a:r>
+          </a:p>
+          <a:p xmlns:a="http://schemas.openxmlformats.org/drawingml/2006/main">
+            <a:pPr>
+              <a:defRPr sz="1050">
+                <a:solidFill>
+                  <a:srgbClr val="17242B"/>
+                </a:solidFill>
+                <a:latin typeface="Arial"/>
+                <a:ea typeface="Arial"/>
+                <a:cs typeface="Arial"/>
+              </a:defRPr>
+            </a:pPr>
+            <a:r>
+              <a:rPr sz="1050">
+                <a:solidFill>
+                  <a:srgbClr val="17242B"/>
+                </a:solidFill>
+                <a:latin typeface="Arial"/>
+                <a:ea typeface="Arial"/>
+                <a:cs typeface="Arial"/>
+              </a:rPr>
+              <a:t>Brier 0.098 vs logistic 0.117</a:t>
+            </a:r>
+          </a:p>
+        </p:txBody>
+      </p:sp>
+      <p:sp>
+        <p:nvSpPr>
+          <p:cNvPr id="16" name="">
+            <a:extLst xmlns:a="http://schemas.openxmlformats.org/drawingml/2006/main">
+              <a:ext uri="{FF2B5EF4-FFF2-40B4-BE49-F238E27FC236}">
+                <a16:creationId xmlns:a16="http://schemas.microsoft.com/office/drawing/2014/main" id="{7ABB8697-61CB-4CF9-9755-4DC2BF4BBCAB}"/>
               </a:ext>
             </a:extLst>
           </p:cNvPr>
@@ -5347,7 +5553,7 @@
     </p:spTree>
     <p:extLst>
       <p:ext uri="{BB962C8B-B14F-4D97-AF65-F5344CB8AC3E}">
-        <p14:creationId xmlns:p14="http://schemas.microsoft.com/office/powerpoint/2010/main" val="1746040678"/>
+        <p14:creationId xmlns:p14="http://schemas.microsoft.com/office/powerpoint/2010/main" val="1533838940"/>
       </p:ext>
     </p:extLst>
   </p:cSld>

</xml_diff>